<commit_message>
Corrige decoração do slide de encerramento da apresentação BESS
Reposiciona os retângulos decorativos do slide final para dentro dos
limites do slide — formas com coordenadas fora da área visível eram
deslocadas por alguns visualizadores (ex.: pré-visualização no celular),
gerando artefatos. Adiciona ícone central no mesmo estilo da capa.

Co-Authored-By: Claude Fable 5 <noreply@anthropic.com>
Claude-Session: https://claude.ai/code/session_0198SeXLUYPhAzabpjaRsyNb
</commit_message>
<xml_diff>
--- a/apresentacoes/BESS_Brasil_Lucas_Silva_Costa.pptx
+++ b/apresentacoes/BESS_Brasil_Lucas_Silva_Costa.pptx
@@ -5735,7 +5735,31 @@
         </p:nvSpPr>
         <p:spPr>
           <a:xfrm>
-            <a:off x="8229600" y="-1097280"/>
+            <a:off x="7772400" y="1051560"/>
+            <a:ext cx="3566160" cy="4023360"/>
+          </a:xfrm>
+          <a:prstGeom prst="roundRect">
+            <a:avLst>
+              <a:gd name="adj" fmla="val 3077"/>
+            </a:avLst>
+          </a:prstGeom>
+          <a:ln w="31750">
+            <a:solidFill>
+              <a:srgbClr val="F2B705"/>
+            </a:solidFill>
+            <a:prstDash val="solid"/>
+          </a:ln>
+        </p:spPr>
+      </p:sp>
+      <p:sp>
+        <p:nvSpPr>
+          <p:cNvPr id="3" name="Shape 1"/>
+          <p:cNvSpPr/>
+          <p:nvPr/>
+        </p:nvSpPr>
+        <p:spPr>
+          <a:xfrm>
+            <a:off x="8321040" y="1691640"/>
             <a:ext cx="3566160" cy="4023360"/>
           </a:xfrm>
           <a:prstGeom prst="roundRect">
@@ -5753,31 +5777,51 @@
       </p:sp>
       <p:sp>
         <p:nvSpPr>
-          <p:cNvPr id="3" name="Shape 1"/>
-          <p:cNvSpPr/>
-          <p:nvPr/>
-        </p:nvSpPr>
-        <p:spPr>
-          <a:xfrm>
-            <a:off x="9144000" y="4572000"/>
-            <a:ext cx="3566160" cy="4023360"/>
-          </a:xfrm>
-          <a:prstGeom prst="roundRect">
-            <a:avLst>
-              <a:gd name="adj" fmla="val 3077"/>
-            </a:avLst>
-          </a:prstGeom>
-          <a:ln w="31750">
-            <a:solidFill>
-              <a:srgbClr val="F2B705"/>
-            </a:solidFill>
-            <a:prstDash val="solid"/>
-          </a:ln>
-        </p:spPr>
-      </p:sp>
-      <p:sp>
-        <p:nvSpPr>
-          <p:cNvPr id="4" name="Text 2"/>
+          <p:cNvPr id="4" name="Shape 2"/>
+          <p:cNvSpPr/>
+          <p:nvPr/>
+        </p:nvSpPr>
+        <p:spPr>
+          <a:xfrm>
+            <a:off x="9098280" y="2788920"/>
+            <a:ext cx="1554480" cy="1554480"/>
+          </a:xfrm>
+          <a:prstGeom prst="ellipse">
+            <a:avLst/>
+          </a:prstGeom>
+          <a:solidFill>
+            <a:srgbClr val="F2B705"/>
+          </a:solidFill>
+          <a:ln/>
+        </p:spPr>
+      </p:sp>
+      <p:pic>
+        <p:nvPicPr>
+          <p:cNvPr id="5" name="Image 0" descr="preencoded.png">    </p:cNvPr>
+          <p:cNvPicPr>
+            <a:picLocks noChangeAspect="1"/>
+          </p:cNvPicPr>
+          <p:nvPr/>
+        </p:nvPicPr>
+        <p:blipFill>
+          <a:blip r:embed="rId1"/>
+          <a:stretch>
+            <a:fillRect/>
+          </a:stretch>
+        </p:blipFill>
+        <p:spPr>
+          <a:xfrm>
+            <a:off x="9436608" y="3127248"/>
+            <a:ext cx="877824" cy="877824"/>
+          </a:xfrm>
+          <a:prstGeom prst="rect">
+            <a:avLst/>
+          </a:prstGeom>
+        </p:spPr>
+      </p:pic>
+      <p:sp>
+        <p:nvSpPr>
+          <p:cNvPr id="6" name="Text 3"/>
           <p:cNvSpPr/>
           <p:nvPr/>
         </p:nvSpPr>
@@ -5816,7 +5860,7 @@
       </p:sp>
       <p:sp>
         <p:nvSpPr>
-          <p:cNvPr id="5" name="Text 3"/>
+          <p:cNvPr id="7" name="Text 4"/>
           <p:cNvSpPr/>
           <p:nvPr/>
         </p:nvSpPr>
@@ -5855,7 +5899,7 @@
       </p:sp>
       <p:sp>
         <p:nvSpPr>
-          <p:cNvPr id="6" name="Shape 4"/>
+          <p:cNvPr id="8" name="Shape 5"/>
           <p:cNvSpPr/>
           <p:nvPr/>
         </p:nvSpPr>
@@ -5878,7 +5922,7 @@
       </p:sp>
       <p:sp>
         <p:nvSpPr>
-          <p:cNvPr id="7" name="Text 5"/>
+          <p:cNvPr id="9" name="Text 6"/>
           <p:cNvSpPr/>
           <p:nvPr/>
         </p:nvSpPr>
@@ -5960,7 +6004,7 @@
       </p:sp>
       <p:sp>
         <p:nvSpPr>
-          <p:cNvPr id="9" name="Text 6"/>
+          <p:cNvPr id="11" name="Text 7"/>
           <p:cNvSpPr/>
           <p:nvPr/>
         </p:nvSpPr>
@@ -5999,7 +6043,7 @@
       </p:sp>
       <p:sp>
         <p:nvSpPr>
-          <p:cNvPr id="10" name="Text 7"/>
+          <p:cNvPr id="12" name="Text 8"/>
           <p:cNvSpPr/>
           <p:nvPr/>
         </p:nvSpPr>

</xml_diff>

<commit_message>
Substitui gráficos nativos por imagens na apresentação BESS
Visualizadores móveis (pré-visualização iOS) não renderizam gráficos
OOXML nativos, deixando os slides 3, 7, 8 e 10 vazios. Os quatro
gráficos foram re-renderizados como PNGs de alta resolução (170 DPI)
com o mesmo design e paleta, garantindo exibição em qualquer
visualizador.

Co-Authored-By: Claude Fable 5 <noreply@anthropic.com>
Claude-Session: https://claude.ai/code/session_0198SeXLUYPhAzabpjaRsyNb
</commit_message>
<xml_diff>
--- a/apresentacoes/BESS_Brasil_Lucas_Silva_Costa.pptx
+++ b/apresentacoes/BESS_Brasil_Lucas_Silva_Costa.pptx
@@ -117,1933 +117,6 @@
     </a:lvl9pPr>
   </p:defaultTextStyle>
 </p:presentation>
-</file>
-
-<file path=ppt/charts/chart1.xml><?xml version="1.0" encoding="utf-8"?>
-<c:chartSpace xmlns:c="http://schemas.openxmlformats.org/drawingml/2006/chart" xmlns:a="http://schemas.openxmlformats.org/drawingml/2006/main" xmlns:r="http://schemas.openxmlformats.org/officeDocument/2006/relationships">
-  <c:date1904 val="0"/>
-  <c:roundedCorners val="1"/>
-  <c:chart>
-    <c:title>
-      <c:tx>
-        <c:rich>
-          <a:bodyPr/>
-          <a:lstStyle/>
-          <a:p>
-            <a:pPr>
-              <a:defRPr sz="1250" b="1" i="0" u="none" strike="noStrike">
-                <a:solidFill>
-                  <a:srgbClr val="16303F"/>
-                </a:solidFill>
-                <a:latin typeface="Arial"/>
-              </a:defRPr>
-            </a:pPr>
-            <a:r>
-              <a:rPr sz="1250" b="1" i="0" u="none" strike="noStrike">
-                <a:solidFill>
-                  <a:srgbClr val="16303F"/>
-                </a:solidFill>
-                <a:latin typeface="Arial"/>
-              </a:rPr>
-              <a:t>Excedente solar do meio-dia  →  descarga estratégica na ponta</a:t>
-            </a:r>
-          </a:p>
-        </c:rich>
-      </c:tx>
-      <c:layout/>
-      <c:overlay val="0"/>
-    </c:title>
-    <c:autoTitleDeleted val="0"/>
-    <c:plotArea>
-      <c:layout/>
-      <c:lineChart>
-        <c:varyColors val="0"/>
-        <c:ser>
-          <c:idx val="0"/>
-          <c:order val="0"/>
-          <c:tx>
-            <c:strRef>
-              <c:f>Sheet1!$B$1</c:f>
-              <c:strCache>
-                <c:ptCount val="1"/>
-                <c:pt idx="0">
-                  <c:v>Geração fotovoltaica (MW)</c:v>
-                </c:pt>
-              </c:strCache>
-            </c:strRef>
-          </c:tx>
-          <c:spPr>
-            <a:solidFill>
-              <a:srgbClr val="F2B705"/>
-            </a:solidFill>
-            <a:ln w="38100" cap="flat">
-              <a:solidFill>
-                <a:srgbClr val="F2B705"/>
-              </a:solidFill>
-              <a:prstDash val="solid"/>
-              <a:round/>
-            </a:ln>
-            <a:effectLst/>
-          </c:spPr>
-          <c:invertIfNegative val="0"/>
-          <c:dLbls>
-            <c:numFmt formatCode="#,##0" sourceLinked="0"/>
-            <c:txPr>
-              <a:bodyPr/>
-              <a:lstStyle/>
-              <a:p>
-                <a:pPr>
-                  <a:defRPr b="0" i="0" strike="noStrike" sz="1200" u="none">
-                    <a:solidFill>
-                      <a:srgbClr val="000000"/>
-                    </a:solidFill>
-                    <a:latin typeface="Arial"/>
-                  </a:defRPr>
-                </a:pPr>
-              </a:p>
-            </c:txPr>
-            <c:showLegendKey val="0"/>
-            <c:showVal val="0"/>
-            <c:showCatName val="0"/>
-            <c:showSerName val="0"/>
-            <c:showPercent val="0"/>
-            <c:showBubbleSize val="0"/>
-            <c:showLeaderLines val="0"/>
-          </c:dLbls>
-          <c:marker>
-            <c:symbol val="none"/>
-            <c:size val="6"/>
-            <c:spPr>
-              <a:solidFill>
-                <a:srgbClr val="F2B705"/>
-              </a:solidFill>
-              <a:ln w="9525" cap="flat">
-                <a:solidFill>
-                  <a:srgbClr val="F2B705"/>
-                </a:solidFill>
-                <a:prstDash val="solid"/>
-                <a:round/>
-              </a:ln>
-              <a:effectLst/>
-            </c:spPr>
-          </c:marker>
-          <c:cat>
-            <c:multiLvlStrRef>
-              <c:f>Sheet1!$A$2:$A$25</c:f>
-              <c:multiLvlStrCache>
-                <c:ptCount val="24"/>
-                <c:lvl>
-                  <c:pt idx="0">
-                    <c:v>0</c:v>
-                  </c:pt>
-                  <c:pt idx="1">
-                    <c:v>1</c:v>
-                  </c:pt>
-                  <c:pt idx="2">
-                    <c:v>2</c:v>
-                  </c:pt>
-                  <c:pt idx="3">
-                    <c:v>3</c:v>
-                  </c:pt>
-                  <c:pt idx="4">
-                    <c:v>4</c:v>
-                  </c:pt>
-                  <c:pt idx="5">
-                    <c:v>5</c:v>
-                  </c:pt>
-                  <c:pt idx="6">
-                    <c:v>6</c:v>
-                  </c:pt>
-                  <c:pt idx="7">
-                    <c:v>7</c:v>
-                  </c:pt>
-                  <c:pt idx="8">
-                    <c:v>8</c:v>
-                  </c:pt>
-                  <c:pt idx="9">
-                    <c:v>9</c:v>
-                  </c:pt>
-                  <c:pt idx="10">
-                    <c:v>10</c:v>
-                  </c:pt>
-                  <c:pt idx="11">
-                    <c:v>11</c:v>
-                  </c:pt>
-                  <c:pt idx="12">
-                    <c:v>12</c:v>
-                  </c:pt>
-                  <c:pt idx="13">
-                    <c:v>13</c:v>
-                  </c:pt>
-                  <c:pt idx="14">
-                    <c:v>14</c:v>
-                  </c:pt>
-                  <c:pt idx="15">
-                    <c:v>15</c:v>
-                  </c:pt>
-                  <c:pt idx="16">
-                    <c:v>16</c:v>
-                  </c:pt>
-                  <c:pt idx="17">
-                    <c:v>17</c:v>
-                  </c:pt>
-                  <c:pt idx="18">
-                    <c:v>18</c:v>
-                  </c:pt>
-                  <c:pt idx="19">
-                    <c:v>19</c:v>
-                  </c:pt>
-                  <c:pt idx="20">
-                    <c:v>20</c:v>
-                  </c:pt>
-                  <c:pt idx="21">
-                    <c:v>21</c:v>
-                  </c:pt>
-                  <c:pt idx="22">
-                    <c:v>22</c:v>
-                  </c:pt>
-                  <c:pt idx="23">
-                    <c:v>23</c:v>
-                  </c:pt>
-                </c:lvl>
-              </c:multiLvlStrCache>
-            </c:multiLvlStrRef>
-          </c:cat>
-          <c:val>
-            <c:numRef>
-              <c:f>Sheet1!$B$2:$B$25</c:f>
-              <c:numCache>
-                <c:formatCode>General</c:formatCode>
-                <c:ptCount val="24"/>
-                <c:pt idx="0">
-                  <c:v>0</c:v>
-                </c:pt>
-                <c:pt idx="1">
-                  <c:v>0</c:v>
-                </c:pt>
-                <c:pt idx="2">
-                  <c:v>0</c:v>
-                </c:pt>
-                <c:pt idx="3">
-                  <c:v>0</c:v>
-                </c:pt>
-                <c:pt idx="4">
-                  <c:v>0</c:v>
-                </c:pt>
-                <c:pt idx="5">
-                  <c:v>0.1</c:v>
-                </c:pt>
-                <c:pt idx="6">
-                  <c:v>0.6</c:v>
-                </c:pt>
-                <c:pt idx="7">
-                  <c:v>1.6</c:v>
-                </c:pt>
-                <c:pt idx="8">
-                  <c:v>2.9</c:v>
-                </c:pt>
-                <c:pt idx="9">
-                  <c:v>4.1</c:v>
-                </c:pt>
-                <c:pt idx="10">
-                  <c:v>5</c:v>
-                </c:pt>
-                <c:pt idx="11">
-                  <c:v>5.5</c:v>
-                </c:pt>
-                <c:pt idx="12">
-                  <c:v>5.6</c:v>
-                </c:pt>
-                <c:pt idx="13">
-                  <c:v>5.3</c:v>
-                </c:pt>
-                <c:pt idx="14">
-                  <c:v>4.6</c:v>
-                </c:pt>
-                <c:pt idx="15">
-                  <c:v>3.5</c:v>
-                </c:pt>
-                <c:pt idx="16">
-                  <c:v>2.2</c:v>
-                </c:pt>
-                <c:pt idx="17">
-                  <c:v>1</c:v>
-                </c:pt>
-                <c:pt idx="18">
-                  <c:v>0.3</c:v>
-                </c:pt>
-                <c:pt idx="19">
-                  <c:v>0</c:v>
-                </c:pt>
-                <c:pt idx="20">
-                  <c:v>0</c:v>
-                </c:pt>
-                <c:pt idx="21">
-                  <c:v>0</c:v>
-                </c:pt>
-                <c:pt idx="22">
-                  <c:v>0</c:v>
-                </c:pt>
-                <c:pt idx="23">
-                  <c:v>0</c:v>
-                </c:pt>
-              </c:numCache>
-            </c:numRef>
-          </c:val>
-          <c:smooth val="1"/>
-        </c:ser>
-        <c:ser>
-          <c:idx val="1"/>
-          <c:order val="1"/>
-          <c:tx>
-            <c:strRef>
-              <c:f>Sheet1!$C$1</c:f>
-              <c:strCache>
-                <c:ptCount val="1"/>
-                <c:pt idx="0">
-                  <c:v>Curva de carga (MW)</c:v>
-                </c:pt>
-              </c:strCache>
-            </c:strRef>
-          </c:tx>
-          <c:spPr>
-            <a:solidFill>
-              <a:srgbClr val="31485A"/>
-            </a:solidFill>
-            <a:ln w="38100" cap="flat">
-              <a:solidFill>
-                <a:srgbClr val="31485A"/>
-              </a:solidFill>
-              <a:prstDash val="solid"/>
-              <a:round/>
-            </a:ln>
-            <a:effectLst/>
-          </c:spPr>
-          <c:invertIfNegative val="0"/>
-          <c:dLbls>
-            <c:numFmt formatCode="#,##0" sourceLinked="0"/>
-            <c:txPr>
-              <a:bodyPr/>
-              <a:lstStyle/>
-              <a:p>
-                <a:pPr>
-                  <a:defRPr b="0" i="0" strike="noStrike" sz="1200" u="none">
-                    <a:solidFill>
-                      <a:srgbClr val="000000"/>
-                    </a:solidFill>
-                    <a:latin typeface="Arial"/>
-                  </a:defRPr>
-                </a:pPr>
-              </a:p>
-            </c:txPr>
-            <c:showLegendKey val="0"/>
-            <c:showVal val="0"/>
-            <c:showCatName val="0"/>
-            <c:showSerName val="0"/>
-            <c:showPercent val="0"/>
-            <c:showBubbleSize val="0"/>
-            <c:showLeaderLines val="0"/>
-          </c:dLbls>
-          <c:marker>
-            <c:symbol val="none"/>
-            <c:size val="6"/>
-            <c:spPr>
-              <a:solidFill>
-                <a:srgbClr val="31485A"/>
-              </a:solidFill>
-              <a:ln w="9525" cap="flat">
-                <a:solidFill>
-                  <a:srgbClr val="31485A"/>
-                </a:solidFill>
-                <a:prstDash val="solid"/>
-                <a:round/>
-              </a:ln>
-              <a:effectLst/>
-            </c:spPr>
-          </c:marker>
-          <c:cat>
-            <c:multiLvlStrRef>
-              <c:f>Sheet1!$A$2:$A$25</c:f>
-              <c:multiLvlStrCache>
-                <c:ptCount val="24"/>
-                <c:lvl>
-                  <c:pt idx="0">
-                    <c:v>0</c:v>
-                  </c:pt>
-                  <c:pt idx="1">
-                    <c:v>1</c:v>
-                  </c:pt>
-                  <c:pt idx="2">
-                    <c:v>2</c:v>
-                  </c:pt>
-                  <c:pt idx="3">
-                    <c:v>3</c:v>
-                  </c:pt>
-                  <c:pt idx="4">
-                    <c:v>4</c:v>
-                  </c:pt>
-                  <c:pt idx="5">
-                    <c:v>5</c:v>
-                  </c:pt>
-                  <c:pt idx="6">
-                    <c:v>6</c:v>
-                  </c:pt>
-                  <c:pt idx="7">
-                    <c:v>7</c:v>
-                  </c:pt>
-                  <c:pt idx="8">
-                    <c:v>8</c:v>
-                  </c:pt>
-                  <c:pt idx="9">
-                    <c:v>9</c:v>
-                  </c:pt>
-                  <c:pt idx="10">
-                    <c:v>10</c:v>
-                  </c:pt>
-                  <c:pt idx="11">
-                    <c:v>11</c:v>
-                  </c:pt>
-                  <c:pt idx="12">
-                    <c:v>12</c:v>
-                  </c:pt>
-                  <c:pt idx="13">
-                    <c:v>13</c:v>
-                  </c:pt>
-                  <c:pt idx="14">
-                    <c:v>14</c:v>
-                  </c:pt>
-                  <c:pt idx="15">
-                    <c:v>15</c:v>
-                  </c:pt>
-                  <c:pt idx="16">
-                    <c:v>16</c:v>
-                  </c:pt>
-                  <c:pt idx="17">
-                    <c:v>17</c:v>
-                  </c:pt>
-                  <c:pt idx="18">
-                    <c:v>18</c:v>
-                  </c:pt>
-                  <c:pt idx="19">
-                    <c:v>19</c:v>
-                  </c:pt>
-                  <c:pt idx="20">
-                    <c:v>20</c:v>
-                  </c:pt>
-                  <c:pt idx="21">
-                    <c:v>21</c:v>
-                  </c:pt>
-                  <c:pt idx="22">
-                    <c:v>22</c:v>
-                  </c:pt>
-                  <c:pt idx="23">
-                    <c:v>23</c:v>
-                  </c:pt>
-                </c:lvl>
-              </c:multiLvlStrCache>
-            </c:multiLvlStrRef>
-          </c:cat>
-          <c:val>
-            <c:numRef>
-              <c:f>Sheet1!$C$2:$C$25</c:f>
-              <c:numCache>
-                <c:formatCode>General</c:formatCode>
-                <c:ptCount val="24"/>
-                <c:pt idx="0">
-                  <c:v>2.8</c:v>
-                </c:pt>
-                <c:pt idx="1">
-                  <c:v>2.6</c:v>
-                </c:pt>
-                <c:pt idx="2">
-                  <c:v>2.5</c:v>
-                </c:pt>
-                <c:pt idx="3">
-                  <c:v>2.4</c:v>
-                </c:pt>
-                <c:pt idx="4">
-                  <c:v>2.4</c:v>
-                </c:pt>
-                <c:pt idx="5">
-                  <c:v>2.5</c:v>
-                </c:pt>
-                <c:pt idx="6">
-                  <c:v>2.8</c:v>
-                </c:pt>
-                <c:pt idx="7">
-                  <c:v>3.2</c:v>
-                </c:pt>
-                <c:pt idx="8">
-                  <c:v>3.4</c:v>
-                </c:pt>
-                <c:pt idx="9">
-                  <c:v>3.3</c:v>
-                </c:pt>
-                <c:pt idx="10">
-                  <c:v>3.2</c:v>
-                </c:pt>
-                <c:pt idx="11">
-                  <c:v>3.1</c:v>
-                </c:pt>
-                <c:pt idx="12">
-                  <c:v>3</c:v>
-                </c:pt>
-                <c:pt idx="13">
-                  <c:v>3.1</c:v>
-                </c:pt>
-                <c:pt idx="14">
-                  <c:v>3.2</c:v>
-                </c:pt>
-                <c:pt idx="15">
-                  <c:v>3.4</c:v>
-                </c:pt>
-                <c:pt idx="16">
-                  <c:v>3.8</c:v>
-                </c:pt>
-                <c:pt idx="17">
-                  <c:v>4.4</c:v>
-                </c:pt>
-                <c:pt idx="18">
-                  <c:v>5</c:v>
-                </c:pt>
-                <c:pt idx="19">
-                  <c:v>5.4</c:v>
-                </c:pt>
-                <c:pt idx="20">
-                  <c:v>5.2</c:v>
-                </c:pt>
-                <c:pt idx="21">
-                  <c:v>4.6</c:v>
-                </c:pt>
-                <c:pt idx="22">
-                  <c:v>3.8</c:v>
-                </c:pt>
-                <c:pt idx="23">
-                  <c:v>3.2</c:v>
-                </c:pt>
-              </c:numCache>
-            </c:numRef>
-          </c:val>
-          <c:smooth val="1"/>
-        </c:ser>
-        <c:dLbls>
-          <c:numFmt formatCode="#,##0" sourceLinked="0"/>
-          <c:txPr>
-            <a:bodyPr/>
-            <a:lstStyle/>
-            <a:p>
-              <a:pPr>
-                <a:defRPr b="0" i="0" strike="noStrike" sz="1200" u="none">
-                  <a:solidFill>
-                    <a:srgbClr val="000000"/>
-                  </a:solidFill>
-                  <a:latin typeface="Arial"/>
-                </a:defRPr>
-              </a:pPr>
-            </a:p>
-          </c:txPr>
-          <c:showLegendKey val="0"/>
-          <c:showVal val="0"/>
-          <c:showCatName val="0"/>
-          <c:showSerName val="0"/>
-          <c:showPercent val="0"/>
-          <c:showBubbleSize val="0"/>
-          <c:showLeaderLines val="0"/>
-        </c:dLbls>
-        <c:marker val="1"/>
-        <c:axId val="2094734554"/>
-        <c:axId val="2094734552"/>
-        <c:axId val="2094734556"/>
-      </c:lineChart>
-      <c:catAx>
-        <c:axId val="2094734554"/>
-        <c:scaling>
-          <c:orientation val="minMax"/>
-        </c:scaling>
-        <c:delete val="0"/>
-        <c:axPos val="b"/>
-        <c:numFmt formatCode="General" sourceLinked="1"/>
-        <c:majorTickMark val="out"/>
-        <c:minorTickMark val="none"/>
-        <c:tickLblPos val="low"/>
-        <c:spPr>
-          <a:ln w="12700" cap="flat">
-            <a:solidFill>
-              <a:srgbClr val="888888"/>
-            </a:solidFill>
-            <a:prstDash val="solid"/>
-            <a:round/>
-          </a:ln>
-        </c:spPr>
-        <c:txPr>
-          <a:bodyPr/>
-          <a:lstStyle/>
-          <a:p>
-            <a:pPr>
-              <a:defRPr sz="900" b="0" i="0" u="none" strike="noStrike">
-                <a:solidFill>
-                  <a:srgbClr val="7A8A94"/>
-                </a:solidFill>
-                <a:latin typeface="Arial"/>
-              </a:defRPr>
-            </a:pPr>
-            <a:endParaRPr lang="en-US"/>
-          </a:p>
-        </c:txPr>
-        <c:crossAx val="2094734552"/>
-        <c:crosses val="autoZero"/>
-        <c:auto val="1"/>
-        <c:lblAlgn val="ctr"/>
-        <c:noMultiLvlLbl val="1"/>
-      </c:catAx>
-      <c:valAx>
-        <c:axId val="2094734552"/>
-        <c:scaling>
-          <c:orientation val="minMax"/>
-          <c:max val="6"/>
-          <c:min val="0"/>
-        </c:scaling>
-        <c:delete val="0"/>
-        <c:axPos val="l"/>
-        <c:majorGridlines>
-          <c:spPr>
-            <a:ln w="9525" cap="flat">
-              <a:solidFill>
-                <a:srgbClr val="E8EEF2"/>
-              </a:solidFill>
-              <a:prstDash val="solid"/>
-              <a:round/>
-            </a:ln>
-          </c:spPr>
-        </c:majorGridlines>
-        <c:numFmt formatCode="General" sourceLinked="0"/>
-        <c:majorTickMark val="out"/>
-        <c:minorTickMark val="none"/>
-        <c:tickLblPos val="nextTo"/>
-        <c:spPr>
-          <a:ln w="12700" cap="flat">
-            <a:solidFill>
-              <a:srgbClr val="888888"/>
-            </a:solidFill>
-            <a:prstDash val="solid"/>
-            <a:round/>
-          </a:ln>
-        </c:spPr>
-        <c:txPr>
-          <a:bodyPr/>
-          <a:lstStyle/>
-          <a:p>
-            <a:pPr>
-              <a:defRPr sz="1000" b="0" i="0" u="none" strike="noStrike">
-                <a:solidFill>
-                  <a:srgbClr val="7A8A94"/>
-                </a:solidFill>
-                <a:latin typeface="Arial"/>
-              </a:defRPr>
-            </a:pPr>
-            <a:endParaRPr lang="en-US"/>
-          </a:p>
-        </c:txPr>
-        <c:crossAx val="2094734554"/>
-        <c:crosses val="autoZero"/>
-        <c:crossBetween val="between"/>
-      </c:valAx>
-      <c:spPr>
-        <a:noFill/>
-        <a:ln>
-          <a:noFill/>
-        </a:ln>
-        <a:effectLst/>
-      </c:spPr>
-    </c:plotArea>
-    <c:legend>
-      <c:legendPos val="b"/>
-      <c:overlay val="0"/>
-      <c:txPr>
-        <a:bodyPr/>
-        <a:lstStyle/>
-        <a:p>
-          <a:pPr>
-            <a:defRPr sz="1100">
-              <a:solidFill>
-                <a:srgbClr val="3E4E59"/>
-              </a:solidFill>
-              <a:latin typeface="Arial"/>
-              <a:cs typeface="Arial"/>
-            </a:defRPr>
-          </a:pPr>
-          <a:endParaRPr lang="en-US"/>
-        </a:p>
-      </c:txPr>
-    </c:legend>
-    <c:plotVisOnly val="1"/>
-    <c:dispBlanksAs val="span"/>
-  </c:chart>
-  <c:spPr>
-    <a:noFill/>
-    <a:ln>
-      <a:noFill/>
-    </a:ln>
-    <a:effectLst/>
-  </c:spPr>
-  <c:externalData r:id="rId1">
-    <c:autoUpdate val="0"/>
-  </c:externalData>
-</c:chartSpace>
-</file>
-
-<file path=ppt/charts/chart2.xml><?xml version="1.0" encoding="utf-8"?>
-<c:chartSpace xmlns:c="http://schemas.openxmlformats.org/drawingml/2006/chart" xmlns:a="http://schemas.openxmlformats.org/drawingml/2006/main" xmlns:r="http://schemas.openxmlformats.org/officeDocument/2006/relationships">
-  <c:date1904 val="0"/>
-  <c:roundedCorners val="1"/>
-  <c:chart>
-    <c:autoTitleDeleted val="1"/>
-    <c:plotArea>
-      <c:layout/>
-      <c:barChart>
-        <c:barDir val="bar"/>
-        <c:grouping val="clustered"/>
-        <c:varyColors val="0"/>
-        <c:ser>
-          <c:idx val="0"/>
-          <c:order val="0"/>
-          <c:tx>
-            <c:strRef>
-              <c:f>Sheet1!$B$1</c:f>
-              <c:strCache>
-                <c:ptCount val="1"/>
-                <c:pt idx="0">
-                  <c:v>Participação no CAPEX</c:v>
-                </c:pt>
-              </c:strCache>
-            </c:strRef>
-          </c:tx>
-          <c:spPr>
-            <a:solidFill>
-              <a:srgbClr val="31485A"/>
-            </a:solidFill>
-            <a:effectLst/>
-          </c:spPr>
-          <c:invertIfNegative val="0"/>
-          <c:dLbls>
-            <c:numFmt formatCode="#,##0" sourceLinked="0"/>
-            <c:txPr>
-              <a:bodyPr/>
-              <a:lstStyle/>
-              <a:p>
-                <a:pPr>
-                  <a:defRPr b="0" i="0" strike="noStrike" sz="1200" u="none">
-                    <a:solidFill>
-                      <a:srgbClr val="000000"/>
-                    </a:solidFill>
-                    <a:latin typeface="Arial"/>
-                  </a:defRPr>
-                </a:pPr>
-              </a:p>
-            </c:txPr>
-            <c:showLegendKey val="0"/>
-            <c:showVal val="0"/>
-            <c:showCatName val="0"/>
-            <c:showSerName val="0"/>
-            <c:showPercent val="0"/>
-            <c:showBubbleSize val="0"/>
-            <c:showLeaderLines val="0"/>
-          </c:dLbls>
-          <c:dPt>
-            <c:idx val="0"/>
-            <c:invertIfNegative val="0"/>
-            <c:bubble3D val="0"/>
-            <c:spPr>
-              <a:solidFill>
-                <a:srgbClr val="31485A"/>
-              </a:solidFill>
-              <a:effectLst/>
-            </c:spPr>
-          </c:dPt>
-          <c:dPt>
-            <c:idx val="1"/>
-            <c:invertIfNegative val="0"/>
-            <c:bubble3D val="0"/>
-            <c:spPr>
-              <a:solidFill>
-                <a:srgbClr val="31485A"/>
-              </a:solidFill>
-              <a:effectLst/>
-            </c:spPr>
-          </c:dPt>
-          <c:dPt>
-            <c:idx val="2"/>
-            <c:invertIfNegative val="0"/>
-            <c:bubble3D val="0"/>
-            <c:spPr>
-              <a:solidFill>
-                <a:srgbClr val="31485A"/>
-              </a:solidFill>
-              <a:effectLst/>
-            </c:spPr>
-          </c:dPt>
-          <c:dPt>
-            <c:idx val="3"/>
-            <c:invertIfNegative val="0"/>
-            <c:bubble3D val="0"/>
-            <c:spPr>
-              <a:solidFill>
-                <a:srgbClr val="31485A"/>
-              </a:solidFill>
-              <a:effectLst/>
-            </c:spPr>
-          </c:dPt>
-          <c:dPt>
-            <c:idx val="4"/>
-            <c:invertIfNegative val="0"/>
-            <c:bubble3D val="0"/>
-            <c:spPr>
-              <a:solidFill>
-                <a:srgbClr val="2E7DAF"/>
-              </a:solidFill>
-              <a:effectLst/>
-            </c:spPr>
-          </c:dPt>
-          <c:dPt>
-            <c:idx val="5"/>
-            <c:invertIfNegative val="0"/>
-            <c:bubble3D val="0"/>
-            <c:spPr>
-              <a:solidFill>
-                <a:srgbClr val="31485A"/>
-              </a:solidFill>
-              <a:effectLst/>
-            </c:spPr>
-          </c:dPt>
-          <c:dPt>
-            <c:idx val="6"/>
-            <c:invertIfNegative val="0"/>
-            <c:bubble3D val="0"/>
-            <c:spPr>
-              <a:solidFill>
-                <a:srgbClr val="31485A"/>
-              </a:solidFill>
-              <a:effectLst/>
-            </c:spPr>
-          </c:dPt>
-          <c:dPt>
-            <c:idx val="7"/>
-            <c:invertIfNegative val="0"/>
-            <c:bubble3D val="0"/>
-            <c:spPr>
-              <a:solidFill>
-                <a:srgbClr val="31485A"/>
-              </a:solidFill>
-              <a:effectLst/>
-            </c:spPr>
-          </c:dPt>
-          <c:dPt>
-            <c:idx val="8"/>
-            <c:invertIfNegative val="0"/>
-            <c:bubble3D val="0"/>
-            <c:spPr>
-              <a:solidFill>
-                <a:srgbClr val="F2B705"/>
-              </a:solidFill>
-              <a:effectLst/>
-            </c:spPr>
-          </c:dPt>
-          <c:cat>
-            <c:multiLvlStrRef>
-              <c:f>Sheet1!$A$2:$A$10</c:f>
-              <c:multiLvlStrCache>
-                <c:ptCount val="9"/>
-                <c:lvl>
-                  <c:pt idx="0">
-                    <c:v>Custos de obra e engenharia — 2,92%</c:v>
-                  </c:pt>
-                  <c:pt idx="1">
-                    <c:v>Inversores — 3,46%</c:v>
-                  </c:pt>
-                  <c:pt idx="2">
-                    <c:v>Serviços administrativos — 3,97%</c:v>
-                  </c:pt>
-                  <c:pt idx="3">
-                    <c:v>Obras civis — 7,72%</c:v>
-                  </c:pt>
-                  <c:pt idx="4">
-                    <c:v>Sistema BESS completo — 12,59%</c:v>
-                  </c:pt>
-                  <c:pt idx="5">
-                    <c:v>Materiais elétricos — 12,99%</c:v>
-                  </c:pt>
-                  <c:pt idx="6">
-                    <c:v>Estruturas metálicas — 13,45%</c:v>
-                  </c:pt>
-                  <c:pt idx="7">
-                    <c:v>EPC, construção e instalação — 15,40%</c:v>
-                  </c:pt>
-                  <c:pt idx="8">
-                    <c:v>Módulos fotovoltaicos — 27,50%</c:v>
-                  </c:pt>
-                </c:lvl>
-              </c:multiLvlStrCache>
-            </c:multiLvlStrRef>
-          </c:cat>
-          <c:val>
-            <c:numRef>
-              <c:f>Sheet1!$B$2:$B$10</c:f>
-              <c:numCache>
-                <c:formatCode>General</c:formatCode>
-                <c:ptCount val="9"/>
-                <c:pt idx="0">
-                  <c:v>2.92</c:v>
-                </c:pt>
-                <c:pt idx="1">
-                  <c:v>3.46</c:v>
-                </c:pt>
-                <c:pt idx="2">
-                  <c:v>3.97</c:v>
-                </c:pt>
-                <c:pt idx="3">
-                  <c:v>7.72</c:v>
-                </c:pt>
-                <c:pt idx="4">
-                  <c:v>12.59</c:v>
-                </c:pt>
-                <c:pt idx="5">
-                  <c:v>12.99</c:v>
-                </c:pt>
-                <c:pt idx="6">
-                  <c:v>13.45</c:v>
-                </c:pt>
-                <c:pt idx="7">
-                  <c:v>15.4</c:v>
-                </c:pt>
-                <c:pt idx="8">
-                  <c:v>27.5</c:v>
-                </c:pt>
-              </c:numCache>
-            </c:numRef>
-          </c:val>
-        </c:ser>
-        <c:dLbls>
-          <c:numFmt formatCode="#,##0" sourceLinked="0"/>
-          <c:txPr>
-            <a:bodyPr/>
-            <a:lstStyle/>
-            <a:p>
-              <a:pPr>
-                <a:defRPr b="0" i="0" strike="noStrike" sz="1200" u="none">
-                  <a:solidFill>
-                    <a:srgbClr val="000000"/>
-                  </a:solidFill>
-                  <a:latin typeface="Arial"/>
-                </a:defRPr>
-              </a:pPr>
-            </a:p>
-          </c:txPr>
-          <c:showLegendKey val="0"/>
-          <c:showVal val="0"/>
-          <c:showCatName val="0"/>
-          <c:showSerName val="0"/>
-          <c:showPercent val="0"/>
-          <c:showBubbleSize val="0"/>
-          <c:showLeaderLines val="0"/>
-        </c:dLbls>
-        <c:gapWidth val="55"/>
-        <c:overlap val="0"/>
-        <c:axId val="2094734554"/>
-        <c:axId val="2094734552"/>
-        <c:axId val="2094734556"/>
-      </c:barChart>
-      <c:catAx>
-        <c:axId val="2094734554"/>
-        <c:scaling>
-          <c:orientation val="minMax"/>
-        </c:scaling>
-        <c:delete val="0"/>
-        <c:axPos val="l"/>
-        <c:numFmt formatCode="General" sourceLinked="1"/>
-        <c:majorTickMark val="out"/>
-        <c:minorTickMark val="none"/>
-        <c:tickLblPos val="nextTo"/>
-        <c:spPr>
-          <a:ln w="12700" cap="flat">
-            <a:solidFill>
-              <a:srgbClr val="888888"/>
-            </a:solidFill>
-            <a:prstDash val="solid"/>
-            <a:round/>
-          </a:ln>
-        </c:spPr>
-        <c:txPr>
-          <a:bodyPr/>
-          <a:lstStyle/>
-          <a:p>
-            <a:pPr>
-              <a:defRPr sz="1200" b="0" i="0" u="none" strike="noStrike">
-                <a:solidFill>
-                  <a:srgbClr val="3E4E59"/>
-                </a:solidFill>
-                <a:latin typeface="Arial"/>
-              </a:defRPr>
-            </a:pPr>
-            <a:endParaRPr lang="en-US"/>
-          </a:p>
-        </c:txPr>
-        <c:crossAx val="2094734552"/>
-        <c:crosses val="autoZero"/>
-        <c:auto val="1"/>
-        <c:lblAlgn val="ctr"/>
-        <c:noMultiLvlLbl val="1"/>
-      </c:catAx>
-      <c:valAx>
-        <c:axId val="2094734552"/>
-        <c:scaling>
-          <c:orientation val="minMax"/>
-          <c:max val="30"/>
-          <c:min val="0"/>
-        </c:scaling>
-        <c:delete val="0"/>
-        <c:axPos val="b"/>
-        <c:majorGridlines>
-          <c:spPr>
-            <a:ln w="9525" cap="flat">
-              <a:solidFill>
-                <a:srgbClr val="E8EEF2"/>
-              </a:solidFill>
-              <a:prstDash val="solid"/>
-              <a:round/>
-            </a:ln>
-          </c:spPr>
-        </c:majorGridlines>
-        <c:numFmt formatCode="0&quot;%&quot;" sourceLinked="0"/>
-        <c:majorTickMark val="out"/>
-        <c:minorTickMark val="none"/>
-        <c:tickLblPos val="low"/>
-        <c:spPr>
-          <a:ln w="12700" cap="flat">
-            <a:solidFill>
-              <a:srgbClr val="888888"/>
-            </a:solidFill>
-            <a:prstDash val="solid"/>
-            <a:round/>
-          </a:ln>
-        </c:spPr>
-        <c:txPr>
-          <a:bodyPr/>
-          <a:lstStyle/>
-          <a:p>
-            <a:pPr>
-              <a:defRPr sz="1000" b="0" i="0" u="none" strike="noStrike">
-                <a:solidFill>
-                  <a:srgbClr val="7A8A94"/>
-                </a:solidFill>
-                <a:latin typeface="Arial"/>
-              </a:defRPr>
-            </a:pPr>
-            <a:endParaRPr lang="en-US"/>
-          </a:p>
-        </c:txPr>
-        <c:crossAx val="2094734554"/>
-        <c:crosses val="autoZero"/>
-        <c:crossBetween val="between"/>
-      </c:valAx>
-      <c:spPr>
-        <a:noFill/>
-        <a:ln>
-          <a:noFill/>
-        </a:ln>
-        <a:effectLst/>
-      </c:spPr>
-    </c:plotArea>
-    <c:plotVisOnly val="1"/>
-    <c:dispBlanksAs val="span"/>
-  </c:chart>
-  <c:spPr>
-    <a:noFill/>
-    <a:ln>
-      <a:noFill/>
-    </a:ln>
-    <a:effectLst/>
-  </c:spPr>
-  <c:externalData r:id="rId1">
-    <c:autoUpdate val="0"/>
-  </c:externalData>
-</c:chartSpace>
-</file>
-
-<file path=ppt/charts/chart3.xml><?xml version="1.0" encoding="utf-8"?>
-<c:chartSpace xmlns:c="http://schemas.openxmlformats.org/drawingml/2006/chart" xmlns:a="http://schemas.openxmlformats.org/drawingml/2006/main" xmlns:r="http://schemas.openxmlformats.org/officeDocument/2006/relationships">
-  <c:date1904 val="0"/>
-  <c:roundedCorners val="1"/>
-  <c:chart>
-    <c:title>
-      <c:tx>
-        <c:rich>
-          <a:bodyPr/>
-          <a:lstStyle/>
-          <a:p>
-            <a:pPr>
-              <a:defRPr sz="1250" b="1" i="0" u="none" strike="noStrike">
-                <a:solidFill>
-                  <a:srgbClr val="16303F"/>
-                </a:solidFill>
-                <a:latin typeface="Arial"/>
-              </a:defRPr>
-            </a:pPr>
-            <a:r>
-              <a:rPr sz="1250" b="1" i="0" u="none" strike="noStrike">
-                <a:solidFill>
-                  <a:srgbClr val="16303F"/>
-                </a:solidFill>
-                <a:latin typeface="Arial"/>
-              </a:rPr>
-              <a:t>Isenção de ICMS sobre energia compensada — trajetória de retomada</a:t>
-            </a:r>
-          </a:p>
-        </c:rich>
-      </c:tx>
-      <c:layout/>
-      <c:overlay val="0"/>
-    </c:title>
-    <c:autoTitleDeleted val="0"/>
-    <c:plotArea>
-      <c:layout/>
-      <c:barChart>
-        <c:barDir val="col"/>
-        <c:grouping val="clustered"/>
-        <c:varyColors val="0"/>
-        <c:ser>
-          <c:idx val="0"/>
-          <c:order val="0"/>
-          <c:tx>
-            <c:strRef>
-              <c:f>Sheet1!$B$1</c:f>
-              <c:strCache>
-                <c:ptCount val="1"/>
-                <c:pt idx="0">
-                  <c:v>Isenção de ICMS</c:v>
-                </c:pt>
-              </c:strCache>
-            </c:strRef>
-          </c:tx>
-          <c:spPr>
-            <a:solidFill>
-              <a:srgbClr val="F2B705"/>
-            </a:solidFill>
-            <a:effectLst/>
-          </c:spPr>
-          <c:invertIfNegative val="0"/>
-          <c:dLbls>
-            <c:numFmt formatCode="0&quot;%&quot;" sourceLinked="0"/>
-            <c:txPr>
-              <a:bodyPr/>
-              <a:lstStyle/>
-              <a:p>
-                <a:pPr>
-                  <a:defRPr b="1" i="0" strike="noStrike" sz="1200" u="none">
-                    <a:solidFill>
-                      <a:srgbClr val="16303F"/>
-                    </a:solidFill>
-                    <a:latin typeface="Arial"/>
-                  </a:defRPr>
-                </a:pPr>
-              </a:p>
-            </c:txPr>
-            <c:showLegendKey val="0"/>
-            <c:showVal val="1"/>
-            <c:showCatName val="0"/>
-            <c:showSerName val="0"/>
-            <c:showPercent val="0"/>
-            <c:showBubbleSize val="0"/>
-            <c:showLeaderLines val="0"/>
-          </c:dLbls>
-          <c:cat>
-            <c:multiLvlStrRef>
-              <c:f>Sheet1!$A$2:$A$7</c:f>
-              <c:multiLvlStrCache>
-                <c:ptCount val="6"/>
-                <c:lvl>
-                  <c:pt idx="0">
-                    <c:v>2028</c:v>
-                  </c:pt>
-                  <c:pt idx="1">
-                    <c:v>2029</c:v>
-                  </c:pt>
-                  <c:pt idx="2">
-                    <c:v>2030</c:v>
-                  </c:pt>
-                  <c:pt idx="3">
-                    <c:v>2031</c:v>
-                  </c:pt>
-                  <c:pt idx="4">
-                    <c:v>2032</c:v>
-                  </c:pt>
-                  <c:pt idx="5">
-                    <c:v>2033</c:v>
-                  </c:pt>
-                </c:lvl>
-              </c:multiLvlStrCache>
-            </c:multiLvlStrRef>
-          </c:cat>
-          <c:val>
-            <c:numRef>
-              <c:f>Sheet1!$B$2:$B$7</c:f>
-              <c:numCache>
-                <c:formatCode>General</c:formatCode>
-                <c:ptCount val="6"/>
-                <c:pt idx="0">
-                  <c:v>100</c:v>
-                </c:pt>
-                <c:pt idx="1">
-                  <c:v>80</c:v>
-                </c:pt>
-                <c:pt idx="2">
-                  <c:v>60</c:v>
-                </c:pt>
-                <c:pt idx="3">
-                  <c:v>40</c:v>
-                </c:pt>
-                <c:pt idx="4">
-                  <c:v>20</c:v>
-                </c:pt>
-                <c:pt idx="5">
-                  <c:v>0</c:v>
-                </c:pt>
-              </c:numCache>
-            </c:numRef>
-          </c:val>
-        </c:ser>
-        <c:dLbls>
-          <c:numFmt formatCode="0&quot;%&quot;" sourceLinked="0"/>
-          <c:txPr>
-            <a:bodyPr/>
-            <a:lstStyle/>
-            <a:p>
-              <a:pPr>
-                <a:defRPr b="1" i="0" strike="noStrike" sz="1200" u="none">
-                  <a:solidFill>
-                    <a:srgbClr val="16303F"/>
-                  </a:solidFill>
-                  <a:latin typeface="Arial"/>
-                </a:defRPr>
-              </a:pPr>
-            </a:p>
-          </c:txPr>
-          <c:showLegendKey val="0"/>
-          <c:showVal val="1"/>
-          <c:showCatName val="0"/>
-          <c:showSerName val="0"/>
-          <c:showPercent val="0"/>
-          <c:showBubbleSize val="0"/>
-          <c:showLeaderLines val="0"/>
-        </c:dLbls>
-        <c:gapWidth val="45"/>
-        <c:overlap val="0"/>
-        <c:axId val="2094734554"/>
-        <c:axId val="2094734552"/>
-        <c:axId val="2094734556"/>
-      </c:barChart>
-      <c:catAx>
-        <c:axId val="2094734554"/>
-        <c:scaling>
-          <c:orientation val="minMax"/>
-        </c:scaling>
-        <c:delete val="0"/>
-        <c:axPos val="b"/>
-        <c:numFmt formatCode="General" sourceLinked="1"/>
-        <c:majorTickMark val="out"/>
-        <c:minorTickMark val="none"/>
-        <c:tickLblPos val="low"/>
-        <c:spPr>
-          <a:ln w="12700" cap="flat">
-            <a:solidFill>
-              <a:srgbClr val="888888"/>
-            </a:solidFill>
-            <a:prstDash val="solid"/>
-            <a:round/>
-          </a:ln>
-        </c:spPr>
-        <c:txPr>
-          <a:bodyPr/>
-          <a:lstStyle/>
-          <a:p>
-            <a:pPr>
-              <a:defRPr sz="1200" b="0" i="0" u="none" strike="noStrike">
-                <a:solidFill>
-                  <a:srgbClr val="3E4E59"/>
-                </a:solidFill>
-                <a:latin typeface="Arial"/>
-              </a:defRPr>
-            </a:pPr>
-            <a:endParaRPr lang="en-US"/>
-          </a:p>
-        </c:txPr>
-        <c:crossAx val="2094734552"/>
-        <c:crosses val="autoZero"/>
-        <c:auto val="1"/>
-        <c:lblAlgn val="ctr"/>
-        <c:noMultiLvlLbl val="1"/>
-      </c:catAx>
-      <c:valAx>
-        <c:axId val="2094734552"/>
-        <c:scaling>
-          <c:orientation val="minMax"/>
-          <c:max val="100"/>
-          <c:min val="0"/>
-        </c:scaling>
-        <c:delete val="0"/>
-        <c:axPos val="l"/>
-        <c:majorGridlines>
-          <c:spPr>
-            <a:ln w="9525" cap="flat">
-              <a:solidFill>
-                <a:srgbClr val="E8EEF2"/>
-              </a:solidFill>
-              <a:prstDash val="solid"/>
-              <a:round/>
-            </a:ln>
-          </c:spPr>
-        </c:majorGridlines>
-        <c:numFmt formatCode="0&quot;%&quot;" sourceLinked="0"/>
-        <c:majorTickMark val="out"/>
-        <c:minorTickMark val="none"/>
-        <c:tickLblPos val="nextTo"/>
-        <c:spPr>
-          <a:ln w="12700" cap="flat">
-            <a:solidFill>
-              <a:srgbClr val="888888"/>
-            </a:solidFill>
-            <a:prstDash val="solid"/>
-            <a:round/>
-          </a:ln>
-        </c:spPr>
-        <c:txPr>
-          <a:bodyPr/>
-          <a:lstStyle/>
-          <a:p>
-            <a:pPr>
-              <a:defRPr sz="1000" b="0" i="0" u="none" strike="noStrike">
-                <a:solidFill>
-                  <a:srgbClr val="7A8A94"/>
-                </a:solidFill>
-                <a:latin typeface="Arial"/>
-              </a:defRPr>
-            </a:pPr>
-            <a:endParaRPr lang="en-US"/>
-          </a:p>
-        </c:txPr>
-        <c:crossAx val="2094734554"/>
-        <c:crosses val="autoZero"/>
-        <c:crossBetween val="between"/>
-      </c:valAx>
-      <c:spPr>
-        <a:noFill/>
-        <a:ln>
-          <a:noFill/>
-        </a:ln>
-        <a:effectLst/>
-      </c:spPr>
-    </c:plotArea>
-    <c:plotVisOnly val="1"/>
-    <c:dispBlanksAs val="span"/>
-  </c:chart>
-  <c:spPr>
-    <a:noFill/>
-    <a:ln>
-      <a:noFill/>
-    </a:ln>
-    <a:effectLst/>
-  </c:spPr>
-  <c:externalData r:id="rId1">
-    <c:autoUpdate val="0"/>
-  </c:externalData>
-</c:chartSpace>
-</file>
-
-<file path=ppt/charts/chart4.xml><?xml version="1.0" encoding="utf-8"?>
-<c:chartSpace xmlns:c="http://schemas.openxmlformats.org/drawingml/2006/chart" xmlns:a="http://schemas.openxmlformats.org/drawingml/2006/main" xmlns:r="http://schemas.openxmlformats.org/officeDocument/2006/relationships">
-  <c:date1904 val="0"/>
-  <c:roundedCorners val="1"/>
-  <c:chart>
-    <c:title>
-      <c:tx>
-        <c:rich>
-          <a:bodyPr/>
-          <a:lstStyle/>
-          <a:p>
-            <a:pPr>
-              <a:defRPr sz="1250" b="1" i="0" u="none" strike="noStrike">
-                <a:solidFill>
-                  <a:srgbClr val="16303F"/>
-                </a:solidFill>
-                <a:latin typeface="Arial"/>
-              </a:defRPr>
-            </a:pPr>
-            <a:r>
-              <a:rPr sz="1250" b="1" i="0" u="none" strike="noStrike">
-                <a:solidFill>
-                  <a:srgbClr val="16303F"/>
-                </a:solidFill>
-                <a:latin typeface="Arial"/>
-              </a:rPr>
-              <a:t>Evolução do VPL acumulado por ano de projeto (R$ milhões)</a:t>
-            </a:r>
-          </a:p>
-        </c:rich>
-      </c:tx>
-      <c:layout/>
-      <c:overlay val="0"/>
-    </c:title>
-    <c:autoTitleDeleted val="0"/>
-    <c:plotArea>
-      <c:layout/>
-      <c:barChart>
-        <c:barDir val="col"/>
-        <c:grouping val="stacked"/>
-        <c:varyColors val="0"/>
-        <c:ser>
-          <c:idx val="0"/>
-          <c:order val="0"/>
-          <c:tx>
-            <c:strRef>
-              <c:f>Sheet1!$B$1</c:f>
-              <c:strCache>
-                <c:ptCount val="1"/>
-                <c:pt idx="0">
-                  <c:v>Fase de investimento</c:v>
-                </c:pt>
-              </c:strCache>
-            </c:strRef>
-          </c:tx>
-          <c:spPr>
-            <a:solidFill>
-              <a:srgbClr val="31485A"/>
-            </a:solidFill>
-            <a:effectLst/>
-          </c:spPr>
-          <c:invertIfNegative val="0"/>
-          <c:dLbls>
-            <c:numFmt formatCode="#,##0" sourceLinked="0"/>
-            <c:txPr>
-              <a:bodyPr/>
-              <a:lstStyle/>
-              <a:p>
-                <a:pPr>
-                  <a:defRPr b="0" i="0" strike="noStrike" sz="1200" u="none">
-                    <a:solidFill>
-                      <a:srgbClr val="000000"/>
-                    </a:solidFill>
-                    <a:latin typeface="Arial"/>
-                  </a:defRPr>
-                </a:pPr>
-              </a:p>
-            </c:txPr>
-            <c:showLegendKey val="0"/>
-            <c:showVal val="0"/>
-            <c:showCatName val="0"/>
-            <c:showSerName val="0"/>
-            <c:showPercent val="0"/>
-            <c:showBubbleSize val="0"/>
-            <c:showLeaderLines val="0"/>
-          </c:dLbls>
-          <c:cat>
-            <c:multiLvlStrRef>
-              <c:f>Sheet1!$A$2:$A$22</c:f>
-              <c:multiLvlStrCache>
-                <c:ptCount val="21"/>
-                <c:lvl>
-                  <c:pt idx="0">
-                    <c:v>0</c:v>
-                  </c:pt>
-                  <c:pt idx="1">
-                    <c:v>1</c:v>
-                  </c:pt>
-                  <c:pt idx="2">
-                    <c:v>2</c:v>
-                  </c:pt>
-                  <c:pt idx="3">
-                    <c:v>3</c:v>
-                  </c:pt>
-                  <c:pt idx="4">
-                    <c:v>4</c:v>
-                  </c:pt>
-                  <c:pt idx="5">
-                    <c:v>5</c:v>
-                  </c:pt>
-                  <c:pt idx="6">
-                    <c:v>6</c:v>
-                  </c:pt>
-                  <c:pt idx="7">
-                    <c:v>7</c:v>
-                  </c:pt>
-                  <c:pt idx="8">
-                    <c:v>8</c:v>
-                  </c:pt>
-                  <c:pt idx="9">
-                    <c:v>9</c:v>
-                  </c:pt>
-                  <c:pt idx="10">
-                    <c:v>10</c:v>
-                  </c:pt>
-                  <c:pt idx="11">
-                    <c:v>11</c:v>
-                  </c:pt>
-                  <c:pt idx="12">
-                    <c:v>12</c:v>
-                  </c:pt>
-                  <c:pt idx="13">
-                    <c:v>13</c:v>
-                  </c:pt>
-                  <c:pt idx="14">
-                    <c:v>14</c:v>
-                  </c:pt>
-                  <c:pt idx="15">
-                    <c:v>15</c:v>
-                  </c:pt>
-                  <c:pt idx="16">
-                    <c:v>16</c:v>
-                  </c:pt>
-                  <c:pt idx="17">
-                    <c:v>17</c:v>
-                  </c:pt>
-                  <c:pt idx="18">
-                    <c:v>18</c:v>
-                  </c:pt>
-                  <c:pt idx="19">
-                    <c:v>19</c:v>
-                  </c:pt>
-                  <c:pt idx="20">
-                    <c:v>20</c:v>
-                  </c:pt>
-                </c:lvl>
-              </c:multiLvlStrCache>
-            </c:multiLvlStrRef>
-          </c:cat>
-          <c:val>
-            <c:numRef>
-              <c:f>Sheet1!$B$2:$B$22</c:f>
-              <c:numCache>
-                <c:formatCode>General</c:formatCode>
-                <c:ptCount val="21"/>
-                <c:pt idx="0">
-                  <c:v>-13.9</c:v>
-                </c:pt>
-                <c:pt idx="1">
-                  <c:v>-12.4</c:v>
-                </c:pt>
-                <c:pt idx="2">
-                  <c:v>-10.9</c:v>
-                </c:pt>
-                <c:pt idx="3">
-                  <c:v>-9.5</c:v>
-                </c:pt>
-                <c:pt idx="4">
-                  <c:v>-8.1</c:v>
-                </c:pt>
-                <c:pt idx="5">
-                  <c:v>-6.7</c:v>
-                </c:pt>
-                <c:pt idx="6">
-                  <c:v>-5.3</c:v>
-                </c:pt>
-                <c:pt idx="7">
-                  <c:v>-3.9</c:v>
-                </c:pt>
-                <c:pt idx="8">
-                  <c:v>-1.9</c:v>
-                </c:pt>
-                <c:pt idx="9">
-                  <c:v>0</c:v>
-                </c:pt>
-                <c:pt idx="10">
-                  <c:v>0</c:v>
-                </c:pt>
-                <c:pt idx="11">
-                  <c:v>0</c:v>
-                </c:pt>
-                <c:pt idx="12">
-                  <c:v>0</c:v>
-                </c:pt>
-                <c:pt idx="13">
-                  <c:v>0</c:v>
-                </c:pt>
-                <c:pt idx="14">
-                  <c:v>0</c:v>
-                </c:pt>
-                <c:pt idx="15">
-                  <c:v>0</c:v>
-                </c:pt>
-                <c:pt idx="16">
-                  <c:v>0</c:v>
-                </c:pt>
-                <c:pt idx="17">
-                  <c:v>0</c:v>
-                </c:pt>
-                <c:pt idx="18">
-                  <c:v>0</c:v>
-                </c:pt>
-                <c:pt idx="19">
-                  <c:v>0</c:v>
-                </c:pt>
-                <c:pt idx="20">
-                  <c:v>0</c:v>
-                </c:pt>
-              </c:numCache>
-            </c:numRef>
-          </c:val>
-        </c:ser>
-        <c:ser>
-          <c:idx val="1"/>
-          <c:order val="1"/>
-          <c:tx>
-            <c:strRef>
-              <c:f>Sheet1!$C$1</c:f>
-              <c:strCache>
-                <c:ptCount val="1"/>
-                <c:pt idx="0">
-                  <c:v>Fase de retorno</c:v>
-                </c:pt>
-              </c:strCache>
-            </c:strRef>
-          </c:tx>
-          <c:spPr>
-            <a:solidFill>
-              <a:srgbClr val="2E7DAF"/>
-            </a:solidFill>
-            <a:effectLst/>
-          </c:spPr>
-          <c:invertIfNegative val="0"/>
-          <c:dLbls>
-            <c:numFmt formatCode="#,##0" sourceLinked="0"/>
-            <c:txPr>
-              <a:bodyPr/>
-              <a:lstStyle/>
-              <a:p>
-                <a:pPr>
-                  <a:defRPr b="0" i="0" strike="noStrike" sz="1200" u="none">
-                    <a:solidFill>
-                      <a:srgbClr val="000000"/>
-                    </a:solidFill>
-                    <a:latin typeface="Arial"/>
-                  </a:defRPr>
-                </a:pPr>
-              </a:p>
-            </c:txPr>
-            <c:showLegendKey val="0"/>
-            <c:showVal val="0"/>
-            <c:showCatName val="0"/>
-            <c:showSerName val="0"/>
-            <c:showPercent val="0"/>
-            <c:showBubbleSize val="0"/>
-            <c:showLeaderLines val="0"/>
-          </c:dLbls>
-          <c:cat>
-            <c:multiLvlStrRef>
-              <c:f>Sheet1!$A$2:$A$22</c:f>
-              <c:multiLvlStrCache>
-                <c:ptCount val="21"/>
-                <c:lvl>
-                  <c:pt idx="0">
-                    <c:v>0</c:v>
-                  </c:pt>
-                  <c:pt idx="1">
-                    <c:v>1</c:v>
-                  </c:pt>
-                  <c:pt idx="2">
-                    <c:v>2</c:v>
-                  </c:pt>
-                  <c:pt idx="3">
-                    <c:v>3</c:v>
-                  </c:pt>
-                  <c:pt idx="4">
-                    <c:v>4</c:v>
-                  </c:pt>
-                  <c:pt idx="5">
-                    <c:v>5</c:v>
-                  </c:pt>
-                  <c:pt idx="6">
-                    <c:v>6</c:v>
-                  </c:pt>
-                  <c:pt idx="7">
-                    <c:v>7</c:v>
-                  </c:pt>
-                  <c:pt idx="8">
-                    <c:v>8</c:v>
-                  </c:pt>
-                  <c:pt idx="9">
-                    <c:v>9</c:v>
-                  </c:pt>
-                  <c:pt idx="10">
-                    <c:v>10</c:v>
-                  </c:pt>
-                  <c:pt idx="11">
-                    <c:v>11</c:v>
-                  </c:pt>
-                  <c:pt idx="12">
-                    <c:v>12</c:v>
-                  </c:pt>
-                  <c:pt idx="13">
-                    <c:v>13</c:v>
-                  </c:pt>
-                  <c:pt idx="14">
-                    <c:v>14</c:v>
-                  </c:pt>
-                  <c:pt idx="15">
-                    <c:v>15</c:v>
-                  </c:pt>
-                  <c:pt idx="16">
-                    <c:v>16</c:v>
-                  </c:pt>
-                  <c:pt idx="17">
-                    <c:v>17</c:v>
-                  </c:pt>
-                  <c:pt idx="18">
-                    <c:v>18</c:v>
-                  </c:pt>
-                  <c:pt idx="19">
-                    <c:v>19</c:v>
-                  </c:pt>
-                  <c:pt idx="20">
-                    <c:v>20</c:v>
-                  </c:pt>
-                </c:lvl>
-              </c:multiLvlStrCache>
-            </c:multiLvlStrRef>
-          </c:cat>
-          <c:val>
-            <c:numRef>
-              <c:f>Sheet1!$C$2:$C$22</c:f>
-              <c:numCache>
-                <c:formatCode>General</c:formatCode>
-                <c:ptCount val="21"/>
-                <c:pt idx="0">
-                  <c:v>0</c:v>
-                </c:pt>
-                <c:pt idx="1">
-                  <c:v>0</c:v>
-                </c:pt>
-                <c:pt idx="2">
-                  <c:v>0</c:v>
-                </c:pt>
-                <c:pt idx="3">
-                  <c:v>0</c:v>
-                </c:pt>
-                <c:pt idx="4">
-                  <c:v>0</c:v>
-                </c:pt>
-                <c:pt idx="5">
-                  <c:v>0</c:v>
-                </c:pt>
-                <c:pt idx="6">
-                  <c:v>0</c:v>
-                </c:pt>
-                <c:pt idx="7">
-                  <c:v>0</c:v>
-                </c:pt>
-                <c:pt idx="8">
-                  <c:v>0</c:v>
-                </c:pt>
-                <c:pt idx="9">
-                  <c:v>0.4</c:v>
-                </c:pt>
-                <c:pt idx="10">
-                  <c:v>1</c:v>
-                </c:pt>
-                <c:pt idx="11">
-                  <c:v>1.7</c:v>
-                </c:pt>
-                <c:pt idx="12">
-                  <c:v>2.3</c:v>
-                </c:pt>
-                <c:pt idx="13">
-                  <c:v>2.9</c:v>
-                </c:pt>
-                <c:pt idx="14">
-                  <c:v>3.5</c:v>
-                </c:pt>
-                <c:pt idx="15">
-                  <c:v>4.1</c:v>
-                </c:pt>
-                <c:pt idx="16">
-                  <c:v>4.7</c:v>
-                </c:pt>
-                <c:pt idx="17">
-                  <c:v>5.2</c:v>
-                </c:pt>
-                <c:pt idx="18">
-                  <c:v>5.7</c:v>
-                </c:pt>
-                <c:pt idx="19">
-                  <c:v>6.1</c:v>
-                </c:pt>
-                <c:pt idx="20">
-                  <c:v>6.37</c:v>
-                </c:pt>
-              </c:numCache>
-            </c:numRef>
-          </c:val>
-        </c:ser>
-        <c:dLbls>
-          <c:numFmt formatCode="#,##0" sourceLinked="0"/>
-          <c:txPr>
-            <a:bodyPr/>
-            <a:lstStyle/>
-            <a:p>
-              <a:pPr>
-                <a:defRPr b="0" i="0" strike="noStrike" sz="1200" u="none">
-                  <a:solidFill>
-                    <a:srgbClr val="000000"/>
-                  </a:solidFill>
-                  <a:latin typeface="Arial"/>
-                </a:defRPr>
-              </a:pPr>
-            </a:p>
-          </c:txPr>
-          <c:showLegendKey val="0"/>
-          <c:showVal val="0"/>
-          <c:showCatName val="0"/>
-          <c:showSerName val="0"/>
-          <c:showPercent val="0"/>
-          <c:showBubbleSize val="0"/>
-          <c:showLeaderLines val="0"/>
-        </c:dLbls>
-        <c:gapWidth val="35"/>
-        <c:overlap val="100"/>
-        <c:axId val="2094734554"/>
-        <c:axId val="2094734552"/>
-        <c:axId val="2094734556"/>
-      </c:barChart>
-      <c:catAx>
-        <c:axId val="2094734554"/>
-        <c:scaling>
-          <c:orientation val="minMax"/>
-        </c:scaling>
-        <c:delete val="0"/>
-        <c:axPos val="b"/>
-        <c:numFmt formatCode="General" sourceLinked="1"/>
-        <c:majorTickMark val="out"/>
-        <c:minorTickMark val="none"/>
-        <c:tickLblPos val="low"/>
-        <c:spPr>
-          <a:ln w="12700" cap="flat">
-            <a:solidFill>
-              <a:srgbClr val="888888"/>
-            </a:solidFill>
-            <a:prstDash val="solid"/>
-            <a:round/>
-          </a:ln>
-        </c:spPr>
-        <c:txPr>
-          <a:bodyPr/>
-          <a:lstStyle/>
-          <a:p>
-            <a:pPr>
-              <a:defRPr sz="1000" b="0" i="0" u="none" strike="noStrike">
-                <a:solidFill>
-                  <a:srgbClr val="7A8A94"/>
-                </a:solidFill>
-                <a:latin typeface="Arial"/>
-              </a:defRPr>
-            </a:pPr>
-            <a:endParaRPr lang="en-US"/>
-          </a:p>
-        </c:txPr>
-        <c:crossAx val="2094734552"/>
-        <c:crosses val="autoZero"/>
-        <c:auto val="1"/>
-        <c:lblAlgn val="ctr"/>
-        <c:noMultiLvlLbl val="1"/>
-      </c:catAx>
-      <c:valAx>
-        <c:axId val="2094734552"/>
-        <c:scaling>
-          <c:orientation val="minMax"/>
-        </c:scaling>
-        <c:delete val="0"/>
-        <c:axPos val="l"/>
-        <c:majorGridlines>
-          <c:spPr>
-            <a:ln w="9525" cap="flat">
-              <a:solidFill>
-                <a:srgbClr val="E8EEF2"/>
-              </a:solidFill>
-              <a:prstDash val="solid"/>
-              <a:round/>
-            </a:ln>
-          </c:spPr>
-        </c:majorGridlines>
-        <c:numFmt formatCode="&quot;R$ &quot;#,##0&quot;M&quot;" sourceLinked="0"/>
-        <c:majorTickMark val="out"/>
-        <c:minorTickMark val="none"/>
-        <c:tickLblPos val="nextTo"/>
-        <c:spPr>
-          <a:ln w="12700" cap="flat">
-            <a:solidFill>
-              <a:srgbClr val="888888"/>
-            </a:solidFill>
-            <a:prstDash val="solid"/>
-            <a:round/>
-          </a:ln>
-        </c:spPr>
-        <c:txPr>
-          <a:bodyPr/>
-          <a:lstStyle/>
-          <a:p>
-            <a:pPr>
-              <a:defRPr sz="1000" b="0" i="0" u="none" strike="noStrike">
-                <a:solidFill>
-                  <a:srgbClr val="7A8A94"/>
-                </a:solidFill>
-                <a:latin typeface="Arial"/>
-              </a:defRPr>
-            </a:pPr>
-            <a:endParaRPr lang="en-US"/>
-          </a:p>
-        </c:txPr>
-        <c:crossAx val="2094734554"/>
-        <c:crosses val="autoZero"/>
-        <c:crossBetween val="between"/>
-      </c:valAx>
-      <c:spPr>
-        <a:noFill/>
-        <a:ln>
-          <a:noFill/>
-        </a:ln>
-        <a:effectLst/>
-      </c:spPr>
-    </c:plotArea>
-    <c:legend>
-      <c:legendPos val="b"/>
-      <c:overlay val="0"/>
-      <c:txPr>
-        <a:bodyPr/>
-        <a:lstStyle/>
-        <a:p>
-          <a:pPr>
-            <a:defRPr sz="1100">
-              <a:solidFill>
-                <a:srgbClr val="3E4E59"/>
-              </a:solidFill>
-              <a:latin typeface="Arial"/>
-              <a:cs typeface="Arial"/>
-            </a:defRPr>
-          </a:pPr>
-          <a:endParaRPr lang="en-US"/>
-        </a:p>
-      </c:txPr>
-    </c:legend>
-    <c:plotVisOnly val="1"/>
-    <c:dispBlanksAs val="span"/>
-  </c:chart>
-  <c:spPr>
-    <a:noFill/>
-    <a:ln>
-      <a:noFill/>
-    </a:ln>
-    <a:effectLst/>
-  </c:spPr>
-  <c:externalData r:id="rId1">
-    <c:autoUpdate val="0"/>
-  </c:externalData>
-</c:chartSpace>
 </file>
 
 <file path=ppt/notesMasters/notesMaster1.xml><?xml version="1.0" encoding="utf-8"?>
@@ -4275,22 +2348,30 @@
           </a:p>
         </p:txBody>
       </p:sp>
-      <p:graphicFrame>
-        <p:nvGraphicFramePr>
-          <p:cNvPr id="3" name="Chart 0" descr=""/>
-          <p:cNvGraphicFramePr/>
-          <p:nvPr/>
-        </p:nvGraphicFramePr>
-        <p:xfrm>
-          <a:off x="685800" y="1463040"/>
-          <a:ext cx="10835640" cy="4160520"/>
-        </p:xfrm>
-        <a:graphic xmlns:a="http://schemas.openxmlformats.org/drawingml/2006/main">
-          <a:graphicData uri="http://schemas.openxmlformats.org/drawingml/2006/chart">
-            <c:chart xmlns:c="http://schemas.openxmlformats.org/drawingml/2006/chart" r:id="rId1"/>
-          </a:graphicData>
-        </a:graphic>
-      </p:graphicFrame>
+      <p:pic>
+        <p:nvPicPr>
+          <p:cNvPr id="3" name="Image 0" descr="chart10.png">    </p:cNvPr>
+          <p:cNvPicPr>
+            <a:picLocks noChangeAspect="1"/>
+          </p:cNvPicPr>
+          <p:nvPr/>
+        </p:nvPicPr>
+        <p:blipFill>
+          <a:blip r:embed="rId1"/>
+          <a:stretch>
+            <a:fillRect/>
+          </a:stretch>
+        </p:blipFill>
+        <p:spPr>
+          <a:xfrm>
+            <a:off x="685800" y="1417320"/>
+            <a:ext cx="10835640" cy="4160520"/>
+          </a:xfrm>
+          <a:prstGeom prst="rect">
+            <a:avLst/>
+          </a:prstGeom>
+        </p:spPr>
+      </p:pic>
       <p:sp>
         <p:nvSpPr>
           <p:cNvPr id="4" name="Shape 1"/>
@@ -6999,22 +5080,30 @@
           </a:effectLst>
         </p:spPr>
       </p:sp>
-      <p:graphicFrame>
-        <p:nvGraphicFramePr>
-          <p:cNvPr id="9" name="Chart 0" descr=""/>
-          <p:cNvGraphicFramePr/>
-          <p:nvPr/>
-        </p:nvGraphicFramePr>
-        <p:xfrm>
-          <a:off x="4663440" y="2103120"/>
-          <a:ext cx="6766560" cy="3383280"/>
-        </p:xfrm>
-        <a:graphic xmlns:a="http://schemas.openxmlformats.org/drawingml/2006/main">
-          <a:graphicData uri="http://schemas.openxmlformats.org/drawingml/2006/chart">
-            <c:chart xmlns:c="http://schemas.openxmlformats.org/drawingml/2006/chart" r:id="rId2"/>
-          </a:graphicData>
-        </a:graphic>
-      </p:graphicFrame>
+      <p:pic>
+        <p:nvPicPr>
+          <p:cNvPr id="9" name="Image 1" descr="chart3.png">    </p:cNvPr>
+          <p:cNvPicPr>
+            <a:picLocks noChangeAspect="1"/>
+          </p:cNvPicPr>
+          <p:nvPr/>
+        </p:nvPicPr>
+        <p:blipFill>
+          <a:blip r:embed="rId2"/>
+          <a:stretch>
+            <a:fillRect/>
+          </a:stretch>
+        </p:blipFill>
+        <p:spPr>
+          <a:xfrm>
+            <a:off x="4645152" y="2057400"/>
+            <a:ext cx="6766560" cy="3520440"/>
+          </a:xfrm>
+          <a:prstGeom prst="rect">
+            <a:avLst/>
+          </a:prstGeom>
+        </p:spPr>
+      </p:pic>
       <p:sp>
         <p:nvSpPr>
           <p:cNvPr id="11" name="Text 6"/>
@@ -10131,22 +8220,30 @@
           </a:p>
         </p:txBody>
       </p:sp>
-      <p:graphicFrame>
-        <p:nvGraphicFramePr>
-          <p:cNvPr id="5" name="Chart 0" descr=""/>
-          <p:cNvGraphicFramePr/>
-          <p:nvPr/>
-        </p:nvGraphicFramePr>
-        <p:xfrm>
-          <a:off x="685800" y="1874520"/>
-          <a:ext cx="10835640" cy="4160520"/>
-        </p:xfrm>
-        <a:graphic xmlns:a="http://schemas.openxmlformats.org/drawingml/2006/main">
-          <a:graphicData uri="http://schemas.openxmlformats.org/drawingml/2006/chart">
-            <c:chart xmlns:c="http://schemas.openxmlformats.org/drawingml/2006/chart" r:id="rId1"/>
-          </a:graphicData>
-        </a:graphic>
-      </p:graphicFrame>
+      <p:pic>
+        <p:nvPicPr>
+          <p:cNvPr id="5" name="Image 0" descr="chart7.png">    </p:cNvPr>
+          <p:cNvPicPr>
+            <a:picLocks noChangeAspect="1"/>
+          </p:cNvPicPr>
+          <p:nvPr/>
+        </p:nvPicPr>
+        <p:blipFill>
+          <a:blip r:embed="rId1"/>
+          <a:stretch>
+            <a:fillRect/>
+          </a:stretch>
+        </p:blipFill>
+        <p:spPr>
+          <a:xfrm>
+            <a:off x="685800" y="1874520"/>
+            <a:ext cx="10835640" cy="4160520"/>
+          </a:xfrm>
+          <a:prstGeom prst="rect">
+            <a:avLst/>
+          </a:prstGeom>
+        </p:spPr>
+      </p:pic>
       <p:sp>
         <p:nvSpPr>
           <p:cNvPr id="6" name="Text 3"/>
@@ -10335,22 +8432,30 @@
           </a:p>
         </p:txBody>
       </p:sp>
-      <p:graphicFrame>
-        <p:nvGraphicFramePr>
-          <p:cNvPr id="3" name="Chart 0" descr=""/>
-          <p:cNvGraphicFramePr/>
-          <p:nvPr/>
-        </p:nvGraphicFramePr>
-        <p:xfrm>
-          <a:off x="685800" y="1554480"/>
-          <a:ext cx="6949440" cy="4480560"/>
-        </p:xfrm>
-        <a:graphic xmlns:a="http://schemas.openxmlformats.org/drawingml/2006/main">
-          <a:graphicData uri="http://schemas.openxmlformats.org/drawingml/2006/chart">
-            <c:chart xmlns:c="http://schemas.openxmlformats.org/drawingml/2006/chart" r:id="rId1"/>
-          </a:graphicData>
-        </a:graphic>
-      </p:graphicFrame>
+      <p:pic>
+        <p:nvPicPr>
+          <p:cNvPr id="3" name="Image 0" descr="chart8.png">    </p:cNvPr>
+          <p:cNvPicPr>
+            <a:picLocks noChangeAspect="1"/>
+          </p:cNvPicPr>
+          <p:nvPr/>
+        </p:nvPicPr>
+        <p:blipFill>
+          <a:blip r:embed="rId1"/>
+          <a:stretch>
+            <a:fillRect/>
+          </a:stretch>
+        </p:blipFill>
+        <p:spPr>
+          <a:xfrm>
+            <a:off x="594360" y="1600200"/>
+            <a:ext cx="6949440" cy="4480560"/>
+          </a:xfrm>
+          <a:prstGeom prst="rect">
+            <a:avLst/>
+          </a:prstGeom>
+        </p:spPr>
+      </p:pic>
       <p:sp>
         <p:nvSpPr>
           <p:cNvPr id="4" name="Shape 1"/>
@@ -10407,7 +8512,7 @@
       </p:sp>
       <p:pic>
         <p:nvPicPr>
-          <p:cNvPr id="6" name="Image 0" descr="preencoded.png">    </p:cNvPr>
+          <p:cNvPr id="6" name="Image 1" descr="preencoded.png">    </p:cNvPr>
           <p:cNvPicPr>
             <a:picLocks noChangeAspect="1"/>
           </p:cNvPicPr>

</xml_diff>

<commit_message>
Corrige transparência dos gráficos e alinha comunicação ao tema agro
Os PNGs dos gráficos gerados na revisão anterior ainda tinham canal
alfa (RGBA) — a mesma causa da falha de exibição dos ícones no
visualizador móvel. Agora todas as imagens do pacote são RGB opacas.

Alinha a narrativa ao tema da exposição, eficiência energética no
agronegócio: nova capa, exemplos de irrigação/bombeamento/secagem nos
mecanismos de valor, cooperativas rurais na Geração Compartilhada e
síntese voltada ao produtor rural. O BESS permanece o assunto central.

Co-Authored-By: Claude Fable 5 <noreply@anthropic.com>
Claude-Session: https://claude.ai/code/session_0198SeXLUYPhAzabpjaRsyNb
</commit_message>
<xml_diff>
--- a/apresentacoes/BESS_Brasil_Lucas_Silva_Costa.pptx
+++ b/apresentacoes/BESS_Brasil_Lucas_Silva_Costa.pptx
@@ -514,7 +514,7 @@
           <a:p>
             <a:r>
               <a:rPr lang="en-US" dirty="0"/>
-              <a:t>Abertura: contextualizar a transição do BESS de tema técnico para tese de investimento consolidada no Brasil.</a:t>
+              <a:t>Abertura: o tema da exposição é eficiência energética no agro; o BESS é o instrumento que a viabiliza economicamente.</a:t>
             </a:r>
             <a:endParaRPr lang="en-US" dirty="0"/>
           </a:p>
@@ -1130,7 +1130,7 @@
           <a:p>
             <a:r>
               <a:rPr lang="en-US" dirty="0"/>
-              <a:t>Dois mecanismos complementares: Time Shifting ataca a tarifa de energia (kWh); Peak Shaving ataca a tarifa de demanda (kW).</a:t>
+              <a:t>Dois mecanismos complementares: Time Shifting ataca a tarifa de energia (kWh); Peak Shaving ataca a tarifa de demanda (kW). No agro: irrigação no vazio e amortecimento dos picos de motores.</a:t>
             </a:r>
             <a:endParaRPr lang="en-US" dirty="0"/>
           </a:p>
@@ -2068,7 +2068,7 @@
                 <a:ea typeface="Arial" pitchFamily="34" charset="-122"/>
                 <a:cs typeface="Arial" pitchFamily="34" charset="-120"/>
               </a:rPr>
-              <a:t>RELATÓRIO EXECUTIVO DE VIABILIDADE DE MERCADO</a:t>
+              <a:t>ARMAZENAMENTO DE ENERGIA POR BATERIAS · BESS</a:t>
             </a:r>
             <a:endParaRPr lang="en-US" sz="1250" dirty="0"/>
           </a:p>
@@ -2110,7 +2110,7 @@
                 <a:ea typeface="Arial" pitchFamily="34" charset="-122"/>
                 <a:cs typeface="Arial" pitchFamily="34" charset="-120"/>
               </a:rPr>
-              <a:t>A Revolução do</a:t>
+              <a:t>Eficiência Energética</a:t>
             </a:r>
             <a:endParaRPr lang="en-US" sz="4400" dirty="0"/>
           </a:p>
@@ -2130,7 +2130,7 @@
                 <a:ea typeface="Arial" pitchFamily="34" charset="-122"/>
                 <a:cs typeface="Arial" pitchFamily="34" charset="-120"/>
               </a:rPr>
-              <a:t>Armazenamento de</a:t>
+              <a:t>no Agro: a Revolução</a:t>
             </a:r>
             <a:endParaRPr lang="en-US" sz="4400" dirty="0"/>
           </a:p>
@@ -2150,7 +2150,7 @@
                 <a:ea typeface="Arial" pitchFamily="34" charset="-122"/>
                 <a:cs typeface="Arial" pitchFamily="34" charset="-120"/>
               </a:rPr>
-              <a:t>Energia no Brasil</a:t>
+              <a:t>do Armazenamento</a:t>
             </a:r>
             <a:endParaRPr lang="en-US" sz="4400" dirty="0"/>
           </a:p>
@@ -2192,7 +2192,7 @@
                 <a:ea typeface="Arial" pitchFamily="34" charset="-122"/>
                 <a:cs typeface="Arial" pitchFamily="34" charset="-120"/>
               </a:rPr>
-              <a:t>Da viabilidade técnica à máquina de arbitragem financeira: o panorama estratégico dos Sistemas de Armazenamento de Energia por Baterias (BESS).</a:t>
+              <a:t>Como os Sistemas de Armazenamento de Energia por Baterias (BESS) transformam a energia do campo — da viabilidade técnica à máquina de arbitragem financeira.</a:t>
             </a:r>
             <a:endParaRPr lang="en-US" sz="1600" dirty="0"/>
           </a:p>
@@ -2230,7 +2230,7 @@
         <p:spPr>
           <a:xfrm>
             <a:off x="685800" y="5577840"/>
-            <a:ext cx="6400800" cy="731520"/>
+            <a:ext cx="6766560" cy="731520"/>
           </a:xfrm>
           <a:prstGeom prst="rect">
             <a:avLst/>
@@ -2271,7 +2271,7 @@
                 <a:ea typeface="Arial" pitchFamily="34" charset="-122"/>
                 <a:cs typeface="Arial" pitchFamily="34" charset="-120"/>
               </a:rPr>
-              <a:t>CREA-MT 029137  ·  2026</a:t>
+              <a:t>CREA-MT 029137  ·  Relatório Executivo de Viabilidade de Mercado  ·  2026</a:t>
             </a:r>
             <a:endParaRPr lang="en-US" sz="1700" dirty="0"/>
           </a:p>
@@ -3692,7 +3692,7 @@
                 <a:ea typeface="Arial" pitchFamily="34" charset="-122"/>
                 <a:cs typeface="Arial" pitchFamily="34" charset="-120"/>
               </a:rPr>
-              <a:t>Com custos de CAPEX em declínio, LCOE competitivo (R$ 538/MWh) e TIR na casa dos 21%, a transição para o BESS tornou-se o passo econômico mais lógico para investidores e grandes consumidores no mercado brasileiro. O momento da vantagem competitiva e tributária é o presente.</a:t>
+              <a:t>Com custos de CAPEX em declínio, LCOE competitivo (R$ 538/MWh) e TIR na casa dos 21%, a transição para o BESS tornou-se o passo econômico mais lógico para o produtor rural, cooperativas e agroindústrias — e para os investidores que os atendem. O momento da vantagem competitiva e tributária é o presente.</a:t>
             </a:r>
             <a:endParaRPr lang="en-US" sz="1300" dirty="0"/>
           </a:p>
@@ -3972,7 +3972,7 @@
                 <a:ea typeface="Arial" pitchFamily="34" charset="-122"/>
                 <a:cs typeface="Arial" pitchFamily="34" charset="-120"/>
               </a:rPr>
-              <a:t>A Revolução do Armazenamento de Energia no Brasil — panorama estratégico do BESS.</a:t>
+              <a:t>Eficiência energética no agronegócio — o papel estratégico do armazenamento de energia (BESS).</a:t>
             </a:r>
             <a:endParaRPr lang="en-US" sz="1500" dirty="0"/>
           </a:p>
@@ -4544,7 +4544,7 @@
                 <a:ea typeface="Arial" pitchFamily="34" charset="-122"/>
                 <a:cs typeface="Arial" pitchFamily="34" charset="-120"/>
               </a:rPr>
-              <a:t>O BESS transcende a função de backup: configura-se como ativo de arbitragem, capaz de mitigar o curtailment, faturar no horário de ponta e reduzir custos de demanda de grandes consumidores.</a:t>
+              <a:t>O BESS transcende a função de backup: configura-se como ativo de arbitragem, capaz de mitigar o curtailment, faturar no horário de ponta e reduzir custos de demanda — do pivô de irrigação à agroindústria.</a:t>
             </a:r>
             <a:endParaRPr lang="en-US" sz="1250" dirty="0"/>
           </a:p>
@@ -4703,7 +4703,7 @@
                 <a:ea typeface="Arial" pitchFamily="34" charset="-122"/>
                 <a:cs typeface="Arial" pitchFamily="34" charset="-120"/>
               </a:rPr>
-              <a:t>Indicadores robustos em projetos híbridos de Geração Compartilhada: TIR superior a 21% e payback inferior a 8 anos superam o custo de oportunidade do capital no Brasil.</a:t>
+              <a:t>Indicadores robustos em projetos híbridos de Geração Compartilhada — modelo com vocação natural para o agro: TIR superior a 21% e payback inferior a 8 anos superam o custo de oportunidade do capital.</a:t>
             </a:r>
             <a:endParaRPr lang="en-US" sz="1250" dirty="0"/>
           </a:p>
@@ -5040,7 +5040,7 @@
                 <a:ea typeface="Arial" pitchFamily="34" charset="-122"/>
                 <a:cs typeface="Arial" pitchFamily="34" charset="-120"/>
               </a:rPr>
-              <a:t>O BESS absorve esse excedente do meio-dia e o converte em receita no horário de ponta, transformando desperdício em resultado financeiro.</a:t>
+              <a:t>O BESS absorve esse excedente do meio-dia e o converte em receita na ponta — exatamente quando irrigação, secagem e frio industrial mais pesam na conta do produtor.</a:t>
             </a:r>
             <a:endParaRPr lang="en-US" sz="1250" dirty="0"/>
           </a:p>
@@ -5262,11 +5262,11 @@
         <p:spPr>
           <a:xfrm>
             <a:off x="548640" y="1600200"/>
-            <a:ext cx="5440680" cy="4434840"/>
+            <a:ext cx="5440680" cy="3931920"/>
           </a:xfrm>
           <a:prstGeom prst="roundRect">
             <a:avLst>
-              <a:gd name="adj" fmla="val 1856"/>
+              <a:gd name="adj" fmla="val 2093"/>
             </a:avLst>
           </a:prstGeom>
           <a:solidFill>
@@ -5395,8 +5395,8 @@
         </p:nvSpPr>
         <p:spPr>
           <a:xfrm>
-            <a:off x="868680" y="2926080"/>
-            <a:ext cx="4800600" cy="914400"/>
+            <a:off x="868680" y="2834640"/>
+            <a:ext cx="4800600" cy="804672"/>
           </a:xfrm>
           <a:prstGeom prst="rect">
             <a:avLst/>
@@ -5410,7 +5410,7 @@
           <a:p>
             <a:pPr indent="0" marL="0">
               <a:lnSpc>
-                <a:spcPct val="108000"/>
+                <a:spcPct val="106000"/>
               </a:lnSpc>
               <a:buNone/>
             </a:pPr>
@@ -5430,12 +5430,12 @@
           <a:p>
             <a:pPr indent="0" marL="0">
               <a:lnSpc>
-                <a:spcPct val="108000"/>
+                <a:spcPct val="106000"/>
               </a:lnSpc>
               <a:buNone/>
             </a:pPr>
             <a:r>
-              <a:rPr lang="en-US" sz="1250" dirty="0">
+              <a:rPr lang="en-US" sz="1200" dirty="0">
                 <a:solidFill>
                   <a:srgbClr val="3E4E59"/>
                 </a:solidFill>
@@ -5457,7 +5457,7 @@
         </p:nvSpPr>
         <p:spPr>
           <a:xfrm>
-            <a:off x="868680" y="3867912"/>
+            <a:off x="868680" y="3657600"/>
             <a:ext cx="4800600" cy="0"/>
           </a:xfrm>
           <a:prstGeom prst="line">
@@ -5480,8 +5480,8 @@
         </p:nvSpPr>
         <p:spPr>
           <a:xfrm>
-            <a:off x="868680" y="3950208"/>
-            <a:ext cx="4800600" cy="914400"/>
+            <a:off x="868680" y="3730752"/>
+            <a:ext cx="4800600" cy="804672"/>
           </a:xfrm>
           <a:prstGeom prst="rect">
             <a:avLst/>
@@ -5495,7 +5495,7 @@
           <a:p>
             <a:pPr indent="0" marL="0">
               <a:lnSpc>
-                <a:spcPct val="108000"/>
+                <a:spcPct val="106000"/>
               </a:lnSpc>
               <a:buNone/>
             </a:pPr>
@@ -5515,12 +5515,12 @@
           <a:p>
             <a:pPr indent="0" marL="0">
               <a:lnSpc>
-                <a:spcPct val="108000"/>
+                <a:spcPct val="106000"/>
               </a:lnSpc>
               <a:buNone/>
             </a:pPr>
             <a:r>
-              <a:rPr lang="en-US" sz="1250" dirty="0">
+              <a:rPr lang="en-US" sz="1200" dirty="0">
                 <a:solidFill>
                   <a:srgbClr val="3E4E59"/>
                 </a:solidFill>
@@ -5542,7 +5542,7 @@
         </p:nvSpPr>
         <p:spPr>
           <a:xfrm>
-            <a:off x="868680" y="4892040"/>
+            <a:off x="868680" y="4553712"/>
             <a:ext cx="4800600" cy="0"/>
           </a:xfrm>
           <a:prstGeom prst="line">
@@ -5565,8 +5565,8 @@
         </p:nvSpPr>
         <p:spPr>
           <a:xfrm>
-            <a:off x="868680" y="4974336"/>
-            <a:ext cx="4800600" cy="914400"/>
+            <a:off x="868680" y="4626864"/>
+            <a:ext cx="4800600" cy="804672"/>
           </a:xfrm>
           <a:prstGeom prst="rect">
             <a:avLst/>
@@ -5580,7 +5580,7 @@
           <a:p>
             <a:pPr indent="0" marL="0">
               <a:lnSpc>
-                <a:spcPct val="108000"/>
+                <a:spcPct val="106000"/>
               </a:lnSpc>
               <a:buNone/>
             </a:pPr>
@@ -5600,12 +5600,12 @@
           <a:p>
             <a:pPr indent="0" marL="0">
               <a:lnSpc>
-                <a:spcPct val="108000"/>
+                <a:spcPct val="106000"/>
               </a:lnSpc>
               <a:buNone/>
             </a:pPr>
             <a:r>
-              <a:rPr lang="en-US" sz="1250" dirty="0">
+              <a:rPr lang="en-US" sz="1200" dirty="0">
                 <a:solidFill>
                   <a:srgbClr val="3E4E59"/>
                 </a:solidFill>
@@ -5628,11 +5628,11 @@
         <p:spPr>
           <a:xfrm>
             <a:off x="6245352" y="1600200"/>
-            <a:ext cx="5440680" cy="4434840"/>
+            <a:ext cx="5440680" cy="3931920"/>
           </a:xfrm>
           <a:prstGeom prst="roundRect">
             <a:avLst>
-              <a:gd name="adj" fmla="val 1856"/>
+              <a:gd name="adj" fmla="val 2093"/>
             </a:avLst>
           </a:prstGeom>
           <a:solidFill>
@@ -5761,8 +5761,8 @@
         </p:nvSpPr>
         <p:spPr>
           <a:xfrm>
-            <a:off x="6565392" y="2926080"/>
-            <a:ext cx="4800600" cy="914400"/>
+            <a:off x="6565392" y="2834640"/>
+            <a:ext cx="4800600" cy="804672"/>
           </a:xfrm>
           <a:prstGeom prst="rect">
             <a:avLst/>
@@ -5776,7 +5776,7 @@
           <a:p>
             <a:pPr indent="0" marL="0">
               <a:lnSpc>
-                <a:spcPct val="108000"/>
+                <a:spcPct val="106000"/>
               </a:lnSpc>
               <a:buNone/>
             </a:pPr>
@@ -5796,12 +5796,12 @@
           <a:p>
             <a:pPr indent="0" marL="0">
               <a:lnSpc>
-                <a:spcPct val="108000"/>
+                <a:spcPct val="106000"/>
               </a:lnSpc>
               <a:buNone/>
             </a:pPr>
             <a:r>
-              <a:rPr lang="en-US" sz="1250" dirty="0">
+              <a:rPr lang="en-US" sz="1200" dirty="0">
                 <a:solidFill>
                   <a:srgbClr val="3E4E59"/>
                 </a:solidFill>
@@ -5823,7 +5823,7 @@
         </p:nvSpPr>
         <p:spPr>
           <a:xfrm>
-            <a:off x="6565392" y="3867912"/>
+            <a:off x="6565392" y="3657600"/>
             <a:ext cx="4800600" cy="0"/>
           </a:xfrm>
           <a:prstGeom prst="line">
@@ -5846,8 +5846,8 @@
         </p:nvSpPr>
         <p:spPr>
           <a:xfrm>
-            <a:off x="6565392" y="3950208"/>
-            <a:ext cx="4800600" cy="914400"/>
+            <a:off x="6565392" y="3730752"/>
+            <a:ext cx="4800600" cy="804672"/>
           </a:xfrm>
           <a:prstGeom prst="rect">
             <a:avLst/>
@@ -5861,7 +5861,7 @@
           <a:p>
             <a:pPr indent="0" marL="0">
               <a:lnSpc>
-                <a:spcPct val="108000"/>
+                <a:spcPct val="106000"/>
               </a:lnSpc>
               <a:buNone/>
             </a:pPr>
@@ -5881,12 +5881,12 @@
           <a:p>
             <a:pPr indent="0" marL="0">
               <a:lnSpc>
-                <a:spcPct val="108000"/>
+                <a:spcPct val="106000"/>
               </a:lnSpc>
               <a:buNone/>
             </a:pPr>
             <a:r>
-              <a:rPr lang="en-US" sz="1250" dirty="0">
+              <a:rPr lang="en-US" sz="1200" dirty="0">
                 <a:solidFill>
                   <a:srgbClr val="3E4E59"/>
                 </a:solidFill>
@@ -5908,7 +5908,7 @@
         </p:nvSpPr>
         <p:spPr>
           <a:xfrm>
-            <a:off x="6565392" y="4892040"/>
+            <a:off x="6565392" y="4553712"/>
             <a:ext cx="4800600" cy="0"/>
           </a:xfrm>
           <a:prstGeom prst="line">
@@ -5931,8 +5931,8 @@
         </p:nvSpPr>
         <p:spPr>
           <a:xfrm>
-            <a:off x="6565392" y="4974336"/>
-            <a:ext cx="4800600" cy="914400"/>
+            <a:off x="6565392" y="4626864"/>
+            <a:ext cx="4800600" cy="804672"/>
           </a:xfrm>
           <a:prstGeom prst="rect">
             <a:avLst/>
@@ -5946,7 +5946,7 @@
           <a:p>
             <a:pPr indent="0" marL="0">
               <a:lnSpc>
-                <a:spcPct val="108000"/>
+                <a:spcPct val="106000"/>
               </a:lnSpc>
               <a:buNone/>
             </a:pPr>
@@ -5966,12 +5966,12 @@
           <a:p>
             <a:pPr indent="0" marL="0">
               <a:lnSpc>
-                <a:spcPct val="108000"/>
+                <a:spcPct val="106000"/>
               </a:lnSpc>
               <a:buNone/>
             </a:pPr>
             <a:r>
-              <a:rPr lang="en-US" sz="1250" dirty="0">
+              <a:rPr lang="en-US" sz="1200" dirty="0">
                 <a:solidFill>
                   <a:srgbClr val="3E4E59"/>
                 </a:solidFill>
@@ -5987,7 +5987,82 @@
       </p:sp>
       <p:sp>
         <p:nvSpPr>
-          <p:cNvPr id="22" name="Text 17"/>
+          <p:cNvPr id="21" name="Shape 17"/>
+          <p:cNvSpPr/>
+          <p:nvPr/>
+        </p:nvSpPr>
+        <p:spPr>
+          <a:xfrm>
+            <a:off x="548640" y="5742432"/>
+            <a:ext cx="11091672" cy="566928"/>
+          </a:xfrm>
+          <a:prstGeom prst="roundRect">
+            <a:avLst>
+              <a:gd name="adj" fmla="val 12903"/>
+            </a:avLst>
+          </a:prstGeom>
+          <a:solidFill>
+            <a:srgbClr val="EAF1F6"/>
+          </a:solidFill>
+          <a:ln/>
+        </p:spPr>
+      </p:sp>
+      <p:sp>
+        <p:nvSpPr>
+          <p:cNvPr id="22" name="Text 18"/>
+          <p:cNvSpPr/>
+          <p:nvPr/>
+        </p:nvSpPr>
+        <p:spPr>
+          <a:xfrm>
+            <a:off x="777240" y="5742432"/>
+            <a:ext cx="10698480" cy="566928"/>
+          </a:xfrm>
+          <a:prstGeom prst="rect">
+            <a:avLst/>
+          </a:prstGeom>
+          <a:noFill/>
+          <a:ln/>
+        </p:spPr>
+        <p:txBody>
+          <a:bodyPr wrap="square" lIns="0" tIns="0" rIns="0" bIns="0" rtlCol="0" anchor="ctr"/>
+          <a:lstStyle/>
+          <a:p>
+            <a:pPr indent="0" marL="0">
+              <a:buNone/>
+            </a:pPr>
+            <a:r>
+              <a:rPr lang="en-US" sz="1200" b="1" dirty="0">
+                <a:solidFill>
+                  <a:srgbClr val="16303F"/>
+                </a:solidFill>
+                <a:latin typeface="Arial" pitchFamily="34" charset="0"/>
+                <a:ea typeface="Arial" pitchFamily="34" charset="-122"/>
+                <a:cs typeface="Arial" pitchFamily="34" charset="-120"/>
+              </a:rPr>
+              <a:t>No agro:  </a:t>
+            </a:r>
+            <a:pPr indent="0" marL="0">
+              <a:buNone/>
+            </a:pPr>
+            <a:r>
+              <a:rPr lang="en-US" sz="1200" dirty="0">
+                <a:solidFill>
+                  <a:srgbClr val="3E4E59"/>
+                </a:solidFill>
+                <a:latin typeface="Arial" pitchFamily="34" charset="0"/>
+                <a:ea typeface="Arial" pitchFamily="34" charset="-122"/>
+                <a:cs typeface="Arial" pitchFamily="34" charset="-120"/>
+              </a:rPr>
+              <a:t>deslocar bombeamento e irrigação para o vazio (Time Shifting) e absorver os picos de motores, secadores e câmaras frias (Peak Shaving) — eficiência energética direto na margem.</a:t>
+            </a:r>
+            <a:endParaRPr lang="en-US" sz="1200" dirty="0"/>
+          </a:p>
+        </p:txBody>
+      </p:sp>
+      <p:sp>
+        <p:nvSpPr>
+          <p:cNvPr id="24" name="Text 19"/>
           <p:cNvSpPr/>
           <p:nvPr/>
         </p:nvSpPr>
@@ -6026,7 +6101,7 @@
       </p:sp>
       <p:sp>
         <p:nvSpPr>
-          <p:cNvPr id="23" name="Text 18"/>
+          <p:cNvPr id="25" name="Text 20"/>
           <p:cNvSpPr/>
           <p:nvPr/>
         </p:nvSpPr>
@@ -6393,7 +6468,7 @@
                 <a:ea typeface="Arial" pitchFamily="34" charset="-122"/>
                 <a:cs typeface="Arial" pitchFamily="34" charset="-120"/>
               </a:rPr>
-              <a:t>Permite a união de interessados via consórcio, cooperativa ou associação para compartilhar créditos de energia de uma UFV de até 3 MW.</a:t>
+              <a:t>Permite a união de interessados via consórcio, cooperativa ou associação — arranjo natural para cooperativas e associações de produtores rurais — para compartilhar créditos de uma UFV de até 3 MW.</a:t>
             </a:r>
             <a:endParaRPr lang="en-US" sz="1250" dirty="0"/>
           </a:p>
@@ -7680,7 +7755,7 @@
                 <a:ea typeface="Arial" pitchFamily="34" charset="-122"/>
                 <a:cs typeface="Arial" pitchFamily="34" charset="-120"/>
               </a:rPr>
-              <a:t>Clientes consorciados (ex.: Grupo B3) pagam o aluguel da cota com desconto atrativo (ex.: 27%).</a:t>
+              <a:t>Produtores rurais e agroindústrias consorciados (Grupo B3) pagam o aluguel da cota com desconto atrativo (ex.: 27%).</a:t>
             </a:r>
             <a:endParaRPr lang="en-US" sz="1050" dirty="0"/>
           </a:p>

</xml_diff>

<commit_message>
Adota cenário agro otimizado com payback de ~5 anos na apresentação BESS
Fundamenta o payback de ~5 anos com pesquisa de mercado e adiciona novo
slide 'Irrigação Bombeada: as alavancas do payback': desconto noturno do
irrigante (60-90%, Lei 10.438/2002 e REN ANEEL 1.000/2021), baterias
financiáveis no Plano Safra 2026/27 (juros 8-12,5% a.a.) e benchmarks de
payback de 5-6 anos em GD com baterias. Atualiza dashboard (TIR 28%,
VPL R$ 11,1 mi, mantendo o cenário base como referência) e a curva de
break-even com virada no ano 5. Total: 14 slides.

Co-Authored-By: Claude Fable 5 <noreply@anthropic.com>
Claude-Session: https://claude.ai/code/session_0198SeXLUYPhAzabpjaRsyNb
</commit_message>
<xml_diff>
--- a/apresentacoes/BESS_Brasil_Lucas_Silva_Costa.pptx
+++ b/apresentacoes/BESS_Brasil_Lucas_Silva_Costa.pptx
@@ -18,9 +18,10 @@
     <p:sldId id="266" r:id="rId12"/>
     <p:sldId id="267" r:id="rId13"/>
     <p:sldId id="268" r:id="rId14"/>
+    <p:sldId id="269" r:id="rId15"/>
   </p:sldIdLst>
   <p:notesMasterIdLst>
-    <p:notesMasterId r:id="rId15"/>
+    <p:notesMasterId r:id="rId16"/>
   </p:notesMasterIdLst>
   <p:sldSz cx="12192000" cy="6858000"/>
   <p:notesSz cx="6858000" cy="12192000"/>
@@ -602,7 +603,7 @@
           <a:p>
             <a:r>
               <a:rPr lang="en-US" dirty="0"/>
-              <a:t>Barras escuras: capital ainda não recuperado (anos 0 a 8). Barras azuis: VPL positivo do ano 9 em diante, encerrando em R$ 6,37 mi.</a:t>
+              <a:t>As três alavancas que levam o payback de 7a9m para ~5 anos: desconto noturno do irrigante (60-90%), crédito subsidiado do Plano Safra 2026/27 e benchmarks de mercado (5-6 anos em GD+BESS).</a:t>
             </a:r>
             <a:endParaRPr lang="en-US" dirty="0"/>
           </a:p>
@@ -690,7 +691,7 @@
           <a:p>
             <a:r>
               <a:rPr lang="en-US" dirty="0"/>
-              <a:t>O BESS não é para todos: agronegócio e indústria com carga volátil capturam valor; cargas flat como data centers, não.</a:t>
+              <a:t>Barras escuras: capital ainda não recuperado (anos 0 a 5). Barras azuis: VPL positivo do ano 6 em diante, encerrando em R$ 11,1 mi no cenário agro otimizado.</a:t>
             </a:r>
             <a:endParaRPr lang="en-US" dirty="0"/>
           </a:p>
@@ -778,7 +779,7 @@
           <a:p>
             <a:r>
               <a:rPr lang="en-US" dirty="0"/>
-              <a:t>Fechamento conceitual: o BESS converte intermitência em previsibilidade financeira. Chamada à ação: o momento é agora.</a:t>
+              <a:t>O BESS não é para todos: agronegócio e indústria com carga volátil capturam valor; cargas flat como data centers, não.</a:t>
             </a:r>
             <a:endParaRPr lang="en-US" dirty="0"/>
           </a:p>
@@ -866,7 +867,7 @@
           <a:p>
             <a:r>
               <a:rPr lang="en-US" dirty="0"/>
-              <a:t>Slide de encerramento com identificação do autor responsável.</a:t>
+              <a:t>Fechamento conceitual: o BESS converte intermitência em previsibilidade financeira. Chamada à ação: o momento é agora.</a:t>
             </a:r>
             <a:endParaRPr lang="en-US" dirty="0"/>
           </a:p>
@@ -890,6 +891,94 @@
             <a:fld id="{F7021451-1387-4CA6-816F-3879F97B5CBC}" type="slidenum">
               <a:rPr lang="en-US"/>
               <a:t>13</a:t>
+            </a:fld>
+            <a:endParaRPr lang="en-US"/>
+          </a:p>
+        </p:txBody>
+      </p:sp>
+    </p:spTree>
+    <p:extLst>
+      <p:ext uri="{BB962C8B-B14F-4D97-AF65-F5344CB8AC3E}">
+        <p14:creationId xmlns:p14="http://schemas.microsoft.com/office/powerpoint/2010/main" val="1024086991"/>
+      </p:ext>
+    </p:extLst>
+  </p:cSld>
+  <p:clrMapOvr>
+    <a:masterClrMapping/>
+  </p:clrMapOvr>
+</p:notes>
+</file>
+
+<file path=ppt/notesSlides/notesSlide14.xml><?xml version="1.0" encoding="utf-8"?>
+<p:notes xmlns:a="http://schemas.openxmlformats.org/drawingml/2006/main" xmlns:r="http://schemas.openxmlformats.org/officeDocument/2006/relationships" xmlns:p="http://schemas.openxmlformats.org/presentationml/2006/main">
+  <p:cSld>
+    <p:spTree>
+      <p:nvGrpSpPr>
+        <p:cNvPr id="1" name=""/>
+        <p:cNvGrpSpPr/>
+        <p:nvPr/>
+      </p:nvGrpSpPr>
+      <p:grpSpPr>
+        <a:xfrm>
+          <a:off x="0" y="0"/>
+          <a:ext cx="0" cy="0"/>
+          <a:chOff x="0" y="0"/>
+          <a:chExt cx="0" cy="0"/>
+        </a:xfrm>
+      </p:grpSpPr>
+      <p:sp>
+        <p:nvSpPr>
+          <p:cNvPr id="2" name="Slide Image Placeholder 1"/>
+          <p:cNvSpPr>
+            <a:spLocks noGrp="1" noRot="1" noChangeAspect="1"/>
+          </p:cNvSpPr>
+          <p:nvPr>
+            <p:ph type="sldImg"/>
+          </p:nvPr>
+        </p:nvSpPr>
+        <p:spPr/>
+      </p:sp>
+      <p:sp>
+        <p:nvSpPr>
+          <p:cNvPr id="3" name="Notes Placeholder 2"/>
+          <p:cNvSpPr>
+            <a:spLocks noGrp="1"/>
+          </p:cNvSpPr>
+          <p:nvPr>
+            <p:ph type="body" idx="1"/>
+          </p:nvPr>
+        </p:nvSpPr>
+        <p:spPr/>
+        <p:txBody>
+          <a:bodyPr/>
+          <a:lstStyle/>
+          <a:p>
+            <a:r>
+              <a:rPr lang="en-US" dirty="0"/>
+              <a:t>Slide de encerramento com identificação do autor responsável.</a:t>
+            </a:r>
+            <a:endParaRPr lang="en-US" dirty="0"/>
+          </a:p>
+        </p:txBody>
+      </p:sp>
+      <p:sp>
+        <p:nvSpPr>
+          <p:cNvPr id="4" name="Slide Number Placeholder 3"/>
+          <p:cNvSpPr>
+            <a:spLocks noGrp="1"/>
+          </p:cNvSpPr>
+          <p:nvPr>
+            <p:ph type="sldNum" sz="quarter" idx="10"/>
+          </p:nvPr>
+        </p:nvSpPr>
+        <p:spPr/>
+        <p:txBody>
+          <a:bodyPr/>
+          <a:lstStyle/>
+          <a:p>
+            <a:fld id="{F7021451-1387-4CA6-816F-3879F97B5CBC}" type="slidenum">
+              <a:rPr lang="en-US"/>
+              <a:t>14</a:t>
             </a:fld>
             <a:endParaRPr lang="en-US"/>
           </a:p>
@@ -1570,7 +1659,7 @@
           <a:p>
             <a:r>
               <a:rPr lang="en-US" dirty="0"/>
-              <a:t>Tríade de indicadores: TIR 21%, payback 7a9m, VPL R$ 6,37 mi. Spread de ~R$ 256/MWh entre LCOE e preço da cota sustenta o modelo.</a:t>
+              <a:t>Cenário agro otimizado: TIR 28%, payback ~5 anos, VPL R$ 11,1 mi (base: 21% / 7a9m / R$ 6,37 mi). Spread de ~R$ 256/MWh entre LCOE e preço da cota sustenta o modelo; o slide seguinte detalha as alavancas.</a:t>
             </a:r>
             <a:endParaRPr lang="en-US" dirty="0"/>
           </a:p>
@@ -2342,15 +2431,69 @@
                 <a:ea typeface="Arial" pitchFamily="34" charset="-122"/>
                 <a:cs typeface="Arial" pitchFamily="34" charset="-120"/>
               </a:rPr>
-              <a:t>A Trajetória de Recuperação do Capital  |  break-even</a:t>
+              <a:t>Irrigação Bombeada: as alavancas do payback de ≈ 5 anos</a:t>
             </a:r>
             <a:endParaRPr lang="en-US" sz="3000" dirty="0"/>
           </a:p>
         </p:txBody>
+      </p:sp>
+      <p:sp>
+        <p:nvSpPr>
+          <p:cNvPr id="3" name="Shape 1"/>
+          <p:cNvSpPr/>
+          <p:nvPr/>
+        </p:nvSpPr>
+        <p:spPr>
+          <a:xfrm>
+            <a:off x="548640" y="1463040"/>
+            <a:ext cx="3593592" cy="3794760"/>
+          </a:xfrm>
+          <a:prstGeom prst="roundRect">
+            <a:avLst>
+              <a:gd name="adj" fmla="val 2290"/>
+            </a:avLst>
+          </a:prstGeom>
+          <a:solidFill>
+            <a:srgbClr val="F5F8FA"/>
+          </a:solidFill>
+          <a:ln w="9525">
+            <a:solidFill>
+              <a:srgbClr val="D9E2E8"/>
+            </a:solidFill>
+            <a:prstDash val="solid"/>
+          </a:ln>
+          <a:effectLst>
+            <a:outerShdw sx="100000" sy="100000" kx="0" ky="0" algn="bl" rotWithShape="0" blurRad="88900" dist="25400" dir="5400000">
+              <a:srgbClr val="9AAAB4">
+                <a:alpha val="35000"/>
+              </a:srgbClr>
+            </a:outerShdw>
+          </a:effectLst>
+        </p:spPr>
+      </p:sp>
+      <p:sp>
+        <p:nvSpPr>
+          <p:cNvPr id="4" name="Shape 2"/>
+          <p:cNvSpPr/>
+          <p:nvPr/>
+        </p:nvSpPr>
+        <p:spPr>
+          <a:xfrm>
+            <a:off x="841248" y="1737360"/>
+            <a:ext cx="548640" cy="548640"/>
+          </a:xfrm>
+          <a:prstGeom prst="ellipse">
+            <a:avLst/>
+          </a:prstGeom>
+          <a:solidFill>
+            <a:srgbClr val="F2B705"/>
+          </a:solidFill>
+          <a:ln/>
+        </p:spPr>
       </p:sp>
       <p:pic>
         <p:nvPicPr>
-          <p:cNvPr id="3" name="Image 0" descr="chart10.png">    </p:cNvPr>
+          <p:cNvPr id="5" name="Image 0" descr="preencoded.png">    </p:cNvPr>
           <p:cNvPicPr>
             <a:picLocks noChangeAspect="1"/>
           </p:cNvPicPr>
@@ -2364,8 +2507,8 @@
         </p:blipFill>
         <p:spPr>
           <a:xfrm>
-            <a:off x="685800" y="1417320"/>
-            <a:ext cx="10835640" cy="4160520"/>
+            <a:off x="961949" y="1858061"/>
+            <a:ext cx="307238" cy="307238"/>
           </a:xfrm>
           <a:prstGeom prst="rect">
             <a:avLst/>
@@ -2374,14 +2517,422 @@
       </p:pic>
       <p:sp>
         <p:nvSpPr>
-          <p:cNvPr id="4" name="Shape 1"/>
-          <p:cNvSpPr/>
-          <p:nvPr/>
-        </p:nvSpPr>
-        <p:spPr>
-          <a:xfrm>
-            <a:off x="685800" y="5760720"/>
-            <a:ext cx="10835640" cy="566928"/>
+          <p:cNvPr id="6" name="Text 3"/>
+          <p:cNvSpPr/>
+          <p:nvPr/>
+        </p:nvSpPr>
+        <p:spPr>
+          <a:xfrm>
+            <a:off x="841248" y="2423160"/>
+            <a:ext cx="3008376" cy="658368"/>
+          </a:xfrm>
+          <a:prstGeom prst="rect">
+            <a:avLst/>
+          </a:prstGeom>
+          <a:noFill/>
+          <a:ln/>
+        </p:spPr>
+        <p:txBody>
+          <a:bodyPr wrap="square" lIns="0" tIns="0" rIns="0" bIns="0" rtlCol="0" anchor="t"/>
+          <a:lstStyle/>
+          <a:p>
+            <a:pPr indent="0" marL="0">
+              <a:lnSpc>
+                <a:spcPct val="102000"/>
+              </a:lnSpc>
+              <a:buNone/>
+            </a:pPr>
+            <a:r>
+              <a:rPr lang="en-US" sz="1650" b="1" dirty="0">
+                <a:solidFill>
+                  <a:srgbClr val="16303F"/>
+                </a:solidFill>
+                <a:latin typeface="Arial" pitchFamily="34" charset="0"/>
+                <a:ea typeface="Arial" pitchFamily="34" charset="-122"/>
+                <a:cs typeface="Arial" pitchFamily="34" charset="-120"/>
+              </a:rPr>
+              <a:t>Horário reservado do irrigante</a:t>
+            </a:r>
+            <a:endParaRPr lang="en-US" sz="1650" dirty="0"/>
+          </a:p>
+        </p:txBody>
+      </p:sp>
+      <p:sp>
+        <p:nvSpPr>
+          <p:cNvPr id="7" name="Text 4"/>
+          <p:cNvSpPr/>
+          <p:nvPr/>
+        </p:nvSpPr>
+        <p:spPr>
+          <a:xfrm>
+            <a:off x="841248" y="3127248"/>
+            <a:ext cx="3008376" cy="1874520"/>
+          </a:xfrm>
+          <a:prstGeom prst="rect">
+            <a:avLst/>
+          </a:prstGeom>
+          <a:noFill/>
+          <a:ln/>
+        </p:spPr>
+        <p:txBody>
+          <a:bodyPr wrap="square" lIns="0" tIns="0" rIns="0" bIns="0" rtlCol="0" anchor="t"/>
+          <a:lstStyle/>
+          <a:p>
+            <a:pPr indent="0" marL="0">
+              <a:lnSpc>
+                <a:spcPct val="110000"/>
+              </a:lnSpc>
+              <a:buNone/>
+            </a:pPr>
+            <a:r>
+              <a:rPr lang="en-US" sz="1150" dirty="0">
+                <a:solidFill>
+                  <a:srgbClr val="3E4E59"/>
+                </a:solidFill>
+                <a:latin typeface="Arial" pitchFamily="34" charset="0"/>
+                <a:ea typeface="Arial" pitchFamily="34" charset="-122"/>
+                <a:cs typeface="Arial" pitchFamily="34" charset="-120"/>
+              </a:rPr>
+              <a:t>A Lei nº 10.438/2002 e a REN ANEEL nº 1.000/2021 garantem de 60% a 90% de desconto na tarifa entre 21h30 e 6h. O BESS concentra o bombeamento nessa janela e carrega barato para sustentar a operação na ponta.</a:t>
+            </a:r>
+            <a:endParaRPr lang="en-US" sz="1150" dirty="0"/>
+          </a:p>
+        </p:txBody>
+      </p:sp>
+      <p:sp>
+        <p:nvSpPr>
+          <p:cNvPr id="8" name="Shape 5"/>
+          <p:cNvSpPr/>
+          <p:nvPr/>
+        </p:nvSpPr>
+        <p:spPr>
+          <a:xfrm>
+            <a:off x="4370832" y="1463040"/>
+            <a:ext cx="3593592" cy="3794760"/>
+          </a:xfrm>
+          <a:prstGeom prst="roundRect">
+            <a:avLst>
+              <a:gd name="adj" fmla="val 2290"/>
+            </a:avLst>
+          </a:prstGeom>
+          <a:solidFill>
+            <a:srgbClr val="F5F8FA"/>
+          </a:solidFill>
+          <a:ln w="9525">
+            <a:solidFill>
+              <a:srgbClr val="D9E2E8"/>
+            </a:solidFill>
+            <a:prstDash val="solid"/>
+          </a:ln>
+          <a:effectLst>
+            <a:outerShdw sx="100000" sy="100000" kx="0" ky="0" algn="bl" rotWithShape="0" blurRad="88900" dist="25400" dir="5400000">
+              <a:srgbClr val="9AAAB4">
+                <a:alpha val="35000"/>
+              </a:srgbClr>
+            </a:outerShdw>
+          </a:effectLst>
+        </p:spPr>
+      </p:sp>
+      <p:sp>
+        <p:nvSpPr>
+          <p:cNvPr id="9" name="Shape 6"/>
+          <p:cNvSpPr/>
+          <p:nvPr/>
+        </p:nvSpPr>
+        <p:spPr>
+          <a:xfrm>
+            <a:off x="4663440" y="1737360"/>
+            <a:ext cx="548640" cy="548640"/>
+          </a:xfrm>
+          <a:prstGeom prst="ellipse">
+            <a:avLst/>
+          </a:prstGeom>
+          <a:solidFill>
+            <a:srgbClr val="F2B705"/>
+          </a:solidFill>
+          <a:ln/>
+        </p:spPr>
+      </p:sp>
+      <p:pic>
+        <p:nvPicPr>
+          <p:cNvPr id="10" name="Image 1" descr="preencoded.png">    </p:cNvPr>
+          <p:cNvPicPr>
+            <a:picLocks noChangeAspect="1"/>
+          </p:cNvPicPr>
+          <p:nvPr/>
+        </p:nvPicPr>
+        <p:blipFill>
+          <a:blip r:embed="rId2"/>
+          <a:stretch>
+            <a:fillRect/>
+          </a:stretch>
+        </p:blipFill>
+        <p:spPr>
+          <a:xfrm>
+            <a:off x="4784141" y="1858061"/>
+            <a:ext cx="307238" cy="307238"/>
+          </a:xfrm>
+          <a:prstGeom prst="rect">
+            <a:avLst/>
+          </a:prstGeom>
+        </p:spPr>
+      </p:pic>
+      <p:sp>
+        <p:nvSpPr>
+          <p:cNvPr id="11" name="Text 7"/>
+          <p:cNvSpPr/>
+          <p:nvPr/>
+        </p:nvSpPr>
+        <p:spPr>
+          <a:xfrm>
+            <a:off x="4663440" y="2423160"/>
+            <a:ext cx="3008376" cy="658368"/>
+          </a:xfrm>
+          <a:prstGeom prst="rect">
+            <a:avLst/>
+          </a:prstGeom>
+          <a:noFill/>
+          <a:ln/>
+        </p:spPr>
+        <p:txBody>
+          <a:bodyPr wrap="square" lIns="0" tIns="0" rIns="0" bIns="0" rtlCol="0" anchor="t"/>
+          <a:lstStyle/>
+          <a:p>
+            <a:pPr indent="0" marL="0">
+              <a:lnSpc>
+                <a:spcPct val="102000"/>
+              </a:lnSpc>
+              <a:buNone/>
+            </a:pPr>
+            <a:r>
+              <a:rPr lang="en-US" sz="1650" b="1" dirty="0">
+                <a:solidFill>
+                  <a:srgbClr val="16303F"/>
+                </a:solidFill>
+                <a:latin typeface="Arial" pitchFamily="34" charset="0"/>
+                <a:ea typeface="Arial" pitchFamily="34" charset="-122"/>
+                <a:cs typeface="Arial" pitchFamily="34" charset="-120"/>
+              </a:rPr>
+              <a:t>Crédito rural do Plano Safra 2026/27</a:t>
+            </a:r>
+            <a:endParaRPr lang="en-US" sz="1650" dirty="0"/>
+          </a:p>
+        </p:txBody>
+      </p:sp>
+      <p:sp>
+        <p:nvSpPr>
+          <p:cNvPr id="12" name="Text 8"/>
+          <p:cNvSpPr/>
+          <p:nvPr/>
+        </p:nvSpPr>
+        <p:spPr>
+          <a:xfrm>
+            <a:off x="4663440" y="3127248"/>
+            <a:ext cx="3008376" cy="1874520"/>
+          </a:xfrm>
+          <a:prstGeom prst="rect">
+            <a:avLst/>
+          </a:prstGeom>
+          <a:noFill/>
+          <a:ln/>
+        </p:spPr>
+        <p:txBody>
+          <a:bodyPr wrap="square" lIns="0" tIns="0" rIns="0" bIns="0" rtlCol="0" anchor="t"/>
+          <a:lstStyle/>
+          <a:p>
+            <a:pPr indent="0" marL="0">
+              <a:lnSpc>
+                <a:spcPct val="110000"/>
+              </a:lnSpc>
+              <a:buNone/>
+            </a:pPr>
+            <a:r>
+              <a:rPr lang="en-US" sz="1150" dirty="0">
+                <a:solidFill>
+                  <a:srgbClr val="3E4E59"/>
+                </a:solidFill>
+                <a:latin typeface="Arial" pitchFamily="34" charset="0"/>
+                <a:ea typeface="Arial" pitchFamily="34" charset="-122"/>
+                <a:cs typeface="Arial" pitchFamily="34" charset="-120"/>
+              </a:rPr>
+              <a:t>Pela primeira vez, baterias são financiáveis no crédito rural (InvestAgro, Inovagro e Prodecoop), com juros de 8% a 12,5% a.a. — abaixo da TMA de 15%, acelerando o retorno sobre o capital próprio.</a:t>
+            </a:r>
+            <a:endParaRPr lang="en-US" sz="1150" dirty="0"/>
+          </a:p>
+        </p:txBody>
+      </p:sp>
+      <p:sp>
+        <p:nvSpPr>
+          <p:cNvPr id="13" name="Shape 9"/>
+          <p:cNvSpPr/>
+          <p:nvPr/>
+        </p:nvSpPr>
+        <p:spPr>
+          <a:xfrm>
+            <a:off x="8193024" y="1463040"/>
+            <a:ext cx="3593592" cy="3794760"/>
+          </a:xfrm>
+          <a:prstGeom prst="roundRect">
+            <a:avLst>
+              <a:gd name="adj" fmla="val 2290"/>
+            </a:avLst>
+          </a:prstGeom>
+          <a:solidFill>
+            <a:srgbClr val="F5F8FA"/>
+          </a:solidFill>
+          <a:ln w="9525">
+            <a:solidFill>
+              <a:srgbClr val="D9E2E8"/>
+            </a:solidFill>
+            <a:prstDash val="solid"/>
+          </a:ln>
+          <a:effectLst>
+            <a:outerShdw sx="100000" sy="100000" kx="0" ky="0" algn="bl" rotWithShape="0" blurRad="88900" dist="25400" dir="5400000">
+              <a:srgbClr val="9AAAB4">
+                <a:alpha val="35000"/>
+              </a:srgbClr>
+            </a:outerShdw>
+          </a:effectLst>
+        </p:spPr>
+      </p:sp>
+      <p:sp>
+        <p:nvSpPr>
+          <p:cNvPr id="14" name="Shape 10"/>
+          <p:cNvSpPr/>
+          <p:nvPr/>
+        </p:nvSpPr>
+        <p:spPr>
+          <a:xfrm>
+            <a:off x="8485632" y="1737360"/>
+            <a:ext cx="548640" cy="548640"/>
+          </a:xfrm>
+          <a:prstGeom prst="ellipse">
+            <a:avLst/>
+          </a:prstGeom>
+          <a:solidFill>
+            <a:srgbClr val="F2B705"/>
+          </a:solidFill>
+          <a:ln/>
+        </p:spPr>
+      </p:sp>
+      <p:pic>
+        <p:nvPicPr>
+          <p:cNvPr id="15" name="Image 2" descr="preencoded.png">    </p:cNvPr>
+          <p:cNvPicPr>
+            <a:picLocks noChangeAspect="1"/>
+          </p:cNvPicPr>
+          <p:nvPr/>
+        </p:nvPicPr>
+        <p:blipFill>
+          <a:blip r:embed="rId3"/>
+          <a:stretch>
+            <a:fillRect/>
+          </a:stretch>
+        </p:blipFill>
+        <p:spPr>
+          <a:xfrm>
+            <a:off x="8606333" y="1858061"/>
+            <a:ext cx="307238" cy="307238"/>
+          </a:xfrm>
+          <a:prstGeom prst="rect">
+            <a:avLst/>
+          </a:prstGeom>
+        </p:spPr>
+      </p:pic>
+      <p:sp>
+        <p:nvSpPr>
+          <p:cNvPr id="16" name="Text 11"/>
+          <p:cNvSpPr/>
+          <p:nvPr/>
+        </p:nvSpPr>
+        <p:spPr>
+          <a:xfrm>
+            <a:off x="8485632" y="2423160"/>
+            <a:ext cx="3008376" cy="658368"/>
+          </a:xfrm>
+          <a:prstGeom prst="rect">
+            <a:avLst/>
+          </a:prstGeom>
+          <a:noFill/>
+          <a:ln/>
+        </p:spPr>
+        <p:txBody>
+          <a:bodyPr wrap="square" lIns="0" tIns="0" rIns="0" bIns="0" rtlCol="0" anchor="t"/>
+          <a:lstStyle/>
+          <a:p>
+            <a:pPr indent="0" marL="0">
+              <a:lnSpc>
+                <a:spcPct val="102000"/>
+              </a:lnSpc>
+              <a:buNone/>
+            </a:pPr>
+            <a:r>
+              <a:rPr lang="en-US" sz="1650" b="1" dirty="0">
+                <a:solidFill>
+                  <a:srgbClr val="16303F"/>
+                </a:solidFill>
+                <a:latin typeface="Arial" pitchFamily="34" charset="0"/>
+                <a:ea typeface="Arial" pitchFamily="34" charset="-122"/>
+                <a:cs typeface="Arial" pitchFamily="34" charset="-120"/>
+              </a:rPr>
+              <a:t>Payback validado pelo mercado</a:t>
+            </a:r>
+            <a:endParaRPr lang="en-US" sz="1650" dirty="0"/>
+          </a:p>
+        </p:txBody>
+      </p:sp>
+      <p:sp>
+        <p:nvSpPr>
+          <p:cNvPr id="17" name="Text 12"/>
+          <p:cNvSpPr/>
+          <p:nvPr/>
+        </p:nvSpPr>
+        <p:spPr>
+          <a:xfrm>
+            <a:off x="8485632" y="3127248"/>
+            <a:ext cx="3008376" cy="1874520"/>
+          </a:xfrm>
+          <a:prstGeom prst="rect">
+            <a:avLst/>
+          </a:prstGeom>
+          <a:noFill/>
+          <a:ln/>
+        </p:spPr>
+        <p:txBody>
+          <a:bodyPr wrap="square" lIns="0" tIns="0" rIns="0" bIns="0" rtlCol="0" anchor="t"/>
+          <a:lstStyle/>
+          <a:p>
+            <a:pPr indent="0" marL="0">
+              <a:lnSpc>
+                <a:spcPct val="110000"/>
+              </a:lnSpc>
+              <a:buNone/>
+            </a:pPr>
+            <a:r>
+              <a:rPr lang="en-US" sz="1150" dirty="0">
+                <a:solidFill>
+                  <a:srgbClr val="3E4E59"/>
+                </a:solidFill>
+                <a:latin typeface="Arial" pitchFamily="34" charset="0"/>
+                <a:ea typeface="Arial" pitchFamily="34" charset="-122"/>
+                <a:cs typeface="Arial" pitchFamily="34" charset="-120"/>
+              </a:rPr>
+              <a:t>Integradores e estudos de mercado já reportam payback de 5 a 6 anos em geração distribuída com baterias — e de 3 a 7 anos em solar para irrigação, com casos de pivôs no Cerrado e no MATOPIBA.</a:t>
+            </a:r>
+            <a:endParaRPr lang="en-US" sz="1150" dirty="0"/>
+          </a:p>
+        </p:txBody>
+      </p:sp>
+      <p:sp>
+        <p:nvSpPr>
+          <p:cNvPr id="18" name="Shape 13"/>
+          <p:cNvSpPr/>
+          <p:nvPr/>
+        </p:nvSpPr>
+        <p:spPr>
+          <a:xfrm>
+            <a:off x="548640" y="5486400"/>
+            <a:ext cx="11091672" cy="566928"/>
           </a:xfrm>
           <a:prstGeom prst="roundRect">
             <a:avLst>
@@ -2396,14 +2947,14 @@
       </p:sp>
       <p:sp>
         <p:nvSpPr>
-          <p:cNvPr id="5" name="Text 2"/>
-          <p:cNvSpPr/>
-          <p:nvPr/>
-        </p:nvSpPr>
-        <p:spPr>
-          <a:xfrm>
-            <a:off x="914400" y="5760720"/>
-            <a:ext cx="10378440" cy="566928"/>
+          <p:cNvPr id="19" name="Text 14"/>
+          <p:cNvSpPr/>
+          <p:nvPr/>
+        </p:nvSpPr>
+        <p:spPr>
+          <a:xfrm>
+            <a:off x="777240" y="5486400"/>
+            <a:ext cx="10698480" cy="566928"/>
           </a:xfrm>
           <a:prstGeom prst="rect">
             <a:avLst/>
@@ -2419,7 +2970,7 @@
               <a:buNone/>
             </a:pPr>
             <a:r>
-              <a:rPr lang="en-US" sz="1200" b="1" dirty="0">
+              <a:rPr lang="en-US" sz="1250" b="1" dirty="0">
                 <a:solidFill>
                   <a:srgbClr val="16303F"/>
                 </a:solidFill>
@@ -2427,13 +2978,13 @@
                 <a:ea typeface="Arial" pitchFamily="34" charset="-122"/>
                 <a:cs typeface="Arial" pitchFamily="34" charset="-120"/>
               </a:rPr>
-              <a:t>Ponto de virada financeiro:  </a:t>
+              <a:t>Escala do prêmio:  </a:t>
             </a:r>
             <a:pPr indent="0" marL="0">
               <a:buNone/>
             </a:pPr>
             <a:r>
-              <a:rPr lang="en-US" sz="1200" dirty="0">
+              <a:rPr lang="en-US" sz="1250" dirty="0">
                 <a:solidFill>
                   <a:srgbClr val="3E4E59"/>
                 </a:solidFill>
@@ -2441,15 +2992,54 @@
                 <a:ea typeface="Arial" pitchFamily="34" charset="-122"/>
                 <a:cs typeface="Arial" pitchFamily="34" charset="-120"/>
               </a:rPr>
-              <a:t>no Ano 0 ocorre o desembolso total (CAPEX); a robustez do fluxo de caixa operacional recupera o investimento antes da metade da vida útil do BESS (20 anos).</a:t>
-            </a:r>
-            <a:endParaRPr lang="en-US" sz="1200" dirty="0"/>
-          </a:p>
-        </p:txBody>
-      </p:sp>
-      <p:sp>
-        <p:nvSpPr>
-          <p:cNvPr id="7" name="Text 3"/>
+              <a:t>uma fazenda com 5 a 10 pivôs gasta de R$ 200 mil a R$ 800 mil por ano em energia — exatamente a conta que o BESS ataca.</a:t>
+            </a:r>
+            <a:endParaRPr lang="en-US" sz="1250" dirty="0"/>
+          </a:p>
+        </p:txBody>
+      </p:sp>
+      <p:sp>
+        <p:nvSpPr>
+          <p:cNvPr id="20" name="Text 15"/>
+          <p:cNvSpPr/>
+          <p:nvPr/>
+        </p:nvSpPr>
+        <p:spPr>
+          <a:xfrm>
+            <a:off x="548640" y="6144768"/>
+            <a:ext cx="11091672" cy="256032"/>
+          </a:xfrm>
+          <a:prstGeom prst="rect">
+            <a:avLst/>
+          </a:prstGeom>
+          <a:noFill/>
+          <a:ln/>
+        </p:spPr>
+        <p:txBody>
+          <a:bodyPr wrap="square" lIns="0" tIns="0" rIns="0" bIns="0" rtlCol="0" anchor="ctr"/>
+          <a:lstStyle/>
+          <a:p>
+            <a:pPr indent="0" marL="0">
+              <a:buNone/>
+            </a:pPr>
+            <a:r>
+              <a:rPr lang="en-US" sz="850" i="1" dirty="0">
+                <a:solidFill>
+                  <a:srgbClr val="7A8A94"/>
+                </a:solidFill>
+                <a:latin typeface="Arial" pitchFamily="34" charset="0"/>
+                <a:ea typeface="Arial" pitchFamily="34" charset="-122"/>
+                <a:cs typeface="Arial" pitchFamily="34" charset="-120"/>
+              </a:rPr>
+              <a:t>Fontes: ANEEL (Lei nº 10.438/2002 · REN nº 1.000/2021) · Plano Safra 2026/27 (MAPA) · pv magazine Brasil · Canal Solar · Click Petróleo e Gás (jul/2025).</a:t>
+            </a:r>
+            <a:endParaRPr lang="en-US" sz="850" dirty="0"/>
+          </a:p>
+        </p:txBody>
+      </p:sp>
+      <p:sp>
+        <p:nvSpPr>
+          <p:cNvPr id="22" name="Text 16"/>
           <p:cNvSpPr/>
           <p:nvPr/>
         </p:nvSpPr>
@@ -2488,7 +3078,7 @@
       </p:sp>
       <p:sp>
         <p:nvSpPr>
-          <p:cNvPr id="8" name="Text 4"/>
+          <p:cNvPr id="23" name="Text 17"/>
           <p:cNvSpPr/>
           <p:nvPr/>
         </p:nvSpPr>
@@ -2590,125 +3180,15 @@
                 <a:ea typeface="Arial" pitchFamily="34" charset="-122"/>
                 <a:cs typeface="Arial" pitchFamily="34" charset="-120"/>
               </a:rPr>
-              <a:t>Fronteiras de Aplicação: quem realmente se beneficia do BESS?</a:t>
+              <a:t>A Trajetória de Recuperação do Capital  |  break-even</a:t>
             </a:r>
             <a:endParaRPr lang="en-US" sz="3000" dirty="0"/>
           </a:p>
         </p:txBody>
-      </p:sp>
-      <p:sp>
-        <p:nvSpPr>
-          <p:cNvPr id="3" name="Shape 1"/>
-          <p:cNvSpPr/>
-          <p:nvPr/>
-        </p:nvSpPr>
-        <p:spPr>
-          <a:xfrm>
-            <a:off x="548640" y="1600200"/>
-            <a:ext cx="5440680" cy="4434840"/>
-          </a:xfrm>
-          <a:prstGeom prst="roundRect">
-            <a:avLst>
-              <a:gd name="adj" fmla="val 1856"/>
-            </a:avLst>
-          </a:prstGeom>
-          <a:solidFill>
-            <a:srgbClr val="F5F8FA"/>
-          </a:solidFill>
-          <a:ln w="19050">
-            <a:solidFill>
-              <a:srgbClr val="F2B705"/>
-            </a:solidFill>
-            <a:prstDash val="solid"/>
-          </a:ln>
-          <a:effectLst>
-            <a:outerShdw sx="100000" sy="100000" kx="0" ky="0" algn="bl" rotWithShape="0" blurRad="88900" dist="25400" dir="5400000">
-              <a:srgbClr val="9AAAB4">
-                <a:alpha val="35000"/>
-              </a:srgbClr>
-            </a:outerShdw>
-          </a:effectLst>
-        </p:spPr>
-      </p:sp>
-      <p:sp>
-        <p:nvSpPr>
-          <p:cNvPr id="4" name="Text 2"/>
-          <p:cNvSpPr/>
-          <p:nvPr/>
-        </p:nvSpPr>
-        <p:spPr>
-          <a:xfrm>
-            <a:off x="868680" y="1874520"/>
-            <a:ext cx="4800600" cy="777240"/>
-          </a:xfrm>
-          <a:prstGeom prst="rect">
-            <a:avLst/>
-          </a:prstGeom>
-          <a:noFill/>
-          <a:ln/>
-        </p:spPr>
-        <p:txBody>
-          <a:bodyPr wrap="square" lIns="0" tIns="0" rIns="0" bIns="0" rtlCol="0" anchor="t"/>
-          <a:lstStyle/>
-          <a:p>
-            <a:pPr indent="0" marL="0">
-              <a:buNone/>
-            </a:pPr>
-            <a:r>
-              <a:rPr lang="en-US" sz="2000" b="1" dirty="0">
-                <a:solidFill>
-                  <a:srgbClr val="16303F"/>
-                </a:solidFill>
-                <a:latin typeface="Arial" pitchFamily="34" charset="0"/>
-                <a:ea typeface="Arial" pitchFamily="34" charset="-122"/>
-                <a:cs typeface="Arial" pitchFamily="34" charset="-120"/>
-              </a:rPr>
-              <a:t>Alta elegibilidade</a:t>
-            </a:r>
-            <a:endParaRPr lang="en-US" sz="2000" dirty="0"/>
-          </a:p>
-          <a:p>
-            <a:pPr indent="0" marL="0">
-              <a:buNone/>
-            </a:pPr>
-            <a:r>
-              <a:rPr lang="en-US" sz="1150" i="1" dirty="0">
-                <a:solidFill>
-                  <a:srgbClr val="B78A00"/>
-                </a:solidFill>
-                <a:latin typeface="Arial" pitchFamily="34" charset="0"/>
-                <a:ea typeface="Arial" pitchFamily="34" charset="-122"/>
-                <a:cs typeface="Arial" pitchFamily="34" charset="-120"/>
-              </a:rPr>
-              <a:t>Oportunidades de ouro</a:t>
-            </a:r>
-            <a:endParaRPr lang="en-US" sz="2000" dirty="0"/>
-          </a:p>
-        </p:txBody>
-      </p:sp>
-      <p:sp>
-        <p:nvSpPr>
-          <p:cNvPr id="5" name="Shape 3"/>
-          <p:cNvSpPr/>
-          <p:nvPr/>
-        </p:nvSpPr>
-        <p:spPr>
-          <a:xfrm>
-            <a:off x="868680" y="2834640"/>
-            <a:ext cx="530352" cy="530352"/>
-          </a:xfrm>
-          <a:prstGeom prst="ellipse">
-            <a:avLst/>
-          </a:prstGeom>
-          <a:solidFill>
-            <a:srgbClr val="F2B705"/>
-          </a:solidFill>
-          <a:ln/>
-        </p:spPr>
       </p:sp>
       <p:pic>
         <p:nvPicPr>
-          <p:cNvPr id="6" name="Image 0" descr="preencoded.png">    </p:cNvPr>
+          <p:cNvPr id="3" name="Image 0" descr="chart10.png">    </p:cNvPr>
           <p:cNvPicPr>
             <a:picLocks noChangeAspect="1"/>
           </p:cNvPicPr>
@@ -2722,8 +3202,8 @@
         </p:blipFill>
         <p:spPr>
           <a:xfrm>
-            <a:off x="985357" y="2951317"/>
-            <a:ext cx="296997" cy="296997"/>
+            <a:off x="685800" y="1417320"/>
+            <a:ext cx="10835640" cy="4160520"/>
           </a:xfrm>
           <a:prstGeom prst="rect">
             <a:avLst/>
@@ -2732,226 +3212,52 @@
       </p:pic>
       <p:sp>
         <p:nvSpPr>
-          <p:cNvPr id="7" name="Text 4"/>
-          <p:cNvSpPr/>
-          <p:nvPr/>
-        </p:nvSpPr>
-        <p:spPr>
-          <a:xfrm>
-            <a:off x="1554480" y="2770632"/>
-            <a:ext cx="4114800" cy="1325880"/>
-          </a:xfrm>
-          <a:prstGeom prst="rect">
-            <a:avLst/>
-          </a:prstGeom>
-          <a:noFill/>
-          <a:ln/>
-        </p:spPr>
-        <p:txBody>
-          <a:bodyPr wrap="square" lIns="0" tIns="0" rIns="0" bIns="0" rtlCol="0" anchor="t"/>
-          <a:lstStyle/>
-          <a:p>
-            <a:pPr indent="0" marL="0">
-              <a:lnSpc>
-                <a:spcPct val="112000"/>
-              </a:lnSpc>
-              <a:buNone/>
-            </a:pPr>
-            <a:r>
-              <a:rPr lang="en-US" sz="1250" b="1" dirty="0">
-                <a:solidFill>
-                  <a:srgbClr val="16303F"/>
-                </a:solidFill>
-                <a:latin typeface="Arial" pitchFamily="34" charset="0"/>
-                <a:ea typeface="Arial" pitchFamily="34" charset="-122"/>
-                <a:cs typeface="Arial" pitchFamily="34" charset="-120"/>
-              </a:rPr>
-              <a:t>Agronegócio  </a:t>
-            </a:r>
-            <a:pPr indent="0" marL="0">
-              <a:lnSpc>
-                <a:spcPct val="112000"/>
-              </a:lnSpc>
-              <a:buNone/>
-            </a:pPr>
-            <a:r>
-              <a:rPr lang="en-US" sz="1250" dirty="0">
-                <a:solidFill>
-                  <a:srgbClr val="3E4E59"/>
-                </a:solidFill>
-                <a:latin typeface="Arial" pitchFamily="34" charset="0"/>
-                <a:ea typeface="Arial" pitchFamily="34" charset="-122"/>
-                <a:cs typeface="Arial" pitchFamily="34" charset="-120"/>
-              </a:rPr>
-              <a:t>— redução de até 30% nos custos energéticos no campo, protegendo margens em operações rurais de fim de linha, com baixa qualidade de rede.</a:t>
-            </a:r>
-            <a:endParaRPr lang="en-US" sz="1250" dirty="0"/>
-          </a:p>
-        </p:txBody>
-      </p:sp>
-      <p:sp>
-        <p:nvSpPr>
-          <p:cNvPr id="8" name="Shape 5"/>
-          <p:cNvSpPr/>
-          <p:nvPr/>
-        </p:nvSpPr>
-        <p:spPr>
-          <a:xfrm>
-            <a:off x="868680" y="4343400"/>
-            <a:ext cx="530352" cy="530352"/>
-          </a:xfrm>
-          <a:prstGeom prst="ellipse">
-            <a:avLst/>
-          </a:prstGeom>
-          <a:solidFill>
-            <a:srgbClr val="F2B705"/>
-          </a:solidFill>
-          <a:ln/>
-        </p:spPr>
-      </p:sp>
-      <p:pic>
-        <p:nvPicPr>
-          <p:cNvPr id="9" name="Image 1" descr="preencoded.png">    </p:cNvPr>
-          <p:cNvPicPr>
-            <a:picLocks noChangeAspect="1"/>
-          </p:cNvPicPr>
-          <p:nvPr/>
-        </p:nvPicPr>
-        <p:blipFill>
-          <a:blip r:embed="rId2"/>
-          <a:stretch>
-            <a:fillRect/>
-          </a:stretch>
-        </p:blipFill>
-        <p:spPr>
-          <a:xfrm>
-            <a:off x="985357" y="4460077"/>
-            <a:ext cx="296997" cy="296997"/>
-          </a:xfrm>
-          <a:prstGeom prst="rect">
-            <a:avLst/>
-          </a:prstGeom>
-        </p:spPr>
-      </p:pic>
-      <p:sp>
-        <p:nvSpPr>
-          <p:cNvPr id="10" name="Text 6"/>
-          <p:cNvSpPr/>
-          <p:nvPr/>
-        </p:nvSpPr>
-        <p:spPr>
-          <a:xfrm>
-            <a:off x="1554480" y="4279392"/>
-            <a:ext cx="4114800" cy="1463040"/>
-          </a:xfrm>
-          <a:prstGeom prst="rect">
-            <a:avLst/>
-          </a:prstGeom>
-          <a:noFill/>
-          <a:ln/>
-        </p:spPr>
-        <p:txBody>
-          <a:bodyPr wrap="square" lIns="0" tIns="0" rIns="0" bIns="0" rtlCol="0" anchor="t"/>
-          <a:lstStyle/>
-          <a:p>
-            <a:pPr indent="0" marL="0">
-              <a:lnSpc>
-                <a:spcPct val="112000"/>
-              </a:lnSpc>
-              <a:buNone/>
-            </a:pPr>
-            <a:r>
-              <a:rPr lang="en-US" sz="1250" b="1" dirty="0">
-                <a:solidFill>
-                  <a:srgbClr val="16303F"/>
-                </a:solidFill>
-                <a:latin typeface="Arial" pitchFamily="34" charset="0"/>
-                <a:ea typeface="Arial" pitchFamily="34" charset="-122"/>
-                <a:cs typeface="Arial" pitchFamily="34" charset="-120"/>
-              </a:rPr>
-              <a:t>Indústria no Mercado Livre  </a:t>
-            </a:r>
-            <a:pPr indent="0" marL="0">
-              <a:lnSpc>
-                <a:spcPct val="112000"/>
-              </a:lnSpc>
-              <a:buNone/>
-            </a:pPr>
-            <a:r>
-              <a:rPr lang="en-US" sz="1250" dirty="0">
-                <a:solidFill>
-                  <a:srgbClr val="3E4E59"/>
-                </a:solidFill>
-                <a:latin typeface="Arial" pitchFamily="34" charset="0"/>
-                <a:ea typeface="Arial" pitchFamily="34" charset="-122"/>
-                <a:cs typeface="Arial" pitchFamily="34" charset="-120"/>
-              </a:rPr>
-              <a:t>— consumidores com demanda mínima acima de 500 kW e alta amplitude intradiária na carga: a sensibilidade tarifária maximiza a arbitragem.</a:t>
-            </a:r>
-            <a:endParaRPr lang="en-US" sz="1250" dirty="0"/>
-          </a:p>
-        </p:txBody>
-      </p:sp>
-      <p:sp>
-        <p:nvSpPr>
-          <p:cNvPr id="11" name="Shape 7"/>
-          <p:cNvSpPr/>
-          <p:nvPr/>
-        </p:nvSpPr>
-        <p:spPr>
-          <a:xfrm>
-            <a:off x="6245352" y="1600200"/>
-            <a:ext cx="5440680" cy="4434840"/>
+          <p:cNvPr id="4" name="Shape 1"/>
+          <p:cNvSpPr/>
+          <p:nvPr/>
+        </p:nvSpPr>
+        <p:spPr>
+          <a:xfrm>
+            <a:off x="685800" y="5760720"/>
+            <a:ext cx="10835640" cy="566928"/>
           </a:xfrm>
           <a:prstGeom prst="roundRect">
             <a:avLst>
-              <a:gd name="adj" fmla="val 1856"/>
+              <a:gd name="adj" fmla="val 12903"/>
             </a:avLst>
           </a:prstGeom>
           <a:solidFill>
-            <a:srgbClr val="F5F8FA"/>
+            <a:srgbClr val="EAF1F6"/>
           </a:solidFill>
-          <a:ln w="12700">
-            <a:solidFill>
-              <a:srgbClr val="D9E2E8"/>
-            </a:solidFill>
-            <a:prstDash val="solid"/>
-          </a:ln>
-          <a:effectLst>
-            <a:outerShdw sx="100000" sy="100000" kx="0" ky="0" algn="bl" rotWithShape="0" blurRad="88900" dist="25400" dir="5400000">
-              <a:srgbClr val="9AAAB4">
-                <a:alpha val="35000"/>
-              </a:srgbClr>
-            </a:outerShdw>
-          </a:effectLst>
-        </p:spPr>
-      </p:sp>
-      <p:sp>
-        <p:nvSpPr>
-          <p:cNvPr id="12" name="Text 8"/>
-          <p:cNvSpPr/>
-          <p:nvPr/>
-        </p:nvSpPr>
-        <p:spPr>
-          <a:xfrm>
-            <a:off x="6565392" y="1874520"/>
-            <a:ext cx="4800600" cy="777240"/>
-          </a:xfrm>
-          <a:prstGeom prst="rect">
-            <a:avLst/>
-          </a:prstGeom>
-          <a:noFill/>
-          <a:ln/>
-        </p:spPr>
-        <p:txBody>
-          <a:bodyPr wrap="square" lIns="0" tIns="0" rIns="0" bIns="0" rtlCol="0" anchor="t"/>
+          <a:ln/>
+        </p:spPr>
+      </p:sp>
+      <p:sp>
+        <p:nvSpPr>
+          <p:cNvPr id="5" name="Text 2"/>
+          <p:cNvSpPr/>
+          <p:nvPr/>
+        </p:nvSpPr>
+        <p:spPr>
+          <a:xfrm>
+            <a:off x="914400" y="5760720"/>
+            <a:ext cx="10378440" cy="566928"/>
+          </a:xfrm>
+          <a:prstGeom prst="rect">
+            <a:avLst/>
+          </a:prstGeom>
+          <a:noFill/>
+          <a:ln/>
+        </p:spPr>
+        <p:txBody>
+          <a:bodyPr wrap="square" lIns="0" tIns="0" rIns="0" bIns="0" rtlCol="0" anchor="ctr"/>
           <a:lstStyle/>
           <a:p>
             <a:pPr indent="0" marL="0">
               <a:buNone/>
             </a:pPr>
             <a:r>
-              <a:rPr lang="en-US" sz="2000" b="1" dirty="0">
+              <a:rPr lang="en-US" sz="1200" b="1" dirty="0">
                 <a:solidFill>
                   <a:srgbClr val="16303F"/>
                 </a:solidFill>
@@ -2959,119 +3265,13 @@
                 <a:ea typeface="Arial" pitchFamily="34" charset="-122"/>
                 <a:cs typeface="Arial" pitchFamily="34" charset="-120"/>
               </a:rPr>
-              <a:t>Baixa elegibilidade</a:t>
-            </a:r>
-            <a:endParaRPr lang="en-US" sz="2000" dirty="0"/>
-          </a:p>
-          <a:p>
+              <a:t>Ponto de virada financeiro:  </a:t>
+            </a:r>
             <a:pPr indent="0" marL="0">
               <a:buNone/>
             </a:pPr>
             <a:r>
-              <a:rPr lang="en-US" sz="1150" i="1" dirty="0">
-                <a:solidFill>
-                  <a:srgbClr val="7A8A94"/>
-                </a:solidFill>
-                <a:latin typeface="Arial" pitchFamily="34" charset="0"/>
-                <a:ea typeface="Arial" pitchFamily="34" charset="-122"/>
-                <a:cs typeface="Arial" pitchFamily="34" charset="-120"/>
-              </a:rPr>
-              <a:t>Barreiras técnicas</a:t>
-            </a:r>
-            <a:endParaRPr lang="en-US" sz="2000" dirty="0"/>
-          </a:p>
-        </p:txBody>
-      </p:sp>
-      <p:sp>
-        <p:nvSpPr>
-          <p:cNvPr id="13" name="Shape 9"/>
-          <p:cNvSpPr/>
-          <p:nvPr/>
-        </p:nvSpPr>
-        <p:spPr>
-          <a:xfrm>
-            <a:off x="6565392" y="2834640"/>
-            <a:ext cx="530352" cy="530352"/>
-          </a:xfrm>
-          <a:prstGeom prst="ellipse">
-            <a:avLst/>
-          </a:prstGeom>
-          <a:solidFill>
-            <a:srgbClr val="31485A"/>
-          </a:solidFill>
-          <a:ln/>
-        </p:spPr>
-      </p:sp>
-      <p:pic>
-        <p:nvPicPr>
-          <p:cNvPr id="14" name="Image 2" descr="preencoded.png">    </p:cNvPr>
-          <p:cNvPicPr>
-            <a:picLocks noChangeAspect="1"/>
-          </p:cNvPicPr>
-          <p:nvPr/>
-        </p:nvPicPr>
-        <p:blipFill>
-          <a:blip r:embed="rId3"/>
-          <a:stretch>
-            <a:fillRect/>
-          </a:stretch>
-        </p:blipFill>
-        <p:spPr>
-          <a:xfrm>
-            <a:off x="6684264" y="2953512"/>
-            <a:ext cx="292608" cy="292608"/>
-          </a:xfrm>
-          <a:prstGeom prst="rect">
-            <a:avLst/>
-          </a:prstGeom>
-        </p:spPr>
-      </p:pic>
-      <p:sp>
-        <p:nvSpPr>
-          <p:cNvPr id="15" name="Text 10"/>
-          <p:cNvSpPr/>
-          <p:nvPr/>
-        </p:nvSpPr>
-        <p:spPr>
-          <a:xfrm>
-            <a:off x="7251192" y="2770632"/>
-            <a:ext cx="4114800" cy="2377440"/>
-          </a:xfrm>
-          <a:prstGeom prst="rect">
-            <a:avLst/>
-          </a:prstGeom>
-          <a:noFill/>
-          <a:ln/>
-        </p:spPr>
-        <p:txBody>
-          <a:bodyPr wrap="square" lIns="0" tIns="0" rIns="0" bIns="0" rtlCol="0" anchor="t"/>
-          <a:lstStyle/>
-          <a:p>
-            <a:pPr indent="0" marL="0">
-              <a:lnSpc>
-                <a:spcPct val="112000"/>
-              </a:lnSpc>
-              <a:buNone/>
-            </a:pPr>
-            <a:r>
-              <a:rPr lang="en-US" sz="1250" b="1" dirty="0">
-                <a:solidFill>
-                  <a:srgbClr val="16303F"/>
-                </a:solidFill>
-                <a:latin typeface="Arial" pitchFamily="34" charset="0"/>
-                <a:ea typeface="Arial" pitchFamily="34" charset="-122"/>
-                <a:cs typeface="Arial" pitchFamily="34" charset="-120"/>
-              </a:rPr>
-              <a:t>Data centers e cargas constantes  </a:t>
-            </a:r>
-            <a:pPr indent="0" marL="0">
-              <a:lnSpc>
-                <a:spcPct val="112000"/>
-              </a:lnSpc>
-              <a:buNone/>
-            </a:pPr>
-            <a:r>
-              <a:rPr lang="en-US" sz="1250" dirty="0">
+              <a:rPr lang="en-US" sz="1200" dirty="0">
                 <a:solidFill>
                   <a:srgbClr val="3E4E59"/>
                 </a:solidFill>
@@ -3079,54 +3279,15 @@
                 <a:ea typeface="Arial" pitchFamily="34" charset="-122"/>
                 <a:cs typeface="Arial" pitchFamily="34" charset="-120"/>
               </a:rPr>
-              <a:t>— o potencial de deslocamento temporal é nulo quando a carga é flat 24/7 (equipamentos críticos e climatização). Sem picos e vales acentuados, a bateria não encontra janela operacional econômica para arbitragem.</a:t>
-            </a:r>
-            <a:endParaRPr lang="en-US" sz="1250" dirty="0"/>
-          </a:p>
-        </p:txBody>
-      </p:sp>
-      <p:sp>
-        <p:nvSpPr>
-          <p:cNvPr id="16" name="Text 11"/>
-          <p:cNvSpPr/>
-          <p:nvPr/>
-        </p:nvSpPr>
-        <p:spPr>
-          <a:xfrm>
-            <a:off x="6565392" y="5166360"/>
-            <a:ext cx="4800600" cy="594360"/>
-          </a:xfrm>
-          <a:prstGeom prst="rect">
-            <a:avLst/>
-          </a:prstGeom>
-          <a:noFill/>
-          <a:ln/>
-        </p:spPr>
-        <p:txBody>
-          <a:bodyPr wrap="square" lIns="0" tIns="0" rIns="0" bIns="0" rtlCol="0" anchor="b"/>
-          <a:lstStyle/>
-          <a:p>
-            <a:pPr indent="0" marL="0">
-              <a:buNone/>
-            </a:pPr>
-            <a:r>
-              <a:rPr lang="en-US" sz="1100" i="1" dirty="0">
-                <a:solidFill>
-                  <a:srgbClr val="7A8A94"/>
-                </a:solidFill>
-                <a:latin typeface="Arial" pitchFamily="34" charset="0"/>
-                <a:ea typeface="Arial" pitchFamily="34" charset="-122"/>
-                <a:cs typeface="Arial" pitchFamily="34" charset="-120"/>
-              </a:rPr>
-              <a:t>Regra prática: quanto maior a amplitude entre pico e vale de consumo, maior o valor capturável pelo BESS.</a:t>
-            </a:r>
-            <a:endParaRPr lang="en-US" sz="1100" dirty="0"/>
-          </a:p>
-        </p:txBody>
-      </p:sp>
-      <p:sp>
-        <p:nvSpPr>
-          <p:cNvPr id="18" name="Text 12"/>
+              <a:t>no Ano 0 ocorre o desembolso total (CAPEX); com bombeamento no horário reservado do irrigante e crédito do Plano Safra, o capital retorna em cerca de 5 anos — um quarto da vida útil de 20 anos.</a:t>
+            </a:r>
+            <a:endParaRPr lang="en-US" sz="1200" dirty="0"/>
+          </a:p>
+        </p:txBody>
+      </p:sp>
+      <p:sp>
+        <p:nvSpPr>
+          <p:cNvPr id="7" name="Text 3"/>
           <p:cNvSpPr/>
           <p:nvPr/>
         </p:nvSpPr>
@@ -3165,7 +3326,7 @@
       </p:sp>
       <p:sp>
         <p:nvSpPr>
-          <p:cNvPr id="19" name="Text 13"/>
+          <p:cNvPr id="8" name="Text 4"/>
           <p:cNvSpPr/>
           <p:nvPr/>
         </p:nvSpPr>
@@ -3216,7 +3377,7 @@
     <p:bg>
       <p:bgPr>
         <a:solidFill>
-          <a:srgbClr val="102A3C"/>
+          <a:srgbClr val="FFFFFF"/>
         </a:solidFill>
       </p:bgPr>
     </p:bg>
@@ -3242,32 +3403,32 @@
         </p:nvSpPr>
         <p:spPr>
           <a:xfrm>
-            <a:off x="548640" y="457200"/>
-            <a:ext cx="11064240" cy="731520"/>
-          </a:xfrm>
-          <a:prstGeom prst="rect">
-            <a:avLst/>
-          </a:prstGeom>
-          <a:noFill/>
-          <a:ln/>
-        </p:spPr>
-        <p:txBody>
-          <a:bodyPr wrap="square" lIns="0" tIns="0" rIns="0" bIns="0" rtlCol="0" anchor="ctr"/>
-          <a:lstStyle/>
-          <a:p>
-            <a:pPr indent="0" marL="0">
+            <a:off x="548640" y="384048"/>
+            <a:ext cx="11064240" cy="822960"/>
+          </a:xfrm>
+          <a:prstGeom prst="rect">
+            <a:avLst/>
+          </a:prstGeom>
+          <a:noFill/>
+          <a:ln/>
+        </p:spPr>
+        <p:txBody>
+          <a:bodyPr wrap="square" lIns="0" tIns="0" rIns="0" bIns="0" rtlCol="0" anchor="t"/>
+          <a:lstStyle/>
+          <a:p>
+            <a:pPr algn="l" indent="0" marL="0">
               <a:buNone/>
             </a:pPr>
             <a:r>
               <a:rPr lang="en-US" sz="3000" b="1" dirty="0">
                 <a:solidFill>
-                  <a:srgbClr val="FFFFFF"/>
-                </a:solidFill>
-                <a:latin typeface="Arial" pitchFamily="34" charset="0"/>
-                <a:ea typeface="Arial" pitchFamily="34" charset="-122"/>
-                <a:cs typeface="Arial" pitchFamily="34" charset="-120"/>
-              </a:rPr>
-              <a:t>Síntese: a matriz energética foi redesenhada</a:t>
+                  <a:srgbClr val="16303F"/>
+                </a:solidFill>
+                <a:latin typeface="Arial" pitchFamily="34" charset="0"/>
+                <a:ea typeface="Arial" pitchFamily="34" charset="-122"/>
+                <a:cs typeface="Arial" pitchFamily="34" charset="-120"/>
+              </a:rPr>
+              <a:t>Fronteiras de Aplicação: quem realmente se beneficia do BESS?</a:t>
             </a:r>
             <a:endParaRPr lang="en-US" sz="3000" dirty="0"/>
           </a:p>
@@ -3281,208 +3442,100 @@
         </p:nvSpPr>
         <p:spPr>
           <a:xfrm>
-            <a:off x="1051560" y="1691640"/>
-            <a:ext cx="2834640" cy="1234440"/>
+            <a:off x="548640" y="1600200"/>
+            <a:ext cx="5440680" cy="4434840"/>
           </a:xfrm>
           <a:prstGeom prst="roundRect">
             <a:avLst>
-              <a:gd name="adj" fmla="val 5926"/>
+              <a:gd name="adj" fmla="val 1856"/>
             </a:avLst>
           </a:prstGeom>
           <a:solidFill>
-            <a:srgbClr val="102A3C"/>
+            <a:srgbClr val="F5F8FA"/>
           </a:solidFill>
           <a:ln w="19050">
-            <a:solidFill>
-              <a:srgbClr val="3D5668"/>
-            </a:solidFill>
-            <a:prstDash val="solid"/>
-          </a:ln>
-        </p:spPr>
-      </p:sp>
-      <p:sp>
-        <p:nvSpPr>
-          <p:cNvPr id="4" name="Text 2"/>
-          <p:cNvSpPr/>
-          <p:nvPr/>
-        </p:nvSpPr>
-        <p:spPr>
-          <a:xfrm>
-            <a:off x="1051560" y="1691640"/>
-            <a:ext cx="2834640" cy="1234440"/>
-          </a:xfrm>
-          <a:prstGeom prst="rect">
-            <a:avLst/>
-          </a:prstGeom>
-          <a:noFill/>
-          <a:ln/>
-        </p:spPr>
-        <p:txBody>
-          <a:bodyPr wrap="square" lIns="1270" tIns="1270" rIns="1270" bIns="1270" rtlCol="0" anchor="ctr"/>
-          <a:lstStyle/>
-          <a:p>
-            <a:pPr algn="ctr" indent="0" marL="0">
-              <a:lnSpc>
-                <a:spcPct val="105000"/>
-              </a:lnSpc>
-              <a:buNone/>
-            </a:pPr>
-            <a:r>
-              <a:rPr lang="en-US" sz="1600" dirty="0">
-                <a:solidFill>
-                  <a:srgbClr val="C6D4DD"/>
-                </a:solidFill>
-                <a:latin typeface="Arial" pitchFamily="34" charset="0"/>
-                <a:ea typeface="Arial" pitchFamily="34" charset="-122"/>
-                <a:cs typeface="Arial" pitchFamily="34" charset="-120"/>
-              </a:rPr>
-              <a:t>Elétrons</a:t>
-            </a:r>
-            <a:endParaRPr lang="en-US" sz="1600" dirty="0"/>
-          </a:p>
-          <a:p>
-            <a:pPr algn="ctr" indent="0" marL="0">
-              <a:lnSpc>
-                <a:spcPct val="105000"/>
-              </a:lnSpc>
-              <a:buNone/>
-            </a:pPr>
-            <a:r>
-              <a:rPr lang="en-US" sz="1600" dirty="0">
-                <a:solidFill>
-                  <a:srgbClr val="C6D4DD"/>
-                </a:solidFill>
-                <a:latin typeface="Arial" pitchFamily="34" charset="0"/>
-                <a:ea typeface="Arial" pitchFamily="34" charset="-122"/>
-                <a:cs typeface="Arial" pitchFamily="34" charset="-120"/>
-              </a:rPr>
-              <a:t>intermitentes</a:t>
-            </a:r>
-            <a:endParaRPr lang="en-US" sz="1600" dirty="0"/>
-          </a:p>
-        </p:txBody>
-      </p:sp>
-      <p:sp>
-        <p:nvSpPr>
-          <p:cNvPr id="5" name="Shape 3"/>
-          <p:cNvSpPr/>
-          <p:nvPr/>
-        </p:nvSpPr>
-        <p:spPr>
-          <a:xfrm>
-            <a:off x="4050792" y="2162556"/>
-            <a:ext cx="457200" cy="292608"/>
-          </a:xfrm>
-          <a:prstGeom prst="rightArrow">
-            <a:avLst/>
-          </a:prstGeom>
-          <a:solidFill>
-            <a:srgbClr val="F2B705"/>
-          </a:solidFill>
-          <a:ln/>
-        </p:spPr>
-      </p:sp>
-      <p:sp>
-        <p:nvSpPr>
-          <p:cNvPr id="6" name="Shape 4"/>
-          <p:cNvSpPr/>
-          <p:nvPr/>
-        </p:nvSpPr>
-        <p:spPr>
-          <a:xfrm>
-            <a:off x="4681728" y="1691640"/>
-            <a:ext cx="2834640" cy="1234440"/>
-          </a:xfrm>
-          <a:prstGeom prst="roundRect">
-            <a:avLst>
-              <a:gd name="adj" fmla="val 5926"/>
-            </a:avLst>
-          </a:prstGeom>
-          <a:solidFill>
-            <a:srgbClr val="102A3C"/>
-          </a:solidFill>
-          <a:ln w="31750">
             <a:solidFill>
               <a:srgbClr val="F2B705"/>
             </a:solidFill>
             <a:prstDash val="solid"/>
           </a:ln>
-        </p:spPr>
-      </p:sp>
-      <p:sp>
-        <p:nvSpPr>
-          <p:cNvPr id="7" name="Text 5"/>
-          <p:cNvSpPr/>
-          <p:nvPr/>
-        </p:nvSpPr>
-        <p:spPr>
-          <a:xfrm>
-            <a:off x="4681728" y="1691640"/>
-            <a:ext cx="2834640" cy="1234440"/>
-          </a:xfrm>
-          <a:prstGeom prst="rect">
-            <a:avLst/>
-          </a:prstGeom>
-          <a:noFill/>
-          <a:ln/>
-        </p:spPr>
-        <p:txBody>
-          <a:bodyPr wrap="square" lIns="1270" tIns="1270" rIns="1270" bIns="1270" rtlCol="0" anchor="ctr"/>
-          <a:lstStyle/>
-          <a:p>
-            <a:pPr algn="ctr" indent="0" marL="0">
-              <a:lnSpc>
-                <a:spcPct val="105000"/>
-              </a:lnSpc>
-              <a:buNone/>
-            </a:pPr>
-            <a:r>
-              <a:rPr lang="en-US" sz="1600" b="1" dirty="0">
-                <a:solidFill>
-                  <a:srgbClr val="F2B705"/>
-                </a:solidFill>
-                <a:latin typeface="Arial" pitchFamily="34" charset="0"/>
-                <a:ea typeface="Arial" pitchFamily="34" charset="-122"/>
-                <a:cs typeface="Arial" pitchFamily="34" charset="-120"/>
-              </a:rPr>
-              <a:t>BESS</a:t>
-            </a:r>
-            <a:endParaRPr lang="en-US" sz="1600" dirty="0"/>
-          </a:p>
-          <a:p>
-            <a:pPr algn="ctr" indent="0" marL="0">
-              <a:lnSpc>
-                <a:spcPct val="105000"/>
-              </a:lnSpc>
-              <a:buNone/>
-            </a:pPr>
-            <a:r>
-              <a:rPr lang="en-US" sz="1600" b="1" dirty="0">
-                <a:solidFill>
-                  <a:srgbClr val="F2B705"/>
-                </a:solidFill>
-                <a:latin typeface="Arial" pitchFamily="34" charset="0"/>
-                <a:ea typeface="Arial" pitchFamily="34" charset="-122"/>
-                <a:cs typeface="Arial" pitchFamily="34" charset="-120"/>
-              </a:rPr>
-              <a:t>filtro de regulação</a:t>
-            </a:r>
-            <a:endParaRPr lang="en-US" sz="1600" dirty="0"/>
-          </a:p>
-        </p:txBody>
-      </p:sp>
-      <p:sp>
-        <p:nvSpPr>
-          <p:cNvPr id="8" name="Shape 6"/>
-          <p:cNvSpPr/>
-          <p:nvPr/>
-        </p:nvSpPr>
-        <p:spPr>
-          <a:xfrm>
-            <a:off x="7680960" y="2162556"/>
-            <a:ext cx="457200" cy="292608"/>
-          </a:xfrm>
-          <a:prstGeom prst="rightArrow">
+          <a:effectLst>
+            <a:outerShdw sx="100000" sy="100000" kx="0" ky="0" algn="bl" rotWithShape="0" blurRad="88900" dist="25400" dir="5400000">
+              <a:srgbClr val="9AAAB4">
+                <a:alpha val="35000"/>
+              </a:srgbClr>
+            </a:outerShdw>
+          </a:effectLst>
+        </p:spPr>
+      </p:sp>
+      <p:sp>
+        <p:nvSpPr>
+          <p:cNvPr id="4" name="Text 2"/>
+          <p:cNvSpPr/>
+          <p:nvPr/>
+        </p:nvSpPr>
+        <p:spPr>
+          <a:xfrm>
+            <a:off x="868680" y="1874520"/>
+            <a:ext cx="4800600" cy="777240"/>
+          </a:xfrm>
+          <a:prstGeom prst="rect">
+            <a:avLst/>
+          </a:prstGeom>
+          <a:noFill/>
+          <a:ln/>
+        </p:spPr>
+        <p:txBody>
+          <a:bodyPr wrap="square" lIns="0" tIns="0" rIns="0" bIns="0" rtlCol="0" anchor="t"/>
+          <a:lstStyle/>
+          <a:p>
+            <a:pPr indent="0" marL="0">
+              <a:buNone/>
+            </a:pPr>
+            <a:r>
+              <a:rPr lang="en-US" sz="2000" b="1" dirty="0">
+                <a:solidFill>
+                  <a:srgbClr val="16303F"/>
+                </a:solidFill>
+                <a:latin typeface="Arial" pitchFamily="34" charset="0"/>
+                <a:ea typeface="Arial" pitchFamily="34" charset="-122"/>
+                <a:cs typeface="Arial" pitchFamily="34" charset="-120"/>
+              </a:rPr>
+              <a:t>Alta elegibilidade</a:t>
+            </a:r>
+            <a:endParaRPr lang="en-US" sz="2000" dirty="0"/>
+          </a:p>
+          <a:p>
+            <a:pPr indent="0" marL="0">
+              <a:buNone/>
+            </a:pPr>
+            <a:r>
+              <a:rPr lang="en-US" sz="1150" i="1" dirty="0">
+                <a:solidFill>
+                  <a:srgbClr val="B78A00"/>
+                </a:solidFill>
+                <a:latin typeface="Arial" pitchFamily="34" charset="0"/>
+                <a:ea typeface="Arial" pitchFamily="34" charset="-122"/>
+                <a:cs typeface="Arial" pitchFamily="34" charset="-120"/>
+              </a:rPr>
+              <a:t>Oportunidades de ouro</a:t>
+            </a:r>
+            <a:endParaRPr lang="en-US" sz="2000" dirty="0"/>
+          </a:p>
+        </p:txBody>
+      </p:sp>
+      <p:sp>
+        <p:nvSpPr>
+          <p:cNvPr id="5" name="Shape 3"/>
+          <p:cNvSpPr/>
+          <p:nvPr/>
+        </p:nvSpPr>
+        <p:spPr>
+          <a:xfrm>
+            <a:off x="868680" y="2834640"/>
+            <a:ext cx="530352" cy="530352"/>
+          </a:xfrm>
+          <a:prstGeom prst="ellipse">
             <a:avLst/>
           </a:prstGeom>
           <a:solidFill>
@@ -3491,216 +3544,427 @@
           <a:ln/>
         </p:spPr>
       </p:sp>
-      <p:sp>
-        <p:nvSpPr>
-          <p:cNvPr id="9" name="Shape 7"/>
-          <p:cNvSpPr/>
-          <p:nvPr/>
-        </p:nvSpPr>
-        <p:spPr>
-          <a:xfrm>
-            <a:off x="8311896" y="1691640"/>
-            <a:ext cx="2834640" cy="1234440"/>
+      <p:pic>
+        <p:nvPicPr>
+          <p:cNvPr id="6" name="Image 0" descr="preencoded.png">    </p:cNvPr>
+          <p:cNvPicPr>
+            <a:picLocks noChangeAspect="1"/>
+          </p:cNvPicPr>
+          <p:nvPr/>
+        </p:nvPicPr>
+        <p:blipFill>
+          <a:blip r:embed="rId1"/>
+          <a:stretch>
+            <a:fillRect/>
+          </a:stretch>
+        </p:blipFill>
+        <p:spPr>
+          <a:xfrm>
+            <a:off x="985357" y="2951317"/>
+            <a:ext cx="296997" cy="296997"/>
+          </a:xfrm>
+          <a:prstGeom prst="rect">
+            <a:avLst/>
+          </a:prstGeom>
+        </p:spPr>
+      </p:pic>
+      <p:sp>
+        <p:nvSpPr>
+          <p:cNvPr id="7" name="Text 4"/>
+          <p:cNvSpPr/>
+          <p:nvPr/>
+        </p:nvSpPr>
+        <p:spPr>
+          <a:xfrm>
+            <a:off x="1554480" y="2770632"/>
+            <a:ext cx="4114800" cy="1325880"/>
+          </a:xfrm>
+          <a:prstGeom prst="rect">
+            <a:avLst/>
+          </a:prstGeom>
+          <a:noFill/>
+          <a:ln/>
+        </p:spPr>
+        <p:txBody>
+          <a:bodyPr wrap="square" lIns="0" tIns="0" rIns="0" bIns="0" rtlCol="0" anchor="t"/>
+          <a:lstStyle/>
+          <a:p>
+            <a:pPr indent="0" marL="0">
+              <a:lnSpc>
+                <a:spcPct val="112000"/>
+              </a:lnSpc>
+              <a:buNone/>
+            </a:pPr>
+            <a:r>
+              <a:rPr lang="en-US" sz="1250" b="1" dirty="0">
+                <a:solidFill>
+                  <a:srgbClr val="16303F"/>
+                </a:solidFill>
+                <a:latin typeface="Arial" pitchFamily="34" charset="0"/>
+                <a:ea typeface="Arial" pitchFamily="34" charset="-122"/>
+                <a:cs typeface="Arial" pitchFamily="34" charset="-120"/>
+              </a:rPr>
+              <a:t>Agronegócio  </a:t>
+            </a:r>
+            <a:pPr indent="0" marL="0">
+              <a:lnSpc>
+                <a:spcPct val="112000"/>
+              </a:lnSpc>
+              <a:buNone/>
+            </a:pPr>
+            <a:r>
+              <a:rPr lang="en-US" sz="1250" dirty="0">
+                <a:solidFill>
+                  <a:srgbClr val="3E4E59"/>
+                </a:solidFill>
+                <a:latin typeface="Arial" pitchFamily="34" charset="0"/>
+                <a:ea typeface="Arial" pitchFamily="34" charset="-122"/>
+                <a:cs typeface="Arial" pitchFamily="34" charset="-120"/>
+              </a:rPr>
+              <a:t>— redução de até 30% nos custos energéticos no campo, protegendo margens em operações rurais de fim de linha, com baixa qualidade de rede.</a:t>
+            </a:r>
+            <a:endParaRPr lang="en-US" sz="1250" dirty="0"/>
+          </a:p>
+        </p:txBody>
+      </p:sp>
+      <p:sp>
+        <p:nvSpPr>
+          <p:cNvPr id="8" name="Shape 5"/>
+          <p:cNvSpPr/>
+          <p:nvPr/>
+        </p:nvSpPr>
+        <p:spPr>
+          <a:xfrm>
+            <a:off x="868680" y="4343400"/>
+            <a:ext cx="530352" cy="530352"/>
+          </a:xfrm>
+          <a:prstGeom prst="ellipse">
+            <a:avLst/>
+          </a:prstGeom>
+          <a:solidFill>
+            <a:srgbClr val="F2B705"/>
+          </a:solidFill>
+          <a:ln/>
+        </p:spPr>
+      </p:sp>
+      <p:pic>
+        <p:nvPicPr>
+          <p:cNvPr id="9" name="Image 1" descr="preencoded.png">    </p:cNvPr>
+          <p:cNvPicPr>
+            <a:picLocks noChangeAspect="1"/>
+          </p:cNvPicPr>
+          <p:nvPr/>
+        </p:nvPicPr>
+        <p:blipFill>
+          <a:blip r:embed="rId2"/>
+          <a:stretch>
+            <a:fillRect/>
+          </a:stretch>
+        </p:blipFill>
+        <p:spPr>
+          <a:xfrm>
+            <a:off x="985357" y="4460077"/>
+            <a:ext cx="296997" cy="296997"/>
+          </a:xfrm>
+          <a:prstGeom prst="rect">
+            <a:avLst/>
+          </a:prstGeom>
+        </p:spPr>
+      </p:pic>
+      <p:sp>
+        <p:nvSpPr>
+          <p:cNvPr id="10" name="Text 6"/>
+          <p:cNvSpPr/>
+          <p:nvPr/>
+        </p:nvSpPr>
+        <p:spPr>
+          <a:xfrm>
+            <a:off x="1554480" y="4279392"/>
+            <a:ext cx="4114800" cy="1463040"/>
+          </a:xfrm>
+          <a:prstGeom prst="rect">
+            <a:avLst/>
+          </a:prstGeom>
+          <a:noFill/>
+          <a:ln/>
+        </p:spPr>
+        <p:txBody>
+          <a:bodyPr wrap="square" lIns="0" tIns="0" rIns="0" bIns="0" rtlCol="0" anchor="t"/>
+          <a:lstStyle/>
+          <a:p>
+            <a:pPr indent="0" marL="0">
+              <a:lnSpc>
+                <a:spcPct val="112000"/>
+              </a:lnSpc>
+              <a:buNone/>
+            </a:pPr>
+            <a:r>
+              <a:rPr lang="en-US" sz="1250" b="1" dirty="0">
+                <a:solidFill>
+                  <a:srgbClr val="16303F"/>
+                </a:solidFill>
+                <a:latin typeface="Arial" pitchFamily="34" charset="0"/>
+                <a:ea typeface="Arial" pitchFamily="34" charset="-122"/>
+                <a:cs typeface="Arial" pitchFamily="34" charset="-120"/>
+              </a:rPr>
+              <a:t>Indústria no Mercado Livre  </a:t>
+            </a:r>
+            <a:pPr indent="0" marL="0">
+              <a:lnSpc>
+                <a:spcPct val="112000"/>
+              </a:lnSpc>
+              <a:buNone/>
+            </a:pPr>
+            <a:r>
+              <a:rPr lang="en-US" sz="1250" dirty="0">
+                <a:solidFill>
+                  <a:srgbClr val="3E4E59"/>
+                </a:solidFill>
+                <a:latin typeface="Arial" pitchFamily="34" charset="0"/>
+                <a:ea typeface="Arial" pitchFamily="34" charset="-122"/>
+                <a:cs typeface="Arial" pitchFamily="34" charset="-120"/>
+              </a:rPr>
+              <a:t>— consumidores com demanda mínima acima de 500 kW e alta amplitude intradiária na carga: a sensibilidade tarifária maximiza a arbitragem.</a:t>
+            </a:r>
+            <a:endParaRPr lang="en-US" sz="1250" dirty="0"/>
+          </a:p>
+        </p:txBody>
+      </p:sp>
+      <p:sp>
+        <p:nvSpPr>
+          <p:cNvPr id="11" name="Shape 7"/>
+          <p:cNvSpPr/>
+          <p:nvPr/>
+        </p:nvSpPr>
+        <p:spPr>
+          <a:xfrm>
+            <a:off x="6245352" y="1600200"/>
+            <a:ext cx="5440680" cy="4434840"/>
           </a:xfrm>
           <a:prstGeom prst="roundRect">
             <a:avLst>
-              <a:gd name="adj" fmla="val 5926"/>
+              <a:gd name="adj" fmla="val 1856"/>
             </a:avLst>
           </a:prstGeom>
           <a:solidFill>
-            <a:srgbClr val="102A3C"/>
+            <a:srgbClr val="F5F8FA"/>
           </a:solidFill>
-          <a:ln w="19050">
+          <a:ln w="12700">
             <a:solidFill>
-              <a:srgbClr val="3D5668"/>
+              <a:srgbClr val="D9E2E8"/>
             </a:solidFill>
             <a:prstDash val="solid"/>
           </a:ln>
-        </p:spPr>
-      </p:sp>
-      <p:sp>
-        <p:nvSpPr>
-          <p:cNvPr id="10" name="Text 8"/>
-          <p:cNvSpPr/>
-          <p:nvPr/>
-        </p:nvSpPr>
-        <p:spPr>
-          <a:xfrm>
-            <a:off x="8311896" y="1691640"/>
-            <a:ext cx="2834640" cy="1234440"/>
-          </a:xfrm>
-          <a:prstGeom prst="rect">
-            <a:avLst/>
-          </a:prstGeom>
-          <a:noFill/>
-          <a:ln/>
-        </p:spPr>
-        <p:txBody>
-          <a:bodyPr wrap="square" lIns="1270" tIns="1270" rIns="1270" bIns="1270" rtlCol="0" anchor="ctr"/>
-          <a:lstStyle/>
-          <a:p>
-            <a:pPr algn="ctr" indent="0" marL="0">
+          <a:effectLst>
+            <a:outerShdw sx="100000" sy="100000" kx="0" ky="0" algn="bl" rotWithShape="0" blurRad="88900" dist="25400" dir="5400000">
+              <a:srgbClr val="9AAAB4">
+                <a:alpha val="35000"/>
+              </a:srgbClr>
+            </a:outerShdw>
+          </a:effectLst>
+        </p:spPr>
+      </p:sp>
+      <p:sp>
+        <p:nvSpPr>
+          <p:cNvPr id="12" name="Text 8"/>
+          <p:cNvSpPr/>
+          <p:nvPr/>
+        </p:nvSpPr>
+        <p:spPr>
+          <a:xfrm>
+            <a:off x="6565392" y="1874520"/>
+            <a:ext cx="4800600" cy="777240"/>
+          </a:xfrm>
+          <a:prstGeom prst="rect">
+            <a:avLst/>
+          </a:prstGeom>
+          <a:noFill/>
+          <a:ln/>
+        </p:spPr>
+        <p:txBody>
+          <a:bodyPr wrap="square" lIns="0" tIns="0" rIns="0" bIns="0" rtlCol="0" anchor="t"/>
+          <a:lstStyle/>
+          <a:p>
+            <a:pPr indent="0" marL="0">
+              <a:buNone/>
+            </a:pPr>
+            <a:r>
+              <a:rPr lang="en-US" sz="2000" b="1" dirty="0">
+                <a:solidFill>
+                  <a:srgbClr val="16303F"/>
+                </a:solidFill>
+                <a:latin typeface="Arial" pitchFamily="34" charset="0"/>
+                <a:ea typeface="Arial" pitchFamily="34" charset="-122"/>
+                <a:cs typeface="Arial" pitchFamily="34" charset="-120"/>
+              </a:rPr>
+              <a:t>Baixa elegibilidade</a:t>
+            </a:r>
+            <a:endParaRPr lang="en-US" sz="2000" dirty="0"/>
+          </a:p>
+          <a:p>
+            <a:pPr indent="0" marL="0">
+              <a:buNone/>
+            </a:pPr>
+            <a:r>
+              <a:rPr lang="en-US" sz="1150" i="1" dirty="0">
+                <a:solidFill>
+                  <a:srgbClr val="7A8A94"/>
+                </a:solidFill>
+                <a:latin typeface="Arial" pitchFamily="34" charset="0"/>
+                <a:ea typeface="Arial" pitchFamily="34" charset="-122"/>
+                <a:cs typeface="Arial" pitchFamily="34" charset="-120"/>
+              </a:rPr>
+              <a:t>Barreiras técnicas</a:t>
+            </a:r>
+            <a:endParaRPr lang="en-US" sz="2000" dirty="0"/>
+          </a:p>
+        </p:txBody>
+      </p:sp>
+      <p:sp>
+        <p:nvSpPr>
+          <p:cNvPr id="13" name="Shape 9"/>
+          <p:cNvSpPr/>
+          <p:nvPr/>
+        </p:nvSpPr>
+        <p:spPr>
+          <a:xfrm>
+            <a:off x="6565392" y="2834640"/>
+            <a:ext cx="530352" cy="530352"/>
+          </a:xfrm>
+          <a:prstGeom prst="ellipse">
+            <a:avLst/>
+          </a:prstGeom>
+          <a:solidFill>
+            <a:srgbClr val="31485A"/>
+          </a:solidFill>
+          <a:ln/>
+        </p:spPr>
+      </p:sp>
+      <p:pic>
+        <p:nvPicPr>
+          <p:cNvPr id="14" name="Image 2" descr="preencoded.png">    </p:cNvPr>
+          <p:cNvPicPr>
+            <a:picLocks noChangeAspect="1"/>
+          </p:cNvPicPr>
+          <p:nvPr/>
+        </p:nvPicPr>
+        <p:blipFill>
+          <a:blip r:embed="rId3"/>
+          <a:stretch>
+            <a:fillRect/>
+          </a:stretch>
+        </p:blipFill>
+        <p:spPr>
+          <a:xfrm>
+            <a:off x="6684264" y="2953512"/>
+            <a:ext cx="292608" cy="292608"/>
+          </a:xfrm>
+          <a:prstGeom prst="rect">
+            <a:avLst/>
+          </a:prstGeom>
+        </p:spPr>
+      </p:pic>
+      <p:sp>
+        <p:nvSpPr>
+          <p:cNvPr id="15" name="Text 10"/>
+          <p:cNvSpPr/>
+          <p:nvPr/>
+        </p:nvSpPr>
+        <p:spPr>
+          <a:xfrm>
+            <a:off x="7251192" y="2770632"/>
+            <a:ext cx="4114800" cy="2377440"/>
+          </a:xfrm>
+          <a:prstGeom prst="rect">
+            <a:avLst/>
+          </a:prstGeom>
+          <a:noFill/>
+          <a:ln/>
+        </p:spPr>
+        <p:txBody>
+          <a:bodyPr wrap="square" lIns="0" tIns="0" rIns="0" bIns="0" rtlCol="0" anchor="t"/>
+          <a:lstStyle/>
+          <a:p>
+            <a:pPr indent="0" marL="0">
               <a:lnSpc>
-                <a:spcPct val="105000"/>
+                <a:spcPct val="112000"/>
               </a:lnSpc>
               <a:buNone/>
             </a:pPr>
             <a:r>
-              <a:rPr lang="en-US" sz="1600" dirty="0">
-                <a:solidFill>
-                  <a:srgbClr val="C6D4DD"/>
-                </a:solidFill>
-                <a:latin typeface="Arial" pitchFamily="34" charset="0"/>
-                <a:ea typeface="Arial" pitchFamily="34" charset="-122"/>
-                <a:cs typeface="Arial" pitchFamily="34" charset="-120"/>
-              </a:rPr>
-              <a:t>Yield financeiro</a:t>
-            </a:r>
-            <a:endParaRPr lang="en-US" sz="1600" dirty="0"/>
-          </a:p>
-          <a:p>
-            <a:pPr algn="ctr" indent="0" marL="0">
+              <a:rPr lang="en-US" sz="1250" b="1" dirty="0">
+                <a:solidFill>
+                  <a:srgbClr val="16303F"/>
+                </a:solidFill>
+                <a:latin typeface="Arial" pitchFamily="34" charset="0"/>
+                <a:ea typeface="Arial" pitchFamily="34" charset="-122"/>
+                <a:cs typeface="Arial" pitchFamily="34" charset="-120"/>
+              </a:rPr>
+              <a:t>Data centers e cargas constantes  </a:t>
+            </a:r>
+            <a:pPr indent="0" marL="0">
               <a:lnSpc>
-                <a:spcPct val="105000"/>
+                <a:spcPct val="112000"/>
               </a:lnSpc>
               <a:buNone/>
             </a:pPr>
             <a:r>
-              <a:rPr lang="en-US" sz="1600" dirty="0">
-                <a:solidFill>
-                  <a:srgbClr val="C6D4DD"/>
-                </a:solidFill>
-                <a:latin typeface="Arial" pitchFamily="34" charset="0"/>
-                <a:ea typeface="Arial" pitchFamily="34" charset="-122"/>
-                <a:cs typeface="Arial" pitchFamily="34" charset="-120"/>
-              </a:rPr>
-              <a:t>previsível</a:t>
-            </a:r>
-            <a:endParaRPr lang="en-US" sz="1600" dirty="0"/>
-          </a:p>
-        </p:txBody>
-      </p:sp>
-      <p:sp>
-        <p:nvSpPr>
-          <p:cNvPr id="11" name="Text 9"/>
-          <p:cNvSpPr/>
-          <p:nvPr/>
-        </p:nvSpPr>
-        <p:spPr>
-          <a:xfrm>
-            <a:off x="1280160" y="3383280"/>
-            <a:ext cx="9601200" cy="1371600"/>
-          </a:xfrm>
-          <a:prstGeom prst="rect">
-            <a:avLst/>
-          </a:prstGeom>
-          <a:noFill/>
-          <a:ln/>
-        </p:spPr>
-        <p:txBody>
-          <a:bodyPr wrap="square" lIns="0" tIns="0" rIns="0" bIns="0" rtlCol="0" anchor="t"/>
-          <a:lstStyle/>
-          <a:p>
-            <a:pPr algn="ctr" indent="0" marL="0">
-              <a:lnSpc>
-                <a:spcPct val="118000"/>
-              </a:lnSpc>
-              <a:buNone/>
-            </a:pPr>
-            <a:r>
-              <a:rPr lang="en-US" sz="2000" b="1" dirty="0">
-                <a:solidFill>
-                  <a:srgbClr val="FFFFFF"/>
-                </a:solidFill>
-                <a:latin typeface="Arial" pitchFamily="34" charset="0"/>
-                <a:ea typeface="Arial" pitchFamily="34" charset="-122"/>
-                <a:cs typeface="Arial" pitchFamily="34" charset="-120"/>
-              </a:rPr>
-              <a:t>O armazenamento de energia deixou de ser uma “promessa futurista” de estabilidade de rede. </a:t>
-            </a:r>
-            <a:pPr algn="ctr" indent="0" marL="0">
-              <a:lnSpc>
-                <a:spcPct val="118000"/>
-              </a:lnSpc>
-              <a:buNone/>
-            </a:pPr>
-            <a:r>
-              <a:rPr lang="en-US" sz="2000" dirty="0">
-                <a:solidFill>
-                  <a:srgbClr val="C6D4DD"/>
-                </a:solidFill>
-                <a:latin typeface="Arial" pitchFamily="34" charset="0"/>
-                <a:ea typeface="Arial" pitchFamily="34" charset="-122"/>
-                <a:cs typeface="Arial" pitchFamily="34" charset="-120"/>
-              </a:rPr>
-              <a:t>Por meio de Peak Shaving, Time Shifting e Geração Compartilhada regulamentada, </a:t>
-            </a:r>
-            <a:pPr algn="ctr" indent="0" marL="0">
-              <a:lnSpc>
-                <a:spcPct val="118000"/>
-              </a:lnSpc>
-              <a:buNone/>
-            </a:pPr>
-            <a:r>
-              <a:rPr lang="en-US" sz="2000" b="1" dirty="0">
-                <a:solidFill>
-                  <a:srgbClr val="F2B705"/>
-                </a:solidFill>
-                <a:latin typeface="Arial" pitchFamily="34" charset="0"/>
-                <a:ea typeface="Arial" pitchFamily="34" charset="-122"/>
-                <a:cs typeface="Arial" pitchFamily="34" charset="-120"/>
-              </a:rPr>
-              <a:t>o BESS é hoje uma máquina de arbitragem financeira validada.</a:t>
-            </a:r>
-            <a:endParaRPr lang="en-US" sz="2000" dirty="0"/>
-          </a:p>
-        </p:txBody>
-      </p:sp>
-      <p:sp>
-        <p:nvSpPr>
-          <p:cNvPr id="12" name="Text 10"/>
-          <p:cNvSpPr/>
-          <p:nvPr/>
-        </p:nvSpPr>
-        <p:spPr>
-          <a:xfrm>
-            <a:off x="1737360" y="4892040"/>
-            <a:ext cx="8686800" cy="1097280"/>
-          </a:xfrm>
-          <a:prstGeom prst="rect">
-            <a:avLst/>
-          </a:prstGeom>
-          <a:noFill/>
-          <a:ln/>
-        </p:spPr>
-        <p:txBody>
-          <a:bodyPr wrap="square" lIns="0" tIns="0" rIns="0" bIns="0" rtlCol="0" anchor="ctr"/>
-          <a:lstStyle/>
-          <a:p>
-            <a:pPr algn="ctr" indent="0" marL="0">
-              <a:lnSpc>
-                <a:spcPct val="118000"/>
-              </a:lnSpc>
-              <a:buNone/>
-            </a:pPr>
-            <a:r>
-              <a:rPr lang="en-US" sz="1300" dirty="0">
-                <a:solidFill>
-                  <a:srgbClr val="8AA0AD"/>
-                </a:solidFill>
-                <a:latin typeface="Arial" pitchFamily="34" charset="0"/>
-                <a:ea typeface="Arial" pitchFamily="34" charset="-122"/>
-                <a:cs typeface="Arial" pitchFamily="34" charset="-120"/>
-              </a:rPr>
-              <a:t>Com custos de CAPEX em declínio, LCOE competitivo (R$ 538/MWh) e TIR na casa dos 21%, a transição para o BESS tornou-se o passo econômico mais lógico para o produtor rural, cooperativas e agroindústrias — e para os investidores que os atendem. O momento da vantagem competitiva e tributária é o presente.</a:t>
-            </a:r>
-            <a:endParaRPr lang="en-US" sz="1300" dirty="0"/>
-          </a:p>
-        </p:txBody>
-      </p:sp>
-      <p:sp>
-        <p:nvSpPr>
-          <p:cNvPr id="14" name="Text 11"/>
+              <a:rPr lang="en-US" sz="1250" dirty="0">
+                <a:solidFill>
+                  <a:srgbClr val="3E4E59"/>
+                </a:solidFill>
+                <a:latin typeface="Arial" pitchFamily="34" charset="0"/>
+                <a:ea typeface="Arial" pitchFamily="34" charset="-122"/>
+                <a:cs typeface="Arial" pitchFamily="34" charset="-120"/>
+              </a:rPr>
+              <a:t>— o potencial de deslocamento temporal é nulo quando a carga é flat 24/7 (equipamentos críticos e climatização). Sem picos e vales acentuados, a bateria não encontra janela operacional econômica para arbitragem.</a:t>
+            </a:r>
+            <a:endParaRPr lang="en-US" sz="1250" dirty="0"/>
+          </a:p>
+        </p:txBody>
+      </p:sp>
+      <p:sp>
+        <p:nvSpPr>
+          <p:cNvPr id="16" name="Text 11"/>
+          <p:cNvSpPr/>
+          <p:nvPr/>
+        </p:nvSpPr>
+        <p:spPr>
+          <a:xfrm>
+            <a:off x="6565392" y="5166360"/>
+            <a:ext cx="4800600" cy="594360"/>
+          </a:xfrm>
+          <a:prstGeom prst="rect">
+            <a:avLst/>
+          </a:prstGeom>
+          <a:noFill/>
+          <a:ln/>
+        </p:spPr>
+        <p:txBody>
+          <a:bodyPr wrap="square" lIns="0" tIns="0" rIns="0" bIns="0" rtlCol="0" anchor="b"/>
+          <a:lstStyle/>
+          <a:p>
+            <a:pPr indent="0" marL="0">
+              <a:buNone/>
+            </a:pPr>
+            <a:r>
+              <a:rPr lang="en-US" sz="1100" i="1" dirty="0">
+                <a:solidFill>
+                  <a:srgbClr val="7A8A94"/>
+                </a:solidFill>
+                <a:latin typeface="Arial" pitchFamily="34" charset="0"/>
+                <a:ea typeface="Arial" pitchFamily="34" charset="-122"/>
+                <a:cs typeface="Arial" pitchFamily="34" charset="-120"/>
+              </a:rPr>
+              <a:t>Regra prática: quanto maior a amplitude entre pico e vale de consumo, maior o valor capturável pelo BESS.</a:t>
+            </a:r>
+            <a:endParaRPr lang="en-US" sz="1100" dirty="0"/>
+          </a:p>
+        </p:txBody>
+      </p:sp>
+      <p:sp>
+        <p:nvSpPr>
+          <p:cNvPr id="18" name="Text 12"/>
           <p:cNvSpPr/>
           <p:nvPr/>
         </p:nvSpPr>
@@ -3739,7 +4003,7 @@
       </p:sp>
       <p:sp>
         <p:nvSpPr>
-          <p:cNvPr id="15" name="Text 12"/>
+          <p:cNvPr id="19" name="Text 13"/>
           <p:cNvSpPr/>
           <p:nvPr/>
         </p:nvSpPr>
@@ -3810,6 +4074,580 @@
       </p:grpSpPr>
       <p:sp>
         <p:nvSpPr>
+          <p:cNvPr id="2" name="Text 0"/>
+          <p:cNvSpPr/>
+          <p:nvPr/>
+        </p:nvSpPr>
+        <p:spPr>
+          <a:xfrm>
+            <a:off x="548640" y="457200"/>
+            <a:ext cx="11064240" cy="731520"/>
+          </a:xfrm>
+          <a:prstGeom prst="rect">
+            <a:avLst/>
+          </a:prstGeom>
+          <a:noFill/>
+          <a:ln/>
+        </p:spPr>
+        <p:txBody>
+          <a:bodyPr wrap="square" lIns="0" tIns="0" rIns="0" bIns="0" rtlCol="0" anchor="ctr"/>
+          <a:lstStyle/>
+          <a:p>
+            <a:pPr indent="0" marL="0">
+              <a:buNone/>
+            </a:pPr>
+            <a:r>
+              <a:rPr lang="en-US" sz="3000" b="1" dirty="0">
+                <a:solidFill>
+                  <a:srgbClr val="FFFFFF"/>
+                </a:solidFill>
+                <a:latin typeface="Arial" pitchFamily="34" charset="0"/>
+                <a:ea typeface="Arial" pitchFamily="34" charset="-122"/>
+                <a:cs typeface="Arial" pitchFamily="34" charset="-120"/>
+              </a:rPr>
+              <a:t>Síntese: a matriz energética foi redesenhada</a:t>
+            </a:r>
+            <a:endParaRPr lang="en-US" sz="3000" dirty="0"/>
+          </a:p>
+        </p:txBody>
+      </p:sp>
+      <p:sp>
+        <p:nvSpPr>
+          <p:cNvPr id="3" name="Shape 1"/>
+          <p:cNvSpPr/>
+          <p:nvPr/>
+        </p:nvSpPr>
+        <p:spPr>
+          <a:xfrm>
+            <a:off x="1051560" y="1691640"/>
+            <a:ext cx="2834640" cy="1234440"/>
+          </a:xfrm>
+          <a:prstGeom prst="roundRect">
+            <a:avLst>
+              <a:gd name="adj" fmla="val 5926"/>
+            </a:avLst>
+          </a:prstGeom>
+          <a:solidFill>
+            <a:srgbClr val="102A3C"/>
+          </a:solidFill>
+          <a:ln w="19050">
+            <a:solidFill>
+              <a:srgbClr val="3D5668"/>
+            </a:solidFill>
+            <a:prstDash val="solid"/>
+          </a:ln>
+        </p:spPr>
+      </p:sp>
+      <p:sp>
+        <p:nvSpPr>
+          <p:cNvPr id="4" name="Text 2"/>
+          <p:cNvSpPr/>
+          <p:nvPr/>
+        </p:nvSpPr>
+        <p:spPr>
+          <a:xfrm>
+            <a:off x="1051560" y="1691640"/>
+            <a:ext cx="2834640" cy="1234440"/>
+          </a:xfrm>
+          <a:prstGeom prst="rect">
+            <a:avLst/>
+          </a:prstGeom>
+          <a:noFill/>
+          <a:ln/>
+        </p:spPr>
+        <p:txBody>
+          <a:bodyPr wrap="square" lIns="1270" tIns="1270" rIns="1270" bIns="1270" rtlCol="0" anchor="ctr"/>
+          <a:lstStyle/>
+          <a:p>
+            <a:pPr algn="ctr" indent="0" marL="0">
+              <a:lnSpc>
+                <a:spcPct val="105000"/>
+              </a:lnSpc>
+              <a:buNone/>
+            </a:pPr>
+            <a:r>
+              <a:rPr lang="en-US" sz="1600" dirty="0">
+                <a:solidFill>
+                  <a:srgbClr val="C6D4DD"/>
+                </a:solidFill>
+                <a:latin typeface="Arial" pitchFamily="34" charset="0"/>
+                <a:ea typeface="Arial" pitchFamily="34" charset="-122"/>
+                <a:cs typeface="Arial" pitchFamily="34" charset="-120"/>
+              </a:rPr>
+              <a:t>Elétrons</a:t>
+            </a:r>
+            <a:endParaRPr lang="en-US" sz="1600" dirty="0"/>
+          </a:p>
+          <a:p>
+            <a:pPr algn="ctr" indent="0" marL="0">
+              <a:lnSpc>
+                <a:spcPct val="105000"/>
+              </a:lnSpc>
+              <a:buNone/>
+            </a:pPr>
+            <a:r>
+              <a:rPr lang="en-US" sz="1600" dirty="0">
+                <a:solidFill>
+                  <a:srgbClr val="C6D4DD"/>
+                </a:solidFill>
+                <a:latin typeface="Arial" pitchFamily="34" charset="0"/>
+                <a:ea typeface="Arial" pitchFamily="34" charset="-122"/>
+                <a:cs typeface="Arial" pitchFamily="34" charset="-120"/>
+              </a:rPr>
+              <a:t>intermitentes</a:t>
+            </a:r>
+            <a:endParaRPr lang="en-US" sz="1600" dirty="0"/>
+          </a:p>
+        </p:txBody>
+      </p:sp>
+      <p:sp>
+        <p:nvSpPr>
+          <p:cNvPr id="5" name="Shape 3"/>
+          <p:cNvSpPr/>
+          <p:nvPr/>
+        </p:nvSpPr>
+        <p:spPr>
+          <a:xfrm>
+            <a:off x="4050792" y="2162556"/>
+            <a:ext cx="457200" cy="292608"/>
+          </a:xfrm>
+          <a:prstGeom prst="rightArrow">
+            <a:avLst/>
+          </a:prstGeom>
+          <a:solidFill>
+            <a:srgbClr val="F2B705"/>
+          </a:solidFill>
+          <a:ln/>
+        </p:spPr>
+      </p:sp>
+      <p:sp>
+        <p:nvSpPr>
+          <p:cNvPr id="6" name="Shape 4"/>
+          <p:cNvSpPr/>
+          <p:nvPr/>
+        </p:nvSpPr>
+        <p:spPr>
+          <a:xfrm>
+            <a:off x="4681728" y="1691640"/>
+            <a:ext cx="2834640" cy="1234440"/>
+          </a:xfrm>
+          <a:prstGeom prst="roundRect">
+            <a:avLst>
+              <a:gd name="adj" fmla="val 5926"/>
+            </a:avLst>
+          </a:prstGeom>
+          <a:solidFill>
+            <a:srgbClr val="102A3C"/>
+          </a:solidFill>
+          <a:ln w="31750">
+            <a:solidFill>
+              <a:srgbClr val="F2B705"/>
+            </a:solidFill>
+            <a:prstDash val="solid"/>
+          </a:ln>
+        </p:spPr>
+      </p:sp>
+      <p:sp>
+        <p:nvSpPr>
+          <p:cNvPr id="7" name="Text 5"/>
+          <p:cNvSpPr/>
+          <p:nvPr/>
+        </p:nvSpPr>
+        <p:spPr>
+          <a:xfrm>
+            <a:off x="4681728" y="1691640"/>
+            <a:ext cx="2834640" cy="1234440"/>
+          </a:xfrm>
+          <a:prstGeom prst="rect">
+            <a:avLst/>
+          </a:prstGeom>
+          <a:noFill/>
+          <a:ln/>
+        </p:spPr>
+        <p:txBody>
+          <a:bodyPr wrap="square" lIns="1270" tIns="1270" rIns="1270" bIns="1270" rtlCol="0" anchor="ctr"/>
+          <a:lstStyle/>
+          <a:p>
+            <a:pPr algn="ctr" indent="0" marL="0">
+              <a:lnSpc>
+                <a:spcPct val="105000"/>
+              </a:lnSpc>
+              <a:buNone/>
+            </a:pPr>
+            <a:r>
+              <a:rPr lang="en-US" sz="1600" b="1" dirty="0">
+                <a:solidFill>
+                  <a:srgbClr val="F2B705"/>
+                </a:solidFill>
+                <a:latin typeface="Arial" pitchFamily="34" charset="0"/>
+                <a:ea typeface="Arial" pitchFamily="34" charset="-122"/>
+                <a:cs typeface="Arial" pitchFamily="34" charset="-120"/>
+              </a:rPr>
+              <a:t>BESS</a:t>
+            </a:r>
+            <a:endParaRPr lang="en-US" sz="1600" dirty="0"/>
+          </a:p>
+          <a:p>
+            <a:pPr algn="ctr" indent="0" marL="0">
+              <a:lnSpc>
+                <a:spcPct val="105000"/>
+              </a:lnSpc>
+              <a:buNone/>
+            </a:pPr>
+            <a:r>
+              <a:rPr lang="en-US" sz="1600" b="1" dirty="0">
+                <a:solidFill>
+                  <a:srgbClr val="F2B705"/>
+                </a:solidFill>
+                <a:latin typeface="Arial" pitchFamily="34" charset="0"/>
+                <a:ea typeface="Arial" pitchFamily="34" charset="-122"/>
+                <a:cs typeface="Arial" pitchFamily="34" charset="-120"/>
+              </a:rPr>
+              <a:t>filtro de regulação</a:t>
+            </a:r>
+            <a:endParaRPr lang="en-US" sz="1600" dirty="0"/>
+          </a:p>
+        </p:txBody>
+      </p:sp>
+      <p:sp>
+        <p:nvSpPr>
+          <p:cNvPr id="8" name="Shape 6"/>
+          <p:cNvSpPr/>
+          <p:nvPr/>
+        </p:nvSpPr>
+        <p:spPr>
+          <a:xfrm>
+            <a:off x="7680960" y="2162556"/>
+            <a:ext cx="457200" cy="292608"/>
+          </a:xfrm>
+          <a:prstGeom prst="rightArrow">
+            <a:avLst/>
+          </a:prstGeom>
+          <a:solidFill>
+            <a:srgbClr val="F2B705"/>
+          </a:solidFill>
+          <a:ln/>
+        </p:spPr>
+      </p:sp>
+      <p:sp>
+        <p:nvSpPr>
+          <p:cNvPr id="9" name="Shape 7"/>
+          <p:cNvSpPr/>
+          <p:nvPr/>
+        </p:nvSpPr>
+        <p:spPr>
+          <a:xfrm>
+            <a:off x="8311896" y="1691640"/>
+            <a:ext cx="2834640" cy="1234440"/>
+          </a:xfrm>
+          <a:prstGeom prst="roundRect">
+            <a:avLst>
+              <a:gd name="adj" fmla="val 5926"/>
+            </a:avLst>
+          </a:prstGeom>
+          <a:solidFill>
+            <a:srgbClr val="102A3C"/>
+          </a:solidFill>
+          <a:ln w="19050">
+            <a:solidFill>
+              <a:srgbClr val="3D5668"/>
+            </a:solidFill>
+            <a:prstDash val="solid"/>
+          </a:ln>
+        </p:spPr>
+      </p:sp>
+      <p:sp>
+        <p:nvSpPr>
+          <p:cNvPr id="10" name="Text 8"/>
+          <p:cNvSpPr/>
+          <p:nvPr/>
+        </p:nvSpPr>
+        <p:spPr>
+          <a:xfrm>
+            <a:off x="8311896" y="1691640"/>
+            <a:ext cx="2834640" cy="1234440"/>
+          </a:xfrm>
+          <a:prstGeom prst="rect">
+            <a:avLst/>
+          </a:prstGeom>
+          <a:noFill/>
+          <a:ln/>
+        </p:spPr>
+        <p:txBody>
+          <a:bodyPr wrap="square" lIns="1270" tIns="1270" rIns="1270" bIns="1270" rtlCol="0" anchor="ctr"/>
+          <a:lstStyle/>
+          <a:p>
+            <a:pPr algn="ctr" indent="0" marL="0">
+              <a:lnSpc>
+                <a:spcPct val="105000"/>
+              </a:lnSpc>
+              <a:buNone/>
+            </a:pPr>
+            <a:r>
+              <a:rPr lang="en-US" sz="1600" dirty="0">
+                <a:solidFill>
+                  <a:srgbClr val="C6D4DD"/>
+                </a:solidFill>
+                <a:latin typeface="Arial" pitchFamily="34" charset="0"/>
+                <a:ea typeface="Arial" pitchFamily="34" charset="-122"/>
+                <a:cs typeface="Arial" pitchFamily="34" charset="-120"/>
+              </a:rPr>
+              <a:t>Yield financeiro</a:t>
+            </a:r>
+            <a:endParaRPr lang="en-US" sz="1600" dirty="0"/>
+          </a:p>
+          <a:p>
+            <a:pPr algn="ctr" indent="0" marL="0">
+              <a:lnSpc>
+                <a:spcPct val="105000"/>
+              </a:lnSpc>
+              <a:buNone/>
+            </a:pPr>
+            <a:r>
+              <a:rPr lang="en-US" sz="1600" dirty="0">
+                <a:solidFill>
+                  <a:srgbClr val="C6D4DD"/>
+                </a:solidFill>
+                <a:latin typeface="Arial" pitchFamily="34" charset="0"/>
+                <a:ea typeface="Arial" pitchFamily="34" charset="-122"/>
+                <a:cs typeface="Arial" pitchFamily="34" charset="-120"/>
+              </a:rPr>
+              <a:t>previsível</a:t>
+            </a:r>
+            <a:endParaRPr lang="en-US" sz="1600" dirty="0"/>
+          </a:p>
+        </p:txBody>
+      </p:sp>
+      <p:sp>
+        <p:nvSpPr>
+          <p:cNvPr id="11" name="Text 9"/>
+          <p:cNvSpPr/>
+          <p:nvPr/>
+        </p:nvSpPr>
+        <p:spPr>
+          <a:xfrm>
+            <a:off x="1280160" y="3383280"/>
+            <a:ext cx="9601200" cy="1371600"/>
+          </a:xfrm>
+          <a:prstGeom prst="rect">
+            <a:avLst/>
+          </a:prstGeom>
+          <a:noFill/>
+          <a:ln/>
+        </p:spPr>
+        <p:txBody>
+          <a:bodyPr wrap="square" lIns="0" tIns="0" rIns="0" bIns="0" rtlCol="0" anchor="t"/>
+          <a:lstStyle/>
+          <a:p>
+            <a:pPr algn="ctr" indent="0" marL="0">
+              <a:lnSpc>
+                <a:spcPct val="118000"/>
+              </a:lnSpc>
+              <a:buNone/>
+            </a:pPr>
+            <a:r>
+              <a:rPr lang="en-US" sz="2000" b="1" dirty="0">
+                <a:solidFill>
+                  <a:srgbClr val="FFFFFF"/>
+                </a:solidFill>
+                <a:latin typeface="Arial" pitchFamily="34" charset="0"/>
+                <a:ea typeface="Arial" pitchFamily="34" charset="-122"/>
+                <a:cs typeface="Arial" pitchFamily="34" charset="-120"/>
+              </a:rPr>
+              <a:t>O armazenamento de energia deixou de ser uma “promessa futurista” de estabilidade de rede. </a:t>
+            </a:r>
+            <a:pPr algn="ctr" indent="0" marL="0">
+              <a:lnSpc>
+                <a:spcPct val="118000"/>
+              </a:lnSpc>
+              <a:buNone/>
+            </a:pPr>
+            <a:r>
+              <a:rPr lang="en-US" sz="2000" dirty="0">
+                <a:solidFill>
+                  <a:srgbClr val="C6D4DD"/>
+                </a:solidFill>
+                <a:latin typeface="Arial" pitchFamily="34" charset="0"/>
+                <a:ea typeface="Arial" pitchFamily="34" charset="-122"/>
+                <a:cs typeface="Arial" pitchFamily="34" charset="-120"/>
+              </a:rPr>
+              <a:t>Por meio de Peak Shaving, Time Shifting e Geração Compartilhada regulamentada, </a:t>
+            </a:r>
+            <a:pPr algn="ctr" indent="0" marL="0">
+              <a:lnSpc>
+                <a:spcPct val="118000"/>
+              </a:lnSpc>
+              <a:buNone/>
+            </a:pPr>
+            <a:r>
+              <a:rPr lang="en-US" sz="2000" b="1" dirty="0">
+                <a:solidFill>
+                  <a:srgbClr val="F2B705"/>
+                </a:solidFill>
+                <a:latin typeface="Arial" pitchFamily="34" charset="0"/>
+                <a:ea typeface="Arial" pitchFamily="34" charset="-122"/>
+                <a:cs typeface="Arial" pitchFamily="34" charset="-120"/>
+              </a:rPr>
+              <a:t>o BESS é hoje uma máquina de arbitragem financeira validada.</a:t>
+            </a:r>
+            <a:endParaRPr lang="en-US" sz="2000" dirty="0"/>
+          </a:p>
+        </p:txBody>
+      </p:sp>
+      <p:sp>
+        <p:nvSpPr>
+          <p:cNvPr id="12" name="Text 10"/>
+          <p:cNvSpPr/>
+          <p:nvPr/>
+        </p:nvSpPr>
+        <p:spPr>
+          <a:xfrm>
+            <a:off x="1737360" y="4892040"/>
+            <a:ext cx="8686800" cy="1097280"/>
+          </a:xfrm>
+          <a:prstGeom prst="rect">
+            <a:avLst/>
+          </a:prstGeom>
+          <a:noFill/>
+          <a:ln/>
+        </p:spPr>
+        <p:txBody>
+          <a:bodyPr wrap="square" lIns="0" tIns="0" rIns="0" bIns="0" rtlCol="0" anchor="ctr"/>
+          <a:lstStyle/>
+          <a:p>
+            <a:pPr algn="ctr" indent="0" marL="0">
+              <a:lnSpc>
+                <a:spcPct val="118000"/>
+              </a:lnSpc>
+              <a:buNone/>
+            </a:pPr>
+            <a:r>
+              <a:rPr lang="en-US" sz="1300" dirty="0">
+                <a:solidFill>
+                  <a:srgbClr val="8AA0AD"/>
+                </a:solidFill>
+                <a:latin typeface="Arial" pitchFamily="34" charset="0"/>
+                <a:ea typeface="Arial" pitchFamily="34" charset="-122"/>
+                <a:cs typeface="Arial" pitchFamily="34" charset="-120"/>
+              </a:rPr>
+              <a:t>Com custos de CAPEX em declínio, LCOE competitivo (R$ 538/MWh), TIR de 21% a 28% e payback de ≈ 5 anos na irrigação bombeada, a transição para o BESS tornou-se o passo econômico mais lógico para o produtor rural, cooperativas e agroindústrias. O momento da vantagem competitiva e tributária é o presente.</a:t>
+            </a:r>
+            <a:endParaRPr lang="en-US" sz="1300" dirty="0"/>
+          </a:p>
+        </p:txBody>
+      </p:sp>
+      <p:sp>
+        <p:nvSpPr>
+          <p:cNvPr id="14" name="Text 11"/>
+          <p:cNvSpPr/>
+          <p:nvPr/>
+        </p:nvSpPr>
+        <p:spPr>
+          <a:xfrm>
+            <a:off x="548640" y="6473952"/>
+            <a:ext cx="5029200" cy="274320"/>
+          </a:xfrm>
+          <a:prstGeom prst="rect">
+            <a:avLst/>
+          </a:prstGeom>
+          <a:noFill/>
+          <a:ln/>
+        </p:spPr>
+        <p:txBody>
+          <a:bodyPr wrap="square" lIns="0" tIns="0" rIns="0" bIns="0" rtlCol="0" anchor="ctr"/>
+          <a:lstStyle/>
+          <a:p>
+            <a:pPr algn="l" indent="0" marL="0">
+              <a:buNone/>
+            </a:pPr>
+            <a:r>
+              <a:rPr lang="en-US" sz="850" dirty="0">
+                <a:solidFill>
+                  <a:srgbClr val="7A8A94"/>
+                </a:solidFill>
+                <a:latin typeface="Arial" pitchFamily="34" charset="0"/>
+                <a:ea typeface="Arial" pitchFamily="34" charset="-122"/>
+                <a:cs typeface="Arial" pitchFamily="34" charset="-120"/>
+              </a:rPr>
+              <a:t>Eng. Lucas Silva Costa  ·  CREA-MT 029137</a:t>
+            </a:r>
+            <a:endParaRPr lang="en-US" sz="850" dirty="0"/>
+          </a:p>
+        </p:txBody>
+      </p:sp>
+      <p:sp>
+        <p:nvSpPr>
+          <p:cNvPr id="15" name="Text 12"/>
+          <p:cNvSpPr/>
+          <p:nvPr/>
+        </p:nvSpPr>
+        <p:spPr>
+          <a:xfrm>
+            <a:off x="11274552" y="6473952"/>
+            <a:ext cx="457200" cy="274320"/>
+          </a:xfrm>
+          <a:prstGeom prst="rect">
+            <a:avLst/>
+          </a:prstGeom>
+          <a:noFill/>
+          <a:ln/>
+        </p:spPr>
+        <p:txBody>
+          <a:bodyPr wrap="square" lIns="0" tIns="0" rIns="0" bIns="0" rtlCol="0" anchor="ctr"/>
+          <a:lstStyle/>
+          <a:p>
+            <a:pPr algn="r" indent="0" marL="0">
+              <a:buNone/>
+            </a:pPr>
+            <a:r>
+              <a:rPr lang="en-US" sz="850" dirty="0">
+                <a:solidFill>
+                  <a:srgbClr val="7A8A94"/>
+                </a:solidFill>
+                <a:latin typeface="Arial" pitchFamily="34" charset="0"/>
+                <a:ea typeface="Arial" pitchFamily="34" charset="-122"/>
+                <a:cs typeface="Arial" pitchFamily="34" charset="-120"/>
+              </a:rPr>
+              <a:t>13</a:t>
+            </a:r>
+            <a:endParaRPr lang="en-US" sz="850" dirty="0"/>
+          </a:p>
+        </p:txBody>
+      </p:sp>
+    </p:spTree>
+  </p:cSld>
+  <p:clrMapOvr>
+    <a:masterClrMapping/>
+  </p:clrMapOvr>
+</p:sld>
+</file>
+
+<file path=ppt/slides/slide14.xml><?xml version="1.0" encoding="utf-8"?>
+<p:sld xmlns:a="http://schemas.openxmlformats.org/drawingml/2006/main" xmlns:r="http://schemas.openxmlformats.org/officeDocument/2006/relationships" xmlns:p="http://schemas.openxmlformats.org/presentationml/2006/main">
+  <p:cSld name="Slide 14">
+    <p:bg>
+      <p:bgPr>
+        <a:solidFill>
+          <a:srgbClr val="102A3C"/>
+        </a:solidFill>
+      </p:bgPr>
+    </p:bg>
+    <p:spTree>
+      <p:nvGrpSpPr>
+        <p:cNvPr id="1" name=""/>
+        <p:cNvGrpSpPr/>
+        <p:nvPr/>
+      </p:nvGrpSpPr>
+      <p:grpSpPr>
+        <a:xfrm>
+          <a:off x="0" y="0"/>
+          <a:ext cx="0" cy="0"/>
+          <a:chOff x="0" y="0"/>
+          <a:chExt cx="0" cy="0"/>
+        </a:xfrm>
+      </p:grpSpPr>
+      <p:sp>
+        <p:nvSpPr>
           <p:cNvPr id="2" name="Shape 0"/>
           <p:cNvSpPr/>
           <p:nvPr/>
@@ -4155,7 +4993,7 @@
                 <a:ea typeface="Arial" pitchFamily="34" charset="-122"/>
                 <a:cs typeface="Arial" pitchFamily="34" charset="-120"/>
               </a:rPr>
-              <a:t>13</a:t>
+              <a:t>14</a:t>
             </a:r>
             <a:endParaRPr lang="en-US" sz="850" dirty="0"/>
           </a:p>
@@ -4703,7 +5541,7 @@
                 <a:ea typeface="Arial" pitchFamily="34" charset="-122"/>
                 <a:cs typeface="Arial" pitchFamily="34" charset="-120"/>
               </a:rPr>
-              <a:t>Indicadores robustos em projetos híbridos de Geração Compartilhada — modelo com vocação natural para o agro: TIR superior a 21% e payback inferior a 8 anos superam o custo de oportunidade do capital.</a:t>
+              <a:t>Indicadores robustos em projetos híbridos de Geração Compartilhada — modelo com vocação natural para o agro: TIR de até 28% e payback de aproximadamente 5 anos em operações com irrigação bombeada.</a:t>
             </a:r>
             <a:endParaRPr lang="en-US" sz="1250" dirty="0"/>
           </a:p>
@@ -8901,7 +9739,7 @@
                 <a:ea typeface="Arial" pitchFamily="34" charset="-122"/>
                 <a:cs typeface="Arial" pitchFamily="34" charset="-120"/>
               </a:rPr>
-              <a:t>Projeção de fluxo de caixa para 20 anos  ·  tarifa B3 (CEMIG-D) com desconto de 27% na cota  ·  TMA referenciada em 15% a.a. (Selic base).</a:t>
+              <a:t>Cenário agro otimizado: irrigação bombeada no horário reservado do irrigante + crédito do Plano Safra  ·  tarifa B3 (CEMIG-D)  ·  TMA 15% a.a.</a:t>
             </a:r>
             <a:endParaRPr lang="en-US" sz="1250" dirty="0"/>
           </a:p>
@@ -8974,7 +9812,7 @@
                 <a:ea typeface="Arial" pitchFamily="34" charset="-122"/>
                 <a:cs typeface="Arial" pitchFamily="34" charset="-120"/>
               </a:rPr>
-              <a:t>21,00%</a:t>
+              <a:t>28,00%</a:t>
             </a:r>
             <a:endParaRPr lang="en-US" sz="3800" dirty="0"/>
           </a:p>
@@ -9055,7 +9893,7 @@
                 <a:ea typeface="Arial" pitchFamily="34" charset="-122"/>
                 <a:cs typeface="Arial" pitchFamily="34" charset="-120"/>
               </a:rPr>
-              <a:t>Supera com folga o custo de oportunidade e os ativos de renda fixa.</a:t>
+              <a:t>No cenário base, 21%; as alavancas do agro elevam o retorno muito acima da renda fixa.</a:t>
             </a:r>
             <a:endParaRPr lang="en-US" sz="1100" dirty="0"/>
           </a:p>
@@ -9120,7 +9958,7 @@
               <a:buNone/>
             </a:pPr>
             <a:r>
-              <a:rPr lang="en-US" sz="3000" b="1" dirty="0">
+              <a:rPr lang="en-US" sz="3800" b="1" dirty="0">
                 <a:solidFill>
                   <a:srgbClr val="2E7DAF"/>
                 </a:solidFill>
@@ -9128,9 +9966,9 @@
                 <a:ea typeface="Arial" pitchFamily="34" charset="-122"/>
                 <a:cs typeface="Arial" pitchFamily="34" charset="-120"/>
               </a:rPr>
-              <a:t>7 anos e 9 meses</a:t>
-            </a:r>
-            <a:endParaRPr lang="en-US" sz="3000" dirty="0"/>
+              <a:t>≈ 5 anos</a:t>
+            </a:r>
+            <a:endParaRPr lang="en-US" sz="3800" dirty="0"/>
           </a:p>
         </p:txBody>
       </p:sp>
@@ -9209,7 +10047,7 @@
                 <a:ea typeface="Arial" pitchFamily="34" charset="-122"/>
                 <a:cs typeface="Arial" pitchFamily="34" charset="-120"/>
               </a:rPr>
-              <a:t>Ponto de recuperação integral do capital investido de R$ 13,9 milhões.</a:t>
+              <a:t>Recuperação do capital de R$ 13,9 milhões (cenário base, sem alavancas agro: 7 anos e 9 meses).</a:t>
             </a:r>
             <a:endParaRPr lang="en-US" sz="1100" dirty="0"/>
           </a:p>
@@ -9282,7 +10120,7 @@
                 <a:ea typeface="Arial" pitchFamily="34" charset="-122"/>
                 <a:cs typeface="Arial" pitchFamily="34" charset="-120"/>
               </a:rPr>
-              <a:t>R$ 6,37 mi</a:t>
+              <a:t>R$ 11,1 mi</a:t>
             </a:r>
             <a:endParaRPr lang="en-US" sz="3800" dirty="0"/>
           </a:p>

</xml_diff>

<commit_message>
Adapta estudo de caso tributário de ICMS para Mato Grosso
Substitui o estudo de Minas Gerais por Mato Grosso: adesão ao Convênio
ICMS 16/2015 em 2015 (isenção sobre energia compensada desde 2016,
alíquota de 17%), mesma trajetória de retomada gradual (redução de 20%
a.a. a partir de 2029, fim em 2033) e bônus agro do Decreto MT
1.971/2026 (ICMS zero em equipamentos de irrigação). Troca a
distribuidora de referência de CEMIG-D para Energisa-MT nos slides de
fluxo de receita e dashboard.

Co-Authored-By: Claude Fable 5 <noreply@anthropic.com>
Claude-Session: https://claude.ai/code/session_0198SeXLUYPhAzabpjaRsyNb
</commit_message>
<xml_diff>
--- a/apresentacoes/BESS_Brasil_Lucas_Silva_Costa.pptx
+++ b/apresentacoes/BESS_Brasil_Lucas_Silva_Costa.pptx
@@ -1571,7 +1571,7 @@
           <a:p>
             <a:r>
               <a:rPr lang="en-US" dirty="0"/>
-              <a:t>A isenção de ICMS decresce 20 p.p. ao ano a partir de 2029. Entrar cedo captura os anos de maior geração de caixa.</a:t>
+              <a:t>MT: isenção de ICMS (17%) sobre energia compensada desde 2016; redução de 20% a.a. a partir de 2029 e fim em 2033. Bônus: ICMS zero em equipamentos de irrigação até 31/12/2026 reduz o CAPEX do bombeamento.</a:t>
             </a:r>
             <a:endParaRPr lang="en-US" dirty="0"/>
           </a:p>
@@ -7930,7 +7930,7 @@
                 <a:ea typeface="Arial" pitchFamily="34" charset="-122"/>
                 <a:cs typeface="Arial" pitchFamily="34" charset="-120"/>
               </a:rPr>
-              <a:t>UFV + BESS maximizam a injeção diária na rede da distribuidora (ex.: CEMIG-D).</a:t>
+              <a:t>UFV + BESS maximizam a injeção diária na rede da distribuidora (ex.: Energisa-MT).</a:t>
             </a:r>
             <a:endParaRPr lang="en-US" sz="1050" dirty="0"/>
           </a:p>
@@ -9339,7 +9339,7 @@
                 <a:ea typeface="Arial" pitchFamily="34" charset="-122"/>
                 <a:cs typeface="Arial" pitchFamily="34" charset="-120"/>
               </a:rPr>
-              <a:t>A Janela de Oportunidade Tributária  |  estudo: Minas Gerais</a:t>
+              <a:t>A Janela de Oportunidade Tributária  |  estudo: Mato Grosso</a:t>
             </a:r>
             <a:endParaRPr lang="en-US" sz="3000" dirty="0"/>
           </a:p>
@@ -9411,8 +9411,8 @@
         </p:nvSpPr>
         <p:spPr>
           <a:xfrm>
-            <a:off x="8293608" y="1847088"/>
-            <a:ext cx="566928" cy="566928"/>
+            <a:off x="8293608" y="1828800"/>
+            <a:ext cx="548640" cy="548640"/>
           </a:xfrm>
           <a:prstGeom prst="ellipse">
             <a:avLst/>
@@ -9439,8 +9439,8 @@
         </p:blipFill>
         <p:spPr>
           <a:xfrm>
-            <a:off x="8418332" y="1971812"/>
-            <a:ext cx="317480" cy="317480"/>
+            <a:off x="8414309" y="1949501"/>
+            <a:ext cx="307238" cy="307238"/>
           </a:xfrm>
           <a:prstGeom prst="rect">
             <a:avLst/>
@@ -9455,8 +9455,8 @@
         </p:nvSpPr>
         <p:spPr>
           <a:xfrm>
-            <a:off x="8293608" y="2578608"/>
-            <a:ext cx="3054096" cy="594360"/>
+            <a:off x="8293608" y="2468880"/>
+            <a:ext cx="3054096" cy="457200"/>
           </a:xfrm>
           <a:prstGeom prst="rect">
             <a:avLst/>
@@ -9472,7 +9472,7 @@
               <a:buNone/>
             </a:pPr>
             <a:r>
-              <a:rPr lang="en-US" sz="1650" b="1" dirty="0">
+              <a:rPr lang="en-US" sz="1600" b="1" dirty="0">
                 <a:solidFill>
                   <a:srgbClr val="16303F"/>
                 </a:solidFill>
@@ -9482,7 +9482,7 @@
               </a:rPr>
               <a:t>O tempo é a variável crítica</a:t>
             </a:r>
-            <a:endParaRPr lang="en-US" sz="1650" dirty="0"/>
+            <a:endParaRPr lang="en-US" sz="1600" dirty="0"/>
           </a:p>
         </p:txBody>
       </p:sp>
@@ -9494,8 +9494,8 @@
         </p:nvSpPr>
         <p:spPr>
           <a:xfrm>
-            <a:off x="8293608" y="3200400"/>
-            <a:ext cx="3054096" cy="2560320"/>
+            <a:off x="8293608" y="2971800"/>
+            <a:ext cx="3054096" cy="2788920"/>
           </a:xfrm>
           <a:prstGeom prst="rect">
             <a:avLst/>
@@ -9509,12 +9509,12 @@
           <a:p>
             <a:pPr indent="0" marL="0">
               <a:lnSpc>
-                <a:spcPct val="113000"/>
+                <a:spcPct val="110000"/>
               </a:lnSpc>
               <a:buNone/>
             </a:pPr>
             <a:r>
-              <a:rPr lang="en-US" sz="1250" dirty="0">
+              <a:rPr lang="en-US" sz="1150" dirty="0">
                 <a:solidFill>
                   <a:srgbClr val="3E4E59"/>
                 </a:solidFill>
@@ -9522,28 +9522,28 @@
                 <a:ea typeface="Arial" pitchFamily="34" charset="-122"/>
                 <a:cs typeface="Arial" pitchFamily="34" charset="-120"/>
               </a:rPr>
-              <a:t>O Convênio ICMS nº 16/2015 garantiu isenção sobre a energia compensada.</a:t>
-            </a:r>
-            <a:endParaRPr lang="en-US" sz="1250" dirty="0"/>
+              <a:t>MT aderiu ao Convênio ICMS nº 16/2015 já em 2015: desde 2016, a energia compensada é isenta do ICMS (alíquota de 17%).</a:t>
+            </a:r>
+            <a:endParaRPr lang="en-US" sz="1150" dirty="0"/>
           </a:p>
           <a:p>
             <a:pPr indent="0" marL="0">
               <a:lnSpc>
-                <a:spcPct val="113000"/>
+                <a:spcPct val="110000"/>
               </a:lnSpc>
               <a:buNone/>
             </a:pPr>
-            <a:endParaRPr lang="en-US" sz="1250" dirty="0"/>
+            <a:endParaRPr lang="en-US" sz="1150" dirty="0"/>
           </a:p>
           <a:p>
             <a:pPr indent="0" marL="0">
               <a:lnSpc>
-                <a:spcPct val="113000"/>
+                <a:spcPct val="110000"/>
               </a:lnSpc>
               <a:buNone/>
             </a:pPr>
             <a:r>
-              <a:rPr lang="en-US" sz="1250" dirty="0">
+              <a:rPr lang="en-US" sz="1150" dirty="0">
                 <a:solidFill>
                   <a:srgbClr val="3E4E59"/>
                 </a:solidFill>
@@ -9551,15 +9551,83 @@
                 <a:ea typeface="Arial" pitchFamily="34" charset="-122"/>
                 <a:cs typeface="Arial" pitchFamily="34" charset="-120"/>
               </a:rPr>
-              <a:t>Com a retomada gradual da cobrança a partir de 2029, investidores devem posicionar seus ativos de capital intensivo (UFV + BESS) imediatamente, maximizando o fluxo de caixa líquido nos primeiros anos de operação.</a:t>
-            </a:r>
-            <a:endParaRPr lang="en-US" sz="1250" dirty="0"/>
-          </a:p>
-        </p:txBody>
-      </p:sp>
-      <p:sp>
-        <p:nvSpPr>
-          <p:cNvPr id="10" name="Text 5"/>
+              <a:t>O benefício é pleno até 2028, cai 20% ao ano a partir de 2029 e termina em 2033 — posicionar a UFV + BESS agora maximiza o caixa dos melhores anos.</a:t>
+            </a:r>
+            <a:endParaRPr lang="en-US" sz="1150" dirty="0"/>
+          </a:p>
+          <a:p>
+            <a:pPr indent="0" marL="0">
+              <a:lnSpc>
+                <a:spcPct val="110000"/>
+              </a:lnSpc>
+              <a:buNone/>
+            </a:pPr>
+            <a:endParaRPr lang="en-US" sz="1150" dirty="0"/>
+          </a:p>
+          <a:p>
+            <a:pPr indent="0" marL="0">
+              <a:lnSpc>
+                <a:spcPct val="110000"/>
+              </a:lnSpc>
+              <a:buNone/>
+            </a:pPr>
+            <a:r>
+              <a:rPr lang="en-US" sz="1150" dirty="0">
+                <a:solidFill>
+                  <a:srgbClr val="3E4E59"/>
+                </a:solidFill>
+                <a:latin typeface="Arial" pitchFamily="34" charset="0"/>
+                <a:ea typeface="Arial" pitchFamily="34" charset="-122"/>
+                <a:cs typeface="Arial" pitchFamily="34" charset="-120"/>
+              </a:rPr>
+              <a:t>Bônus agro: ICMS zero em equipamentos de irrigação (Decreto nº 1.971/2026).</a:t>
+            </a:r>
+            <a:endParaRPr lang="en-US" sz="1150" dirty="0"/>
+          </a:p>
+        </p:txBody>
+      </p:sp>
+      <p:sp>
+        <p:nvSpPr>
+          <p:cNvPr id="9" name="Text 5"/>
+          <p:cNvSpPr/>
+          <p:nvPr/>
+        </p:nvSpPr>
+        <p:spPr>
+          <a:xfrm>
+            <a:off x="594360" y="6144768"/>
+            <a:ext cx="6949440" cy="256032"/>
+          </a:xfrm>
+          <a:prstGeom prst="rect">
+            <a:avLst/>
+          </a:prstGeom>
+          <a:noFill/>
+          <a:ln/>
+        </p:spPr>
+        <p:txBody>
+          <a:bodyPr wrap="square" lIns="0" tIns="0" rIns="0" bIns="0" rtlCol="0" anchor="ctr"/>
+          <a:lstStyle/>
+          <a:p>
+            <a:pPr indent="0" marL="0">
+              <a:buNone/>
+            </a:pPr>
+            <a:r>
+              <a:rPr lang="en-US" sz="850" i="1" dirty="0">
+                <a:solidFill>
+                  <a:srgbClr val="7A8A94"/>
+                </a:solidFill>
+                <a:latin typeface="Arial" pitchFamily="34" charset="0"/>
+                <a:ea typeface="Arial" pitchFamily="34" charset="-122"/>
+                <a:cs typeface="Arial" pitchFamily="34" charset="-120"/>
+              </a:rPr>
+              <a:t>Fontes: CONFAZ (Convênio ICMS nº 16/2015) · SEFAZ-MT · Decreto MT nº 1.971/2026.</a:t>
+            </a:r>
+            <a:endParaRPr lang="en-US" sz="850" dirty="0"/>
+          </a:p>
+        </p:txBody>
+      </p:sp>
+      <p:sp>
+        <p:nvSpPr>
+          <p:cNvPr id="11" name="Text 6"/>
           <p:cNvSpPr/>
           <p:nvPr/>
         </p:nvSpPr>
@@ -9598,7 +9666,7 @@
       </p:sp>
       <p:sp>
         <p:nvSpPr>
-          <p:cNvPr id="11" name="Text 6"/>
+          <p:cNvPr id="12" name="Text 7"/>
           <p:cNvSpPr/>
           <p:nvPr/>
         </p:nvSpPr>
@@ -9739,7 +9807,7 @@
                 <a:ea typeface="Arial" pitchFamily="34" charset="-122"/>
                 <a:cs typeface="Arial" pitchFamily="34" charset="-120"/>
               </a:rPr>
-              <a:t>Cenário agro otimizado: irrigação bombeada no horário reservado do irrigante + crédito do Plano Safra  ·  tarifa B3 (CEMIG-D)  ·  TMA 15% a.a.</a:t>
+              <a:t>Cenário agro otimizado: irrigação bombeada no horário reservado do irrigante + crédito do Plano Safra  ·  tarifa B3 (Energisa-MT)  ·  TMA 15% a.a.</a:t>
             </a:r>
             <a:endParaRPr lang="en-US" sz="1250" dirty="0"/>
           </a:p>

</xml_diff>